<commit_message>
Released fixes and 5 Levels
</commit_message>
<xml_diff>
--- a/Assets/PP_Assets.pptx
+++ b/Assets/PP_Assets.pptx
@@ -4,9 +4,18 @@
   <p:sldMasterIdLst>
     <p:sldMasterId id="2147483648" r:id="rId1"/>
   </p:sldMasterIdLst>
+  <p:notesMasterIdLst>
+    <p:notesMasterId r:id="rId10"/>
+  </p:notesMasterIdLst>
   <p:sldIdLst>
     <p:sldId id="257" r:id="rId2"/>
     <p:sldId id="258" r:id="rId3"/>
+    <p:sldId id="263" r:id="rId4"/>
+    <p:sldId id="259" r:id="rId5"/>
+    <p:sldId id="262" r:id="rId6"/>
+    <p:sldId id="264" r:id="rId7"/>
+    <p:sldId id="260" r:id="rId8"/>
+    <p:sldId id="261" r:id="rId9"/>
   </p:sldIdLst>
   <p:sldSz cx="12192000" cy="6858000"/>
   <p:notesSz cx="6858000" cy="9144000"/>
@@ -105,7 +114,501 @@
       </a:defRPr>
     </a:lvl9pPr>
   </p:defaultTextStyle>
+  <p:extLst>
+    <p:ext uri="{EFAFB233-063F-42B5-8137-9DF3F51BA10A}">
+      <p15:sldGuideLst xmlns:p15="http://schemas.microsoft.com/office/powerpoint/2012/main"/>
+    </p:ext>
+  </p:extLst>
 </p:presentation>
+</file>
+
+<file path=ppt/ink/ink1.xml><?xml version="1.0" encoding="utf-8"?>
+<inkml:ink xmlns:inkml="http://www.w3.org/2003/InkML">
+  <inkml:definitions>
+    <inkml:context xml:id="ctx0">
+      <inkml:inkSource xml:id="inkSrc0">
+        <inkml:traceFormat>
+          <inkml:channel name="X" type="integer" min="-2.14748E9" max="2.14748E9" units="cm"/>
+          <inkml:channel name="Y" type="integer" min="-2.14748E9" max="2.14748E9" units="cm"/>
+          <inkml:channel name="F" type="integer" max="32767" units="dev"/>
+        </inkml:traceFormat>
+        <inkml:channelProperties>
+          <inkml:channelProperty channel="X" name="resolution" value="1000" units="1/cm"/>
+          <inkml:channelProperty channel="Y" name="resolution" value="1000" units="1/cm"/>
+          <inkml:channelProperty channel="F" name="resolution" value="0" units="1/dev"/>
+        </inkml:channelProperties>
+      </inkml:inkSource>
+      <inkml:timestamp xml:id="ts0" timeString="2026-07-15T16:44:51.546"/>
+    </inkml:context>
+    <inkml:brush xml:id="br0">
+      <inkml:brushProperty name="width" value="0.05" units="cm"/>
+      <inkml:brushProperty name="height" value="0.05" units="cm"/>
+      <inkml:brushProperty name="color" value="#3B4B65"/>
+    </inkml:brush>
+  </inkml:definitions>
+  <inkml:trace contextRef="#ctx0" brushRef="#br0">56 66 9830,'1'-2'133,"-1"1"1,1-1-1,0 0 0,0 0 0,0 1 1,0-1-1,0 0 0,1 1 0,-1-1 1,0 1-1,1 0 0,-1-1 0,1 1 1,-1 0-1,1 0 0,0 0 0,0 0 0,1-1 1,-2 2-70,0 0 1,0 0-1,0 0 1,0-1-1,-1 1 1,1 0-1,0 0 1,0 1-1,0-1 1,0 0-1,0 0 1,-1 0-1,1 0 1,0 1-1,0-1 1,0 0-1,-1 1 1,1-1-1,0 1 1,-1-1-1,1 1 1,0-1-1,-1 1 1,1-1-1,0 1 1,-1 0-1,1-1 1,-1 1-1,1 0 1,-1-1-1,0 1 1,1 0-1,-1 0 1,0-1-1,1 1 1,-1 0-1,0 0 1,0 0-1,0 0 1,0-1-1,1 1 1,-2 1-1,6 16 1314,-4-14-1058,1 1 1,-1 0-1,0 0 0,0-1 0,-1 1 1,1 0-1,-1 0 0,0 0 0,-1 0 1,1 0-1,-2 5 0,2-10-283,0 1 1,0-1-1,0 1 0,-1-1 0,1 1 1,0-1-1,0 0 0,-1 1 0,1-1 1,0 1-1,-1-1 0,1 0 0,0 1 0,-1-1 1,1 0-1,0 0 0,-1 1 0,1-1 1,-1 0-1,1 0 0,-1 1 0,1-1 1,-1 0-1,1 0 0,0 0 0,-1 0 1,1 0-1,-1 0 0,1 0 0,-1 0 1,1 0-1,-1 0 0,1 0 0,-1 0 1,1 0-1,-1 0 0,1 0 0,-1 0 1,1-1-1,-1 1 0,1 0 0,0 0 1,-1 0-1,1-1 0,-1 1 0,1 0 1,0-1-1,-1 1 0,1-1 0,-2 0-71,1 0 0,0 0 0,0 0 0,0 0 0,0 0 0,0 0 0,0-1 0,1 1 0,-1 0 0,0-1 0,1 1 0,-1 0 0,1-1 0,-1 1 0,1-3 0,0 2-133,0-1 0,0 0 0,1 0 1,-1 1-1,1-1 0,0 0 0,0 0 1,0 1-1,0-1 0,0 1 0,0-1 1,4-4-1,-4 6 195,0 0 0,0-1 0,1 1 0,-1 0-1,0 0 1,0 0 0,1 0 0,-1 0 0,0 0 0,1 1 0,-1-1 0,1 0 0,0 1 0,-1-1-1,1 1 1,-1-1 0,1 1 0,0 0 0,-1 0 0,1-1 0,0 1 0,-1 0 0,1 0 0,2 1-1,-3 0 33,0-1 0,0 1-1,0 0 1,-1 0-1,1 0 1,0 0-1,0 0 1,0 0-1,-1 0 1,1 0-1,0 0 1,-1 0-1,1 0 1,-1 0-1,0 0 1,1 1-1,-1-1 1,0 0-1,1 0 1,-1 0-1,0 1 1,0-1-1,0 0 1,0 0-1,-1 1 1,1-1-1,0 2 1,-8 35 1449,7-36-1407,0 0-1,0 0 0,-1 0 1,1-1-1,-1 1 0,1-1 1,-1 1-1,0-1 0,0 1 1,0-1-1,0 0 1,0 0-1,0 0 0,0 0 1,-2 1-1,3-2-113,1 0 0,-1 0 0,1 1-1,-1-1 1,0 0 0,1 0 0,-1 0 0,0 1 0,0-1 0,1 0 0,-1 0-1,0 0 1,1 0 0,-1 0 0,0-1 0,1 1 0,-1 0 0,0 0-1,1 0 1,-1-1 0,0 1 0,1 0 0,-1 0 0,1-1 0,-1 1 0,1-1-1,-1 1 1,0 0 0,1-1 0,0 1 0,-1-1 0,1 1 0,-1-1 0,1 1-1,-1-1 1,1 0 0,0 1 0,0-1 0,-1 1 0,1-1 0,0 0-1,0 1 1,0-1 0,-1 0 0,1 1 0,0-1 0,0 0 0,0 1 0,0-1-1,1-1 1,-1-8-825,0 0 0,1 1 0,3-19 0,-3 26 729,-1 0-1,1-1 1,0 1 0,0-1 0,0 1 0,0 0-1,0 0 1,1 0 0,-1 0 0,1 0 0,-1 0-1,1 0 1,0 0 0,-1 0 0,1 1 0,0-1 0,0 1-1,0-1 1,1 1 0,3-2 0,-6 3 124,1-1 0,-1 1 0,0 0 0,0 0 0,0 0 0,1 0 0,-1 0 0,0 0 1,0 0-1,1 0 0,-1 0 0,0 0 0,0 0 0,0 0 0,1 0 0,-1 0 0,0 0 0,0 0 1,0 0-1,1 0 0,-1 0 0,0 1 0,0-1 0,0 0 0,1 0 0,-1 0 0,0 0 0,0 0 0,0 0 1,0 1-1,1-1 0,-1 0 0,0 0 0,0 0 0,0 0 0,0 1 0,0-1 0,0 0 0,0 0 0,0 0 1,1 1-1,-1 12 587,-8 11 414,8-23-964,-1-1-1,1 1 1,-1 0 0,1 0 0,-1 0-1,0-1 1,1 1 0,-1 0 0,0-1-1,0 1 1,1 0 0,-1-1-1,0 1 1,0-1 0,0 1 0,0-1-1,-1 1 1,2-1-59,-1 0 0,1 0-1,0 0 1,-1-1 0,1 1 0,0 0-1,-1 0 1,1 0 0,0 0 0,-1-1-1,1 1 1,0 0 0,-1 0 0,1-1-1,0 1 1,0 0 0,-1 0 0,1-1-1,0 1 1,0 0 0,0-1 0,-1 1-1,1 0 1,0-1 0,0 1 0,0 0-1,0-1 1,0 0 0,-1-1-124,0-1 0,1 1 0,0-1 0,-1 0 1,1 1-1,0-1 0,1 0 0,-1 1 0,0-1 0,1 1 0,0-4 1,0 3 29,0 1-1,1-1 1,-1 1 0,0 0 0,1-1 0,-1 1 0,1 0 0,0 0 0,0 0 0,0 0 0,2-1 0,-4 2 112,1 1-1,-1 0 0,0 0 1,0 0-1,1 0 0,-1 0 1,0-1-1,0 1 1,1 0-1,-1 0 0,0 0 1,0 0-1,1 0 0,-1 0 1,0 0-1,1 0 1,-1 0-1,0 0 0,0 0 1,1 0-1,-1 0 0,0 0 1,1 0-1,-1 1 0,0-1 1,0 0-1,1 0 1,-1 0-1,0 0 0,0 0 1,0 1-1,1-1 0,-1 0 1,0 0-1,1 1 1,-1 0 67,1 0 1,-1 1 0,1-1 0,-1 1 0,1-1 0,-1 1 0,0-1 0,0 1 0,0-1-1,0 1 1,0 1 0,0 8 476,0-1 0,-1 0 0,-1 0-1,1 0 1,-6 16 0,10-31 432,-1 2-1168,0 1-1,0-1 1,0 0-1,0 0 0,-1 0 1,0 0-1,1 0 1,-1 0-1,0 0 1,-1-1-1,2-2 1,-2 4 149,0 1 0,0 0 1,0 0-1,0 0 0,0-1 0,0 1 1,0 0-1,0 0 0,-1 0 1,1-1-1,0 1 0,-1 0 0,1 0 1,-1 0-1,1 0 0,-1 0 0,1 0 1,-1 0-1,0 0 0,0 0 1,0 0-1,1 0 0,-1 0 0,0 1 1,-2-2-1,0 1 168,0 0 0,0 0 0,0 1 0,0-1 1,0 1-1,-1 0 0,1 0 0,-4 1 0,-1-1-70,1 0 203,1 1 0,-1 1 0,1-1 1,-1 1-1,1 0 0,0 0 0,-1 1 1,1 0-1,0 0 0,1 0 0,-11 8 1,16-11-238,-1 1-1,0-1 1,1 1 0,-1-1 0,1 1 0,-1 0-1,0-1 1,1 1 0,0 0 0,-1 0 0,1-1-1,-1 1 1,1 0 0,0 0 0,0 0 0,-1 0-1,1-1 1,0 1 0,0 0 0,0 0 0,0 0-1,0 0 1,0 0 0,0-1 0,0 1 0,1 0-1,-1 0 1,0 0 0,1 1 0,0-1 38,0 0 0,0 1 0,1-1 0,-1 0 0,1 0 0,-1 0 0,1 0 0,-1 0 0,1-1 0,-1 1 1,1 0-1,0-1 0,2 2 0,6 0 222,0 0 1,0-1 0,19 1-1,-27-3-405,1 1-1,-1-1 1,1 0 0,-1 0-1,1 0 1,-1 0-1,0-1 1,0 1-1,0-1 1,1 1 0,-1-1-1,-1 0 1,1 0-1,0 0 1,0 0-1,-1 0 1,1 0-1,-1 0 1,0 0 0,1 0-1,-1-1 1,0 1-1,-1-1 1,1 1-1,0-1 1,-1 1 0,1-1-1,-1 1 1,0-1-1,0 1 1,0-1-1,0 0 1,-1-2 0,1 4 119,0 1 0,0 0 1,0-1-1,-1 1 0,1-1 1,0 1-1,0 0 0,-1-1 0,1 1 1,0 0-1,-1-1 0,1 1 1,0 0-1,-1 0 0,1-1 1,-1 1-1,1 0 0,0 0 1,-1 0-1,1-1 0,-1 1 1,1 0-1,0 0 0,-1 0 1,1 0-1,-1 0 0,1 0 1,-1 0-1,1 0 0,-1 0 1,1 0-1,-1 0 0,1 0 1,0 0-1,-1 0 0,1 1 1,-1-1-1,1 0 0,-1 0 1,1 0-1,0 1 0,-1-1 1,1 0-1,0 0 0,-1 1 1,1-1-1,0 0 0,-1 1 1,1-1-1,0 0 0,0 1 1,-1-1-1,1 1 0,-2 1 32,1-1-1,0 1 0,-1-1 0,1 1 1,0 0-1,0 0 0,0 0 0,0 0 1,0 0-1,0 2 0,-1 52 813,2-53-796,1 1-1,-1-1 0,0 1 1,1-1-1,0 0 1,0 1-1,0-1 0,0 0 1,0 0-1,1 1 0,0-1 1,-1 0-1,5 4 1,-6-6-47,1 0 1,0-1-1,-1 0 1,1 1-1,-1-1 1,1 1 0,0-1-1,0 0 1,-1 1-1,1-1 1,0 0-1,-1 1 1,1-1 0,0 0-1,0 0 1,0 0-1,-1 0 1,1 0-1,0 0 1,0 0 0,-1 0-1,1 0 1,0 0-1,0 0 1,-1-1-1,2 1 1,0-1-89,-1 0 0,1 0-1,-1 0 1,1 0 0,-1 0 0,1-1 0,-1 1-1,0 0 1,1-1 0,1-2 0,-1 1-201,0-1-1,0 1 1,0-1 0,0 0 0,-1 1 0,1-1 0,-1 0 0,0 0 0,1-6-1,-10-39-3091,1 19 1244,7 28 2058,0 0-1,0 0 1,-1-1-1,1 1 1,-1 0-1,0 0 0,0 0 1,0 0-1,0 0 1,0 0-1,0 0 1,0 1-1,0-1 1,-1 0-1,1 1 0,-1-1 1,0 1-1,1-1 1,-1 1-1,0 0 1,0-1-1,0 1 1,0 0-1,-2-1 0,-3 0 465,0 1-1,0 0 0,0 0 1,0 0-1,0 1 0,-8 0 0,10 0-225,-14-1 732,13 1-548,0-1 0,0 1 1,0 0-1,0 1 0,-10 1 1,63 2 2439,-28-5-1951,-16 0-732,-1 1 0,0-1 1,0 1-1,0 0 0,1 0 0,-1 0 0,0 1 1,0-1-1,0 0 0,1 1 0,-1-1 0,0 1 0,0 0 1,0 0-1,0 0 0,0 0 0,0 0 0,0 0 0,-1 0 1,1 0-1,0 1 0,-1-1 0,3 3 0,-2-2-108,0 1 0,0 0 0,0 0 0,0 1 0,0-1 0,-1 0 0,1 0 0,-1 1 0,0-1 0,0 1 0,0-1 0,-1 1 0,1 5 0,-2 49 0,0-57 0,1 0 0,-1-1 0,0 1 0,1 0 0,-1 0 0,0-1 0,0 1 0,0 0 0,0-1 0,1 1 0,-1-1 0,0 1 0,0-1 0,0 1 0,0-1 0,0 0 0,0 1 0,0-1 0,0 0 0,-1 0 0,1 0 0,0 0 0,0 0 0,0 0 0,0 0 0,0 0 0,-2 0 0,-32-4 0,32 3-63,0 0 0,1 1 0,-1-1 0,0 0 0,1 0 0,-1 0 0,1-1 0,0 1-1,-1-1 1,1 1 0,0-1 0,0 0 0,0 0 0,0 0 0,0 0 0,1 0 0,-1 0 0,1 0 0,-1 0-1,-1-5 1,2 5-47,1 0-1,0 0 0,0 1 0,0-1 1,0 0-1,0 1 0,0-1 0,0 0 1,1 0-1,-1 1 0,1-1 0,-1 0 1,1 1-1,0-1 0,0 1 0,-1-1 1,1 1-1,0-1 0,0 1 0,1 0 1,-1-1-1,0 1 0,0 0 0,1 0 1,-1 0-1,0 0 0,1 0 0,-1 0 1,1 0-1,0 0 0,-1 1 0,1-1 1,2 0-1,-2 0 176,0 0 0,1 0-1,-1 0 1,1 0 0,-1 0 0,1 1 0,0-1 0,-1 1 0,1 0-1,2-1 1,-4 1-51,-1 0 0,1 1 0,-1-1-1,0 0 1,1 0 0,-1 0-1,0 0 1,1 0 0,-1 1 0,1-1-1,-1 0 1,0 0 0,0 1 0,1-1-1,-1 0 1,0 0 0,1 1 0,-1-1-1,0 0 1,0 1 0,0-1 0,1 0-1,-1 1 1,0-1 0,0 0 0,0 1-1,-3 18 394,-6-2-43,6-13-350</inkml:trace>
+</inkml:ink>
+</file>
+
+<file path=ppt/ink/ink2.xml><?xml version="1.0" encoding="utf-8"?>
+<inkml:ink xmlns:inkml="http://www.w3.org/2003/InkML">
+  <inkml:definitions>
+    <inkml:context xml:id="ctx0">
+      <inkml:inkSource xml:id="inkSrc0">
+        <inkml:traceFormat>
+          <inkml:channel name="X" type="integer" min="-2.14748E9" max="2.14748E9" units="cm"/>
+          <inkml:channel name="Y" type="integer" min="-2.14748E9" max="2.14748E9" units="cm"/>
+          <inkml:channel name="F" type="integer" max="32767" units="dev"/>
+        </inkml:traceFormat>
+        <inkml:channelProperties>
+          <inkml:channelProperty channel="X" name="resolution" value="1000" units="1/cm"/>
+          <inkml:channelProperty channel="Y" name="resolution" value="1000" units="1/cm"/>
+          <inkml:channelProperty channel="F" name="resolution" value="0" units="1/dev"/>
+        </inkml:channelProperties>
+      </inkml:inkSource>
+      <inkml:timestamp xml:id="ts0" timeString="2026-07-15T17:44:35.482"/>
+    </inkml:context>
+    <inkml:brush xml:id="br0">
+      <inkml:brushProperty name="width" value="0.05" units="cm"/>
+      <inkml:brushProperty name="height" value="0.05" units="cm"/>
+      <inkml:brushProperty name="color" value="#3B4B65"/>
+    </inkml:brush>
+  </inkml:definitions>
+  <inkml:trace contextRef="#ctx0" brushRef="#br0">56 66 9830,'1'-2'133,"-1"1"1,1-1-1,0 0 0,0 0 0,0 1 1,0-1-1,0 0 0,1 1 0,-1-1 1,0 1-1,1 0 0,-1-1 0,1 1 1,-1 0-1,1 0 0,0 0 0,0 0 0,1-1 1,-2 2-70,0 0 1,0 0-1,0 0 1,0-1-1,-1 1 1,1 0-1,0 0 1,0 1-1,0-1 1,0 0-1,0 0 1,-1 0-1,1 0 1,0 1-1,0-1 1,0 0-1,-1 1 1,1-1-1,0 1 1,-1-1-1,1 1 1,0-1-1,-1 1 1,1-1-1,0 1 1,-1 0-1,1-1 1,-1 1-1,1 0 1,-1-1-1,0 1 1,1 0-1,-1 0 1,0-1-1,1 1 1,-1 0-1,0 0 1,0 0-1,0 0 1,0-1-1,1 1 1,-2 1-1,6 16 1314,-4-14-1058,1 1 1,-1 0-1,0 0 0,0-1 0,-1 1 1,1 0-1,-1 0 0,0 0 0,-1 0 1,1 0-1,-2 5 0,2-10-283,0 1 1,0-1-1,0 1 0,-1-1 0,1 1 1,0-1-1,0 0 0,-1 1 0,1-1 1,0 1-1,-1-1 0,1 0 0,0 1 0,-1-1 1,1 0-1,0 0 0,-1 1 0,1-1 1,-1 0-1,1 0 0,-1 1 0,1-1 1,-1 0-1,1 0 0,0 0 0,-1 0 1,1 0-1,-1 0 0,1 0 0,-1 0 1,1 0-1,-1 0 0,1 0 0,-1 0 1,1 0-1,-1 0 0,1 0 0,-1 0 1,1-1-1,-1 1 0,1 0 0,0 0 1,-1 0-1,1-1 0,-1 1 0,1 0 1,0-1-1,-1 1 0,1-1 0,-2 0-71,1 0 0,0 0 0,0 0 0,0 0 0,0 0 0,0 0 0,0-1 0,1 1 0,-1 0 0,0-1 0,1 1 0,-1 0 0,1-1 0,-1 1 0,1-3 0,0 2-133,0-1 0,0 0 0,1 0 1,-1 1-1,1-1 0,0 0 0,0 0 1,0 1-1,0-1 0,0 1 0,0-1 1,4-4-1,-4 6 195,0 0 0,0-1 0,1 1 0,-1 0-1,0 0 1,0 0 0,1 0 0,-1 0 0,0 0 0,1 1 0,-1-1 0,1 0 0,0 1 0,-1-1-1,1 1 1,-1-1 0,1 1 0,0 0 0,-1 0 0,1-1 0,0 1 0,-1 0 0,1 0 0,2 1-1,-3 0 33,0-1 0,0 1-1,0 0 1,-1 0-1,1 0 1,0 0-1,0 0 1,0 0-1,-1 0 1,1 0-1,0 0 1,-1 0-1,1 0 1,-1 0-1,0 0 1,1 1-1,-1-1 1,0 0-1,1 0 1,-1 0-1,0 1 1,0-1-1,0 0 1,0 0-1,-1 1 1,1-1-1,0 2 1,-8 35 1449,7-36-1407,0 0-1,0 0 0,-1 0 1,1-1-1,-1 1 0,1-1 1,-1 1-1,0-1 0,0 1 1,0-1-1,0 0 1,0 0-1,0 0 0,0 0 1,-2 1-1,3-2-113,1 0 0,-1 0 0,1 1-1,-1-1 1,0 0 0,1 0 0,-1 0 0,0 1 0,0-1 0,1 0 0,-1 0-1,0 0 1,1 0 0,-1 0 0,0-1 0,1 1 0,-1 0 0,0 0-1,1 0 1,-1-1 0,0 1 0,1 0 0,-1 0 0,1-1 0,-1 1 0,1-1-1,-1 1 1,0 0 0,1-1 0,0 1 0,-1-1 0,1 1 0,-1-1 0,1 1-1,-1-1 1,1 0 0,0 1 0,0-1 0,-1 1 0,1-1 0,0 0-1,0 1 1,0-1 0,-1 0 0,1 1 0,0-1 0,0 0 0,0 1 0,0-1-1,1-1 1,-1-8-825,0 0 0,1 1 0,3-19 0,-3 26 729,-1 0-1,1-1 1,0 1 0,0-1 0,0 1 0,0 0-1,0 0 1,1 0 0,-1 0 0,1 0 0,-1 0-1,1 0 1,0 0 0,-1 0 0,1 1 0,0-1 0,0 1-1,0-1 1,1 1 0,3-2 0,-6 3 124,1-1 0,-1 1 0,0 0 0,0 0 0,0 0 0,1 0 0,-1 0 0,0 0 1,0 0-1,1 0 0,-1 0 0,0 0 0,0 0 0,0 0 0,1 0 0,-1 0 0,0 0 0,0 0 1,0 0-1,1 0 0,-1 0 0,0 1 0,0-1 0,0 0 0,1 0 0,-1 0 0,0 0 0,0 0 0,0 0 1,0 1-1,1-1 0,-1 0 0,0 0 0,0 0 0,0 0 0,0 1 0,0-1 0,0 0 0,0 0 0,0 0 1,1 1-1,-1 12 587,-8 11 414,8-23-964,-1-1-1,1 1 1,-1 0 0,1 0 0,-1 0-1,0-1 1,1 1 0,-1 0 0,0-1-1,0 1 1,1 0 0,-1-1-1,0 1 1,0-1 0,0 1 0,0-1-1,-1 1 1,2-1-59,-1 0 0,1 0-1,0 0 1,-1-1 0,1 1 0,0 0-1,-1 0 1,1 0 0,0 0 0,-1-1-1,1 1 1,0 0 0,-1 0 0,1-1-1,0 1 1,0 0 0,-1 0 0,1-1-1,0 1 1,0 0 0,0-1 0,-1 1-1,1 0 1,0-1 0,0 1 0,0 0-1,0-1 1,0 0 0,-1-1-124,0-1 0,1 1 0,0-1 0,-1 0 1,1 1-1,0-1 0,1 0 0,-1 1 0,0-1 0,1 1 0,0-4 1,0 3 29,0 1-1,1-1 1,-1 1 0,0 0 0,1-1 0,-1 1 0,1 0 0,0 0 0,0 0 0,0 0 0,2-1 0,-4 2 112,1 1-1,-1 0 0,0 0 1,0 0-1,1 0 0,-1 0 1,0-1-1,0 1 1,1 0-1,-1 0 0,0 0 1,0 0-1,1 0 0,-1 0 1,0 0-1,1 0 1,-1 0-1,0 0 0,0 0 1,1 0-1,-1 0 0,0 0 1,1 0-1,-1 1 0,0-1 1,0 0-1,1 0 1,-1 0-1,0 0 0,0 0 1,0 1-1,1-1 0,-1 0 1,0 0-1,1 1 1,-1 0 67,1 0 1,-1 1 0,1-1 0,-1 1 0,1-1 0,-1 1 0,0-1 0,0 1 0,0-1-1,0 1 1,0 1 0,0 8 476,0-1 0,-1 0 0,-1 0-1,1 0 1,-6 16 0,10-31 432,-1 2-1168,0 1-1,0-1 1,0 0-1,0 0 0,-1 0 1,0 0-1,1 0 1,-1 0-1,0 0 1,-1-1-1,2-2 1,-2 4 149,0 1 0,0 0 1,0 0-1,0 0 0,0-1 0,0 1 1,0 0-1,0 0 0,-1 0 1,1-1-1,0 1 0,-1 0 0,1 0 1,-1 0-1,1 0 0,-1 0 0,1 0 1,-1 0-1,0 0 0,0 0 1,0 0-1,1 0 0,-1 0 0,0 1 1,-2-2-1,0 1 168,0 0 0,0 0 0,0 1 0,0-1 1,0 1-1,-1 0 0,1 0 0,-4 1 0,-1-1-70,1 0 203,1 1 0,-1 1 0,1-1 1,-1 1-1,1 0 0,0 0 0,-1 1 1,1 0-1,0 0 0,1 0 0,-11 8 1,16-11-238,-1 1-1,0-1 1,1 1 0,-1-1 0,1 1 0,-1 0-1,0-1 1,1 1 0,0 0 0,-1 0 0,1-1-1,-1 1 1,1 0 0,0 0 0,0 0 0,-1 0-1,1-1 1,0 1 0,0 0 0,0 0 0,0 0-1,0 0 1,0 0 0,0-1 0,0 1 0,1 0-1,-1 0 1,0 0 0,1 1 0,0-1 38,0 0 0,0 1 0,1-1 0,-1 0 0,1 0 0,-1 0 0,1 0 0,-1 0 0,1-1 0,-1 1 1,1 0-1,0-1 0,2 2 0,6 0 222,0 0 1,0-1 0,19 1-1,-27-3-405,1 1-1,-1-1 1,1 0 0,-1 0-1,1 0 1,-1 0-1,0-1 1,0 1-1,0-1 1,1 1 0,-1-1-1,-1 0 1,1 0-1,0 0 1,0 0-1,-1 0 1,1 0-1,-1 0 1,0 0 0,1 0-1,-1-1 1,0 1-1,-1-1 1,1 1-1,0-1 1,-1 1 0,1-1-1,-1 1 1,0-1-1,0 1 1,0-1-1,0 0 1,-1-2 0,1 4 119,0 1 0,0 0 1,0-1-1,-1 1 0,1-1 1,0 1-1,0 0 0,-1-1 0,1 1 1,0 0-1,-1-1 0,1 1 1,0 0-1,-1 0 0,1-1 1,-1 1-1,1 0 0,0 0 1,-1 0-1,1-1 0,-1 1 1,1 0-1,0 0 0,-1 0 1,1 0-1,-1 0 0,1 0 1,-1 0-1,1 0 0,-1 0 1,1 0-1,-1 0 0,1 0 1,0 0-1,-1 0 0,1 1 1,-1-1-1,1 0 0,-1 0 1,1 0-1,0 1 0,-1-1 1,1 0-1,0 0 0,-1 1 1,1-1-1,0 0 0,-1 1 1,1-1-1,0 0 0,0 1 1,-1-1-1,1 1 0,-2 1 32,1-1-1,0 1 0,-1-1 0,1 1 1,0 0-1,0 0 0,0 0 0,0 0 1,0 0-1,0 2 0,-1 52 813,2-53-796,1 1-1,-1-1 0,0 1 1,1-1-1,0 0 1,0 1-1,0-1 0,0 0 1,0 0-1,1 1 0,0-1 1,-1 0-1,5 4 1,-6-6-47,1 0 1,0-1-1,-1 0 1,1 1-1,-1-1 1,1 1 0,0-1-1,0 0 1,-1 1-1,1-1 1,0 0-1,-1 1 1,1-1 0,0 0-1,0 0 1,0 0-1,-1 0 1,1 0-1,0 0 1,0 0 0,-1 0-1,1 0 1,0 0-1,0 0 1,-1-1-1,2 1 1,0-1-89,-1 0 0,1 0-1,-1 0 1,1 0 0,-1 0 0,1-1 0,-1 1-1,0 0 1,1-1 0,1-2 0,-1 1-201,0-1-1,0 1 1,0-1 0,0 0 0,-1 1 0,1-1 0,-1 0 0,0 0 0,1-6-1,-10-39-3091,1 19 1244,7 28 2058,0 0-1,0 0 1,-1-1-1,1 1 1,-1 0-1,0 0 0,0 0 1,0 0-1,0 0 1,0 0-1,0 0 1,0 1-1,0-1 1,-1 0-1,1 1 0,-1-1 1,0 1-1,1-1 1,-1 1-1,0 0 1,0-1-1,0 1 1,0 0-1,-2-1 0,-3 0 465,0 1-1,0 0 0,0 0 1,0 0-1,0 1 0,-8 0 0,10 0-225,-14-1 732,13 1-548,0-1 0,0 1 1,0 0-1,0 1 0,-10 1 1,63 2 2439,-28-5-1951,-16 0-732,-1 1 0,0-1 1,0 1-1,0 0 0,1 0 0,-1 0 0,0 1 1,0-1-1,0 0 0,1 1 0,-1-1 0,0 1 0,0 0 1,0 0-1,0 0 0,0 0 0,0 0 0,0 0 0,-1 0 1,1 0-1,0 1 0,-1-1 0,3 3 0,-2-2-108,0 1 0,0 0 0,0 0 0,0 1 0,0-1 0,-1 0 0,1 0 0,-1 1 0,0-1 0,0 1 0,0-1 0,-1 1 0,1 5 0,-2 49 0,0-57 0,1 0 0,-1-1 0,0 1 0,1 0 0,-1 0 0,0-1 0,0 1 0,0 0 0,0-1 0,1 1 0,-1-1 0,0 1 0,0-1 0,0 1 0,0-1 0,0 0 0,0 1 0,0-1 0,0 0 0,-1 0 0,1 0 0,0 0 0,0 0 0,0 0 0,0 0 0,0 0 0,-2 0 0,-32-4 0,32 3-63,0 0 0,1 1 0,-1-1 0,0 0 0,1 0 0,-1 0 0,1-1 0,0 1-1,-1-1 1,1 1 0,0-1 0,0 0 0,0 0 0,0 0 0,0 0 0,1 0 0,-1 0 0,1 0 0,-1 0-1,-1-5 1,2 5-47,1 0-1,0 0 0,0 1 0,0-1 1,0 0-1,0 1 0,0-1 0,0 0 1,1 0-1,-1 1 0,1-1 0,-1 0 1,1 1-1,0-1 0,0 1 0,-1-1 1,1 1-1,0-1 0,0 1 0,1 0 1,-1-1-1,0 1 0,0 0 0,1 0 1,-1 0-1,0 0 0,1 0 0,-1 0 1,1 0-1,0 0 0,-1 1 0,1-1 1,2 0-1,-2 0 176,0 0 0,1 0-1,-1 0 1,1 0 0,-1 0 0,1 1 0,0-1 0,-1 1 0,1 0-1,2-1 1,-4 1-51,-1 0 0,1 1 0,-1-1-1,0 0 1,1 0 0,-1 0-1,0 0 1,1 0 0,-1 1 0,1-1-1,-1 0 1,0 0 0,0 1 0,1-1-1,-1 0 1,0 0 0,1 1 0,-1-1-1,0 0 1,0 1 0,0-1 0,1 0-1,-1 1 1,0-1 0,0 0 0,0 1-1,-3 18 394,-6-2-43,6-13-350</inkml:trace>
+</inkml:ink>
+</file>
+
+<file path=ppt/notesMasters/notesMaster1.xml><?xml version="1.0" encoding="utf-8"?>
+<p:notesMaster xmlns:a="http://schemas.openxmlformats.org/drawingml/2006/main" xmlns:r="http://schemas.openxmlformats.org/officeDocument/2006/relationships" xmlns:p="http://schemas.openxmlformats.org/presentationml/2006/main">
+  <p:cSld>
+    <p:bg>
+      <p:bgRef idx="1001">
+        <a:schemeClr val="bg1"/>
+      </p:bgRef>
+    </p:bg>
+    <p:spTree>
+      <p:nvGrpSpPr>
+        <p:cNvPr id="1" name=""/>
+        <p:cNvGrpSpPr/>
+        <p:nvPr/>
+      </p:nvGrpSpPr>
+      <p:grpSpPr>
+        <a:xfrm>
+          <a:off x="0" y="0"/>
+          <a:ext cx="0" cy="0"/>
+          <a:chOff x="0" y="0"/>
+          <a:chExt cx="0" cy="0"/>
+        </a:xfrm>
+      </p:grpSpPr>
+      <p:sp>
+        <p:nvSpPr>
+          <p:cNvPr id="2" name="Header Placeholder 1"/>
+          <p:cNvSpPr>
+            <a:spLocks noGrp="1"/>
+          </p:cNvSpPr>
+          <p:nvPr>
+            <p:ph type="hdr" sz="quarter"/>
+          </p:nvPr>
+        </p:nvSpPr>
+        <p:spPr>
+          <a:xfrm>
+            <a:off x="0" y="0"/>
+            <a:ext cx="2971800" cy="458788"/>
+          </a:xfrm>
+          <a:prstGeom prst="rect">
+            <a:avLst/>
+          </a:prstGeom>
+        </p:spPr>
+        <p:txBody>
+          <a:bodyPr vert="horz" lIns="91440" tIns="45720" rIns="91440" bIns="45720" rtlCol="0"/>
+          <a:lstStyle>
+            <a:lvl1pPr algn="l">
+              <a:defRPr sz="1200"/>
+            </a:lvl1pPr>
+          </a:lstStyle>
+          <a:p>
+            <a:endParaRPr lang="en-US"/>
+          </a:p>
+        </p:txBody>
+      </p:sp>
+      <p:sp>
+        <p:nvSpPr>
+          <p:cNvPr id="3" name="Date Placeholder 2"/>
+          <p:cNvSpPr>
+            <a:spLocks noGrp="1"/>
+          </p:cNvSpPr>
+          <p:nvPr>
+            <p:ph type="dt" idx="1"/>
+          </p:nvPr>
+        </p:nvSpPr>
+        <p:spPr>
+          <a:xfrm>
+            <a:off x="3884613" y="0"/>
+            <a:ext cx="2971800" cy="458788"/>
+          </a:xfrm>
+          <a:prstGeom prst="rect">
+            <a:avLst/>
+          </a:prstGeom>
+        </p:spPr>
+        <p:txBody>
+          <a:bodyPr vert="horz" lIns="91440" tIns="45720" rIns="91440" bIns="45720" rtlCol="0"/>
+          <a:lstStyle>
+            <a:lvl1pPr algn="r">
+              <a:defRPr sz="1200"/>
+            </a:lvl1pPr>
+          </a:lstStyle>
+          <a:p>
+            <a:fld id="{09A0FCDF-2E5E-4109-B286-A85B4737C97B}" type="datetimeFigureOut">
+              <a:rPr lang="en-US" smtClean="0"/>
+              <a:t>7/15/2026</a:t>
+            </a:fld>
+            <a:endParaRPr lang="en-US"/>
+          </a:p>
+        </p:txBody>
+      </p:sp>
+      <p:sp>
+        <p:nvSpPr>
+          <p:cNvPr id="4" name="Slide Image Placeholder 3"/>
+          <p:cNvSpPr>
+            <a:spLocks noGrp="1" noRot="1" noChangeAspect="1"/>
+          </p:cNvSpPr>
+          <p:nvPr>
+            <p:ph type="sldImg" idx="2"/>
+          </p:nvPr>
+        </p:nvSpPr>
+        <p:spPr>
+          <a:xfrm>
+            <a:off x="685800" y="1143000"/>
+            <a:ext cx="5486400" cy="3086100"/>
+          </a:xfrm>
+          <a:prstGeom prst="rect">
+            <a:avLst/>
+          </a:prstGeom>
+          <a:noFill/>
+          <a:ln w="12700">
+            <a:solidFill>
+              <a:prstClr val="black"/>
+            </a:solidFill>
+          </a:ln>
+        </p:spPr>
+        <p:txBody>
+          <a:bodyPr vert="horz" lIns="91440" tIns="45720" rIns="91440" bIns="45720" rtlCol="0" anchor="ctr"/>
+          <a:lstStyle/>
+          <a:p>
+            <a:endParaRPr lang="en-US"/>
+          </a:p>
+        </p:txBody>
+      </p:sp>
+      <p:sp>
+        <p:nvSpPr>
+          <p:cNvPr id="5" name="Notes Placeholder 4"/>
+          <p:cNvSpPr>
+            <a:spLocks noGrp="1"/>
+          </p:cNvSpPr>
+          <p:nvPr>
+            <p:ph type="body" sz="quarter" idx="3"/>
+          </p:nvPr>
+        </p:nvSpPr>
+        <p:spPr>
+          <a:xfrm>
+            <a:off x="685800" y="4400550"/>
+            <a:ext cx="5486400" cy="3600450"/>
+          </a:xfrm>
+          <a:prstGeom prst="rect">
+            <a:avLst/>
+          </a:prstGeom>
+        </p:spPr>
+        <p:txBody>
+          <a:bodyPr vert="horz" lIns="91440" tIns="45720" rIns="91440" bIns="45720" rtlCol="0"/>
+          <a:lstStyle/>
+          <a:p>
+            <a:pPr lvl="0"/>
+            <a:r>
+              <a:rPr lang="en-US"/>
+              <a:t>Click to edit Master text styles</a:t>
+            </a:r>
+          </a:p>
+          <a:p>
+            <a:pPr lvl="1"/>
+            <a:r>
+              <a:rPr lang="en-US"/>
+              <a:t>Second level</a:t>
+            </a:r>
+          </a:p>
+          <a:p>
+            <a:pPr lvl="2"/>
+            <a:r>
+              <a:rPr lang="en-US"/>
+              <a:t>Third level</a:t>
+            </a:r>
+          </a:p>
+          <a:p>
+            <a:pPr lvl="3"/>
+            <a:r>
+              <a:rPr lang="en-US"/>
+              <a:t>Fourth level</a:t>
+            </a:r>
+          </a:p>
+          <a:p>
+            <a:pPr lvl="4"/>
+            <a:r>
+              <a:rPr lang="en-US"/>
+              <a:t>Fifth level</a:t>
+            </a:r>
+          </a:p>
+        </p:txBody>
+      </p:sp>
+      <p:sp>
+        <p:nvSpPr>
+          <p:cNvPr id="6" name="Footer Placeholder 5"/>
+          <p:cNvSpPr>
+            <a:spLocks noGrp="1"/>
+          </p:cNvSpPr>
+          <p:nvPr>
+            <p:ph type="ftr" sz="quarter" idx="4"/>
+          </p:nvPr>
+        </p:nvSpPr>
+        <p:spPr>
+          <a:xfrm>
+            <a:off x="0" y="8685213"/>
+            <a:ext cx="2971800" cy="458787"/>
+          </a:xfrm>
+          <a:prstGeom prst="rect">
+            <a:avLst/>
+          </a:prstGeom>
+        </p:spPr>
+        <p:txBody>
+          <a:bodyPr vert="horz" lIns="91440" tIns="45720" rIns="91440" bIns="45720" rtlCol="0" anchor="b"/>
+          <a:lstStyle>
+            <a:lvl1pPr algn="l">
+              <a:defRPr sz="1200"/>
+            </a:lvl1pPr>
+          </a:lstStyle>
+          <a:p>
+            <a:endParaRPr lang="en-US"/>
+          </a:p>
+        </p:txBody>
+      </p:sp>
+      <p:sp>
+        <p:nvSpPr>
+          <p:cNvPr id="7" name="Slide Number Placeholder 6"/>
+          <p:cNvSpPr>
+            <a:spLocks noGrp="1"/>
+          </p:cNvSpPr>
+          <p:nvPr>
+            <p:ph type="sldNum" sz="quarter" idx="5"/>
+          </p:nvPr>
+        </p:nvSpPr>
+        <p:spPr>
+          <a:xfrm>
+            <a:off x="3884613" y="8685213"/>
+            <a:ext cx="2971800" cy="458787"/>
+          </a:xfrm>
+          <a:prstGeom prst="rect">
+            <a:avLst/>
+          </a:prstGeom>
+        </p:spPr>
+        <p:txBody>
+          <a:bodyPr vert="horz" lIns="91440" tIns="45720" rIns="91440" bIns="45720" rtlCol="0" anchor="b"/>
+          <a:lstStyle>
+            <a:lvl1pPr algn="r">
+              <a:defRPr sz="1200"/>
+            </a:lvl1pPr>
+          </a:lstStyle>
+          <a:p>
+            <a:fld id="{56D03EF2-D82D-4AC0-BEDE-36536519F695}" type="slidenum">
+              <a:rPr lang="en-US" smtClean="0"/>
+              <a:t>‹#›</a:t>
+            </a:fld>
+            <a:endParaRPr lang="en-US"/>
+          </a:p>
+        </p:txBody>
+      </p:sp>
+    </p:spTree>
+    <p:extLst>
+      <p:ext uri="{BB962C8B-B14F-4D97-AF65-F5344CB8AC3E}">
+        <p14:creationId xmlns:p14="http://schemas.microsoft.com/office/powerpoint/2010/main" val="4097839144"/>
+      </p:ext>
+    </p:extLst>
+  </p:cSld>
+  <p:clrMap bg1="lt1" tx1="dk1" bg2="lt2" tx2="dk2" accent1="accent1" accent2="accent2" accent3="accent3" accent4="accent4" accent5="accent5" accent6="accent6" hlink="hlink" folHlink="folHlink"/>
+  <p:notesStyle>
+    <a:lvl1pPr marL="0" algn="l" defTabSz="914400" rtl="0" eaLnBrk="1" latinLnBrk="0" hangingPunct="1">
+      <a:defRPr sz="1200" kern="1200">
+        <a:solidFill>
+          <a:schemeClr val="tx1"/>
+        </a:solidFill>
+        <a:latin typeface="+mn-lt"/>
+        <a:ea typeface="+mn-ea"/>
+        <a:cs typeface="+mn-cs"/>
+      </a:defRPr>
+    </a:lvl1pPr>
+    <a:lvl2pPr marL="457200" algn="l" defTabSz="914400" rtl="0" eaLnBrk="1" latinLnBrk="0" hangingPunct="1">
+      <a:defRPr sz="1200" kern="1200">
+        <a:solidFill>
+          <a:schemeClr val="tx1"/>
+        </a:solidFill>
+        <a:latin typeface="+mn-lt"/>
+        <a:ea typeface="+mn-ea"/>
+        <a:cs typeface="+mn-cs"/>
+      </a:defRPr>
+    </a:lvl2pPr>
+    <a:lvl3pPr marL="914400" algn="l" defTabSz="914400" rtl="0" eaLnBrk="1" latinLnBrk="0" hangingPunct="1">
+      <a:defRPr sz="1200" kern="1200">
+        <a:solidFill>
+          <a:schemeClr val="tx1"/>
+        </a:solidFill>
+        <a:latin typeface="+mn-lt"/>
+        <a:ea typeface="+mn-ea"/>
+        <a:cs typeface="+mn-cs"/>
+      </a:defRPr>
+    </a:lvl3pPr>
+    <a:lvl4pPr marL="1371600" algn="l" defTabSz="914400" rtl="0" eaLnBrk="1" latinLnBrk="0" hangingPunct="1">
+      <a:defRPr sz="1200" kern="1200">
+        <a:solidFill>
+          <a:schemeClr val="tx1"/>
+        </a:solidFill>
+        <a:latin typeface="+mn-lt"/>
+        <a:ea typeface="+mn-ea"/>
+        <a:cs typeface="+mn-cs"/>
+      </a:defRPr>
+    </a:lvl4pPr>
+    <a:lvl5pPr marL="1828800" algn="l" defTabSz="914400" rtl="0" eaLnBrk="1" latinLnBrk="0" hangingPunct="1">
+      <a:defRPr sz="1200" kern="1200">
+        <a:solidFill>
+          <a:schemeClr val="tx1"/>
+        </a:solidFill>
+        <a:latin typeface="+mn-lt"/>
+        <a:ea typeface="+mn-ea"/>
+        <a:cs typeface="+mn-cs"/>
+      </a:defRPr>
+    </a:lvl5pPr>
+    <a:lvl6pPr marL="2286000" algn="l" defTabSz="914400" rtl="0" eaLnBrk="1" latinLnBrk="0" hangingPunct="1">
+      <a:defRPr sz="1200" kern="1200">
+        <a:solidFill>
+          <a:schemeClr val="tx1"/>
+        </a:solidFill>
+        <a:latin typeface="+mn-lt"/>
+        <a:ea typeface="+mn-ea"/>
+        <a:cs typeface="+mn-cs"/>
+      </a:defRPr>
+    </a:lvl6pPr>
+    <a:lvl7pPr marL="2743200" algn="l" defTabSz="914400" rtl="0" eaLnBrk="1" latinLnBrk="0" hangingPunct="1">
+      <a:defRPr sz="1200" kern="1200">
+        <a:solidFill>
+          <a:schemeClr val="tx1"/>
+        </a:solidFill>
+        <a:latin typeface="+mn-lt"/>
+        <a:ea typeface="+mn-ea"/>
+        <a:cs typeface="+mn-cs"/>
+      </a:defRPr>
+    </a:lvl7pPr>
+    <a:lvl8pPr marL="3200400" algn="l" defTabSz="914400" rtl="0" eaLnBrk="1" latinLnBrk="0" hangingPunct="1">
+      <a:defRPr sz="1200" kern="1200">
+        <a:solidFill>
+          <a:schemeClr val="tx1"/>
+        </a:solidFill>
+        <a:latin typeface="+mn-lt"/>
+        <a:ea typeface="+mn-ea"/>
+        <a:cs typeface="+mn-cs"/>
+      </a:defRPr>
+    </a:lvl8pPr>
+    <a:lvl9pPr marL="3657600" algn="l" defTabSz="914400" rtl="0" eaLnBrk="1" latinLnBrk="0" hangingPunct="1">
+      <a:defRPr sz="1200" kern="1200">
+        <a:solidFill>
+          <a:schemeClr val="tx1"/>
+        </a:solidFill>
+        <a:latin typeface="+mn-lt"/>
+        <a:ea typeface="+mn-ea"/>
+        <a:cs typeface="+mn-cs"/>
+      </a:defRPr>
+    </a:lvl9pPr>
+  </p:notesStyle>
+</p:notesMaster>
+</file>
+
+<file path=ppt/notesSlides/notesSlide1.xml><?xml version="1.0" encoding="utf-8"?>
+<p:notes xmlns:a="http://schemas.openxmlformats.org/drawingml/2006/main" xmlns:r="http://schemas.openxmlformats.org/officeDocument/2006/relationships" xmlns:p="http://schemas.openxmlformats.org/presentationml/2006/main">
+  <p:cSld>
+    <p:spTree>
+      <p:nvGrpSpPr>
+        <p:cNvPr id="1" name=""/>
+        <p:cNvGrpSpPr/>
+        <p:nvPr/>
+      </p:nvGrpSpPr>
+      <p:grpSpPr>
+        <a:xfrm>
+          <a:off x="0" y="0"/>
+          <a:ext cx="0" cy="0"/>
+          <a:chOff x="0" y="0"/>
+          <a:chExt cx="0" cy="0"/>
+        </a:xfrm>
+      </p:grpSpPr>
+      <p:sp>
+        <p:nvSpPr>
+          <p:cNvPr id="2" name="Slide Image Placeholder 1"/>
+          <p:cNvSpPr>
+            <a:spLocks noGrp="1" noRot="1" noChangeAspect="1"/>
+          </p:cNvSpPr>
+          <p:nvPr>
+            <p:ph type="sldImg"/>
+          </p:nvPr>
+        </p:nvSpPr>
+        <p:spPr/>
+      </p:sp>
+      <p:sp>
+        <p:nvSpPr>
+          <p:cNvPr id="3" name="Notes Placeholder 2"/>
+          <p:cNvSpPr>
+            <a:spLocks noGrp="1"/>
+          </p:cNvSpPr>
+          <p:nvPr>
+            <p:ph type="body" idx="1"/>
+          </p:nvPr>
+        </p:nvSpPr>
+        <p:spPr/>
+        <p:txBody>
+          <a:bodyPr/>
+          <a:lstStyle/>
+          <a:p>
+            <a:endParaRPr lang="en-US" dirty="0"/>
+          </a:p>
+        </p:txBody>
+      </p:sp>
+      <p:sp>
+        <p:nvSpPr>
+          <p:cNvPr id="4" name="Slide Number Placeholder 3"/>
+          <p:cNvSpPr>
+            <a:spLocks noGrp="1"/>
+          </p:cNvSpPr>
+          <p:nvPr>
+            <p:ph type="sldNum" sz="quarter" idx="5"/>
+          </p:nvPr>
+        </p:nvSpPr>
+        <p:spPr/>
+        <p:txBody>
+          <a:bodyPr/>
+          <a:lstStyle/>
+          <a:p>
+            <a:fld id="{56D03EF2-D82D-4AC0-BEDE-36536519F695}" type="slidenum">
+              <a:rPr lang="en-US" smtClean="0"/>
+              <a:t>3</a:t>
+            </a:fld>
+            <a:endParaRPr lang="en-US"/>
+          </a:p>
+        </p:txBody>
+      </p:sp>
+    </p:spTree>
+    <p:extLst>
+      <p:ext uri="{BB962C8B-B14F-4D97-AF65-F5344CB8AC3E}">
+        <p14:creationId xmlns:p14="http://schemas.microsoft.com/office/powerpoint/2010/main" val="228787312"/>
+      </p:ext>
+    </p:extLst>
+  </p:cSld>
+  <p:clrMapOvr>
+    <a:masterClrMapping/>
+  </p:clrMapOvr>
+</p:notes>
 </file>
 
 <file path=ppt/slideLayouts/slideLayout1.xml><?xml version="1.0" encoding="utf-8"?>
@@ -255,7 +758,7 @@
           <a:p>
             <a:fld id="{01C29C5A-4FD0-4B2A-89BA-C4E525CF244A}" type="datetimeFigureOut">
               <a:rPr lang="en-US" smtClean="0"/>
-              <a:t>7/13/2026</a:t>
+              <a:t>7/15/2026</a:t>
             </a:fld>
             <a:endParaRPr lang="en-US"/>
           </a:p>
@@ -453,7 +956,7 @@
           <a:p>
             <a:fld id="{01C29C5A-4FD0-4B2A-89BA-C4E525CF244A}" type="datetimeFigureOut">
               <a:rPr lang="en-US" smtClean="0"/>
-              <a:t>7/13/2026</a:t>
+              <a:t>7/15/2026</a:t>
             </a:fld>
             <a:endParaRPr lang="en-US"/>
           </a:p>
@@ -661,7 +1164,7 @@
           <a:p>
             <a:fld id="{01C29C5A-4FD0-4B2A-89BA-C4E525CF244A}" type="datetimeFigureOut">
               <a:rPr lang="en-US" smtClean="0"/>
-              <a:t>7/13/2026</a:t>
+              <a:t>7/15/2026</a:t>
             </a:fld>
             <a:endParaRPr lang="en-US"/>
           </a:p>
@@ -859,7 +1362,7 @@
           <a:p>
             <a:fld id="{01C29C5A-4FD0-4B2A-89BA-C4E525CF244A}" type="datetimeFigureOut">
               <a:rPr lang="en-US" smtClean="0"/>
-              <a:t>7/13/2026</a:t>
+              <a:t>7/15/2026</a:t>
             </a:fld>
             <a:endParaRPr lang="en-US"/>
           </a:p>
@@ -1134,7 +1637,7 @@
           <a:p>
             <a:fld id="{01C29C5A-4FD0-4B2A-89BA-C4E525CF244A}" type="datetimeFigureOut">
               <a:rPr lang="en-US" smtClean="0"/>
-              <a:t>7/13/2026</a:t>
+              <a:t>7/15/2026</a:t>
             </a:fld>
             <a:endParaRPr lang="en-US"/>
           </a:p>
@@ -1399,7 +1902,7 @@
           <a:p>
             <a:fld id="{01C29C5A-4FD0-4B2A-89BA-C4E525CF244A}" type="datetimeFigureOut">
               <a:rPr lang="en-US" smtClean="0"/>
-              <a:t>7/13/2026</a:t>
+              <a:t>7/15/2026</a:t>
             </a:fld>
             <a:endParaRPr lang="en-US"/>
           </a:p>
@@ -1811,7 +2314,7 @@
           <a:p>
             <a:fld id="{01C29C5A-4FD0-4B2A-89BA-C4E525CF244A}" type="datetimeFigureOut">
               <a:rPr lang="en-US" smtClean="0"/>
-              <a:t>7/13/2026</a:t>
+              <a:t>7/15/2026</a:t>
             </a:fld>
             <a:endParaRPr lang="en-US"/>
           </a:p>
@@ -1952,7 +2455,7 @@
           <a:p>
             <a:fld id="{01C29C5A-4FD0-4B2A-89BA-C4E525CF244A}" type="datetimeFigureOut">
               <a:rPr lang="en-US" smtClean="0"/>
-              <a:t>7/13/2026</a:t>
+              <a:t>7/15/2026</a:t>
             </a:fld>
             <a:endParaRPr lang="en-US"/>
           </a:p>
@@ -2065,7 +2568,7 @@
           <a:p>
             <a:fld id="{01C29C5A-4FD0-4B2A-89BA-C4E525CF244A}" type="datetimeFigureOut">
               <a:rPr lang="en-US" smtClean="0"/>
-              <a:t>7/13/2026</a:t>
+              <a:t>7/15/2026</a:t>
             </a:fld>
             <a:endParaRPr lang="en-US"/>
           </a:p>
@@ -2376,7 +2879,7 @@
           <a:p>
             <a:fld id="{01C29C5A-4FD0-4B2A-89BA-C4E525CF244A}" type="datetimeFigureOut">
               <a:rPr lang="en-US" smtClean="0"/>
-              <a:t>7/13/2026</a:t>
+              <a:t>7/15/2026</a:t>
             </a:fld>
             <a:endParaRPr lang="en-US"/>
           </a:p>
@@ -2664,7 +3167,7 @@
           <a:p>
             <a:fld id="{01C29C5A-4FD0-4B2A-89BA-C4E525CF244A}" type="datetimeFigureOut">
               <a:rPr lang="en-US" smtClean="0"/>
-              <a:t>7/13/2026</a:t>
+              <a:t>7/15/2026</a:t>
             </a:fld>
             <a:endParaRPr lang="en-US"/>
           </a:p>
@@ -2905,7 +3408,7 @@
           <a:p>
             <a:fld id="{01C29C5A-4FD0-4B2A-89BA-C4E525CF244A}" type="datetimeFigureOut">
               <a:rPr lang="en-US" smtClean="0"/>
-              <a:t>7/13/2026</a:t>
+              <a:t>7/15/2026</a:t>
             </a:fld>
             <a:endParaRPr lang="en-US"/>
           </a:p>
@@ -3912,6 +4415,3310 @@
 </p:sld>
 </file>
 
+<file path=ppt/slides/slide3.xml><?xml version="1.0" encoding="utf-8"?>
+<p:sld xmlns:a="http://schemas.openxmlformats.org/drawingml/2006/main" xmlns:r="http://schemas.openxmlformats.org/officeDocument/2006/relationships" xmlns:p="http://schemas.openxmlformats.org/presentationml/2006/main">
+  <p:cSld>
+    <p:spTree>
+      <p:nvGrpSpPr>
+        <p:cNvPr id="1" name="">
+          <a:extLst>
+            <a:ext uri="{FF2B5EF4-FFF2-40B4-BE49-F238E27FC236}">
+              <a16:creationId xmlns:a16="http://schemas.microsoft.com/office/drawing/2014/main" id="{12EA9D5A-79DF-5F76-B030-16BCAADB346E}"/>
+            </a:ext>
+          </a:extLst>
+        </p:cNvPr>
+        <p:cNvGrpSpPr/>
+        <p:nvPr/>
+      </p:nvGrpSpPr>
+      <p:grpSpPr>
+        <a:xfrm>
+          <a:off x="0" y="0"/>
+          <a:ext cx="0" cy="0"/>
+          <a:chOff x="0" y="0"/>
+          <a:chExt cx="0" cy="0"/>
+        </a:xfrm>
+      </p:grpSpPr>
+      <p:pic>
+        <p:nvPicPr>
+          <p:cNvPr id="11" name="Picture 10">
+            <a:extLst>
+              <a:ext uri="{FF2B5EF4-FFF2-40B4-BE49-F238E27FC236}">
+                <a16:creationId xmlns:a16="http://schemas.microsoft.com/office/drawing/2014/main" id="{A7163994-4120-B75F-D0BB-9A4400224465}"/>
+              </a:ext>
+            </a:extLst>
+          </p:cNvPr>
+          <p:cNvPicPr>
+            <a:picLocks noChangeAspect="1"/>
+          </p:cNvPicPr>
+          <p:nvPr/>
+        </p:nvPicPr>
+        <p:blipFill>
+          <a:blip r:embed="rId3"/>
+          <a:stretch>
+            <a:fillRect/>
+          </a:stretch>
+        </p:blipFill>
+        <p:spPr>
+          <a:xfrm>
+            <a:off x="983473" y="2972070"/>
+            <a:ext cx="15085394" cy="2352130"/>
+          </a:xfrm>
+          <a:prstGeom prst="rect">
+            <a:avLst/>
+          </a:prstGeom>
+        </p:spPr>
+      </p:pic>
+      <p:sp>
+        <p:nvSpPr>
+          <p:cNvPr id="28" name="Arrow: U-Turn 27">
+            <a:extLst>
+              <a:ext uri="{FF2B5EF4-FFF2-40B4-BE49-F238E27FC236}">
+                <a16:creationId xmlns:a16="http://schemas.microsoft.com/office/drawing/2014/main" id="{B2B6734F-E917-A270-ABA7-F4AAD7BF1443}"/>
+              </a:ext>
+            </a:extLst>
+          </p:cNvPr>
+          <p:cNvSpPr/>
+          <p:nvPr/>
+        </p:nvSpPr>
+        <p:spPr>
+          <a:xfrm rot="2103223">
+            <a:off x="296368" y="1301147"/>
+            <a:ext cx="5560597" cy="2788136"/>
+          </a:xfrm>
+          <a:prstGeom prst="uturnArrow">
+            <a:avLst/>
+          </a:prstGeom>
+          <a:solidFill>
+            <a:srgbClr val="1F3351">
+              <a:alpha val="58000"/>
+            </a:srgbClr>
+          </a:solidFill>
+          <a:ln w="76200">
+            <a:solidFill>
+              <a:srgbClr val="FFFFFF">
+                <a:alpha val="16000"/>
+              </a:srgbClr>
+            </a:solidFill>
+          </a:ln>
+        </p:spPr>
+        <p:style>
+          <a:lnRef idx="2">
+            <a:schemeClr val="accent1">
+              <a:shade val="15000"/>
+            </a:schemeClr>
+          </a:lnRef>
+          <a:fillRef idx="1">
+            <a:schemeClr val="accent1"/>
+          </a:fillRef>
+          <a:effectRef idx="0">
+            <a:schemeClr val="accent1"/>
+          </a:effectRef>
+          <a:fontRef idx="minor">
+            <a:schemeClr val="lt1"/>
+          </a:fontRef>
+        </p:style>
+        <p:txBody>
+          <a:bodyPr rtlCol="0" anchor="ctr"/>
+          <a:lstStyle/>
+          <a:p>
+            <a:pPr algn="ctr"/>
+            <a:endParaRPr lang="en-US">
+              <a:solidFill>
+                <a:schemeClr val="tx1"/>
+              </a:solidFill>
+            </a:endParaRPr>
+          </a:p>
+        </p:txBody>
+      </p:sp>
+      <p:sp>
+        <p:nvSpPr>
+          <p:cNvPr id="29" name="Arrow: U-Turn 28">
+            <a:extLst>
+              <a:ext uri="{FF2B5EF4-FFF2-40B4-BE49-F238E27FC236}">
+                <a16:creationId xmlns:a16="http://schemas.microsoft.com/office/drawing/2014/main" id="{7B7424ED-02FA-45E0-21A7-8ACCE8FB0F8A}"/>
+              </a:ext>
+            </a:extLst>
+          </p:cNvPr>
+          <p:cNvSpPr/>
+          <p:nvPr/>
+        </p:nvSpPr>
+        <p:spPr>
+          <a:xfrm rot="6595308" flipH="1">
+            <a:off x="10215157" y="4320943"/>
+            <a:ext cx="3681198" cy="2788136"/>
+          </a:xfrm>
+          <a:prstGeom prst="uturnArrow">
+            <a:avLst>
+              <a:gd name="adj1" fmla="val 20699"/>
+              <a:gd name="adj2" fmla="val 25000"/>
+              <a:gd name="adj3" fmla="val 25000"/>
+              <a:gd name="adj4" fmla="val 40967"/>
+              <a:gd name="adj5" fmla="val 75000"/>
+            </a:avLst>
+          </a:prstGeom>
+          <a:solidFill>
+            <a:srgbClr val="1F3351">
+              <a:alpha val="58000"/>
+            </a:srgbClr>
+          </a:solidFill>
+          <a:ln w="76200">
+            <a:solidFill>
+              <a:srgbClr val="FFFFFF">
+                <a:alpha val="16000"/>
+              </a:srgbClr>
+            </a:solidFill>
+          </a:ln>
+        </p:spPr>
+        <p:style>
+          <a:lnRef idx="2">
+            <a:schemeClr val="accent1">
+              <a:shade val="15000"/>
+            </a:schemeClr>
+          </a:lnRef>
+          <a:fillRef idx="1">
+            <a:schemeClr val="accent1"/>
+          </a:fillRef>
+          <a:effectRef idx="0">
+            <a:schemeClr val="accent1"/>
+          </a:effectRef>
+          <a:fontRef idx="minor">
+            <a:schemeClr val="lt1"/>
+          </a:fontRef>
+        </p:style>
+        <p:txBody>
+          <a:bodyPr rtlCol="0" anchor="ctr"/>
+          <a:lstStyle/>
+          <a:p>
+            <a:pPr algn="ctr"/>
+            <a:endParaRPr lang="en-US">
+              <a:solidFill>
+                <a:schemeClr val="tx1"/>
+              </a:solidFill>
+            </a:endParaRPr>
+          </a:p>
+        </p:txBody>
+      </p:sp>
+      <p:pic>
+        <p:nvPicPr>
+          <p:cNvPr id="12" name="Picture 11">
+            <a:extLst>
+              <a:ext uri="{FF2B5EF4-FFF2-40B4-BE49-F238E27FC236}">
+                <a16:creationId xmlns:a16="http://schemas.microsoft.com/office/drawing/2014/main" id="{2DEBE992-780F-1CD0-2225-8AB5E73CB7CF}"/>
+              </a:ext>
+            </a:extLst>
+          </p:cNvPr>
+          <p:cNvPicPr>
+            <a:picLocks noChangeAspect="1"/>
+          </p:cNvPicPr>
+          <p:nvPr/>
+        </p:nvPicPr>
+        <p:blipFill>
+          <a:blip r:embed="rId4"/>
+          <a:stretch>
+            <a:fillRect/>
+          </a:stretch>
+        </p:blipFill>
+        <p:spPr>
+          <a:xfrm rot="166398">
+            <a:off x="4803925" y="3399402"/>
+            <a:ext cx="7033537" cy="1434961"/>
+          </a:xfrm>
+          <a:prstGeom prst="rect">
+            <a:avLst/>
+          </a:prstGeom>
+          <a:effectLst>
+            <a:glow rad="254000">
+              <a:srgbClr val="1F3351">
+                <a:alpha val="92000"/>
+              </a:srgbClr>
+            </a:glow>
+            <a:outerShdw blurRad="50800" dist="50800" dir="5400000" algn="ctr" rotWithShape="0">
+              <a:srgbClr val="000000">
+                <a:alpha val="88000"/>
+              </a:srgbClr>
+            </a:outerShdw>
+            <a:reflection endPos="0" dir="5400000" sy="-100000" algn="bl" rotWithShape="0"/>
+          </a:effectLst>
+        </p:spPr>
+      </p:pic>
+      <p:pic>
+        <p:nvPicPr>
+          <p:cNvPr id="25" name="Picture 24">
+            <a:extLst>
+              <a:ext uri="{FF2B5EF4-FFF2-40B4-BE49-F238E27FC236}">
+                <a16:creationId xmlns:a16="http://schemas.microsoft.com/office/drawing/2014/main" id="{89C898F7-F6ED-B783-EBD7-A6BB8B3B8C4B}"/>
+              </a:ext>
+            </a:extLst>
+          </p:cNvPr>
+          <p:cNvPicPr>
+            <a:picLocks noChangeAspect="1"/>
+          </p:cNvPicPr>
+          <p:nvPr/>
+        </p:nvPicPr>
+        <p:blipFill>
+          <a:blip r:embed="rId5"/>
+          <a:stretch>
+            <a:fillRect/>
+          </a:stretch>
+        </p:blipFill>
+        <p:spPr>
+          <a:xfrm>
+            <a:off x="4719740" y="-1286455"/>
+            <a:ext cx="7201905" cy="3677163"/>
+          </a:xfrm>
+          <a:prstGeom prst="rect">
+            <a:avLst/>
+          </a:prstGeom>
+          <a:effectLst>
+            <a:outerShdw blurRad="50800" dist="50800" dir="5400000" algn="ctr" rotWithShape="0">
+              <a:srgbClr val="000000">
+                <a:alpha val="0"/>
+              </a:srgbClr>
+            </a:outerShdw>
+            <a:reflection stA="98000" dir="5400000" sy="-100000" algn="bl" rotWithShape="0"/>
+          </a:effectLst>
+        </p:spPr>
+      </p:pic>
+      <p:pic>
+        <p:nvPicPr>
+          <p:cNvPr id="27" name="Picture 26">
+            <a:extLst>
+              <a:ext uri="{FF2B5EF4-FFF2-40B4-BE49-F238E27FC236}">
+                <a16:creationId xmlns:a16="http://schemas.microsoft.com/office/drawing/2014/main" id="{C5E55986-6751-F47E-8529-0CD52AA9589C}"/>
+              </a:ext>
+            </a:extLst>
+          </p:cNvPr>
+          <p:cNvPicPr>
+            <a:picLocks noChangeAspect="1"/>
+          </p:cNvPicPr>
+          <p:nvPr/>
+        </p:nvPicPr>
+        <p:blipFill>
+          <a:blip r:embed="rId6"/>
+          <a:stretch>
+            <a:fillRect/>
+          </a:stretch>
+        </p:blipFill>
+        <p:spPr>
+          <a:xfrm>
+            <a:off x="8084879" y="-2116754"/>
+            <a:ext cx="3253938" cy="3902698"/>
+          </a:xfrm>
+          <a:prstGeom prst="rect">
+            <a:avLst/>
+          </a:prstGeom>
+          <a:effectLst>
+            <a:outerShdw blurRad="50800" dist="50800" dir="5400000" algn="ctr" rotWithShape="0">
+              <a:srgbClr val="000000">
+                <a:alpha val="96000"/>
+              </a:srgbClr>
+            </a:outerShdw>
+            <a:reflection dir="5400000" sy="-100000" algn="bl" rotWithShape="0"/>
+          </a:effectLst>
+        </p:spPr>
+      </p:pic>
+      <p:sp>
+        <p:nvSpPr>
+          <p:cNvPr id="30" name="Rectangle 29">
+            <a:extLst>
+              <a:ext uri="{FF2B5EF4-FFF2-40B4-BE49-F238E27FC236}">
+                <a16:creationId xmlns:a16="http://schemas.microsoft.com/office/drawing/2014/main" id="{2E05F89A-AC47-BB03-5765-CEE091406C60}"/>
+              </a:ext>
+            </a:extLst>
+          </p:cNvPr>
+          <p:cNvSpPr/>
+          <p:nvPr/>
+        </p:nvSpPr>
+        <p:spPr>
+          <a:xfrm>
+            <a:off x="983473" y="2972070"/>
+            <a:ext cx="13243666" cy="874902"/>
+          </a:xfrm>
+          <a:prstGeom prst="rect">
+            <a:avLst/>
+          </a:prstGeom>
+          <a:gradFill>
+            <a:gsLst>
+              <a:gs pos="0">
+                <a:schemeClr val="accent1">
+                  <a:lumMod val="5000"/>
+                  <a:lumOff val="95000"/>
+                  <a:alpha val="73000"/>
+                </a:schemeClr>
+              </a:gs>
+              <a:gs pos="89000">
+                <a:schemeClr val="accent1">
+                  <a:lumMod val="45000"/>
+                  <a:lumOff val="55000"/>
+                  <a:alpha val="0"/>
+                </a:schemeClr>
+              </a:gs>
+            </a:gsLst>
+            <a:lin ang="5400000" scaled="1"/>
+          </a:gradFill>
+          <a:ln>
+            <a:noFill/>
+          </a:ln>
+        </p:spPr>
+        <p:style>
+          <a:lnRef idx="2">
+            <a:schemeClr val="accent1">
+              <a:shade val="15000"/>
+            </a:schemeClr>
+          </a:lnRef>
+          <a:fillRef idx="1">
+            <a:schemeClr val="accent1"/>
+          </a:fillRef>
+          <a:effectRef idx="0">
+            <a:schemeClr val="accent1"/>
+          </a:effectRef>
+          <a:fontRef idx="minor">
+            <a:schemeClr val="lt1"/>
+          </a:fontRef>
+        </p:style>
+        <p:txBody>
+          <a:bodyPr rtlCol="0" anchor="ctr"/>
+          <a:lstStyle/>
+          <a:p>
+            <a:pPr algn="ctr"/>
+            <a:endParaRPr lang="en-US"/>
+          </a:p>
+        </p:txBody>
+      </p:sp>
+      <p:sp>
+        <p:nvSpPr>
+          <p:cNvPr id="31" name="Rectangle 30">
+            <a:extLst>
+              <a:ext uri="{FF2B5EF4-FFF2-40B4-BE49-F238E27FC236}">
+                <a16:creationId xmlns:a16="http://schemas.microsoft.com/office/drawing/2014/main" id="{1C0DF45B-7B75-E4BA-F94A-72281060529D}"/>
+              </a:ext>
+            </a:extLst>
+          </p:cNvPr>
+          <p:cNvSpPr/>
+          <p:nvPr/>
+        </p:nvSpPr>
+        <p:spPr>
+          <a:xfrm rot="10800000">
+            <a:off x="908151" y="4502515"/>
+            <a:ext cx="13243666" cy="874902"/>
+          </a:xfrm>
+          <a:prstGeom prst="rect">
+            <a:avLst/>
+          </a:prstGeom>
+          <a:gradFill>
+            <a:gsLst>
+              <a:gs pos="0">
+                <a:schemeClr val="accent1">
+                  <a:lumMod val="5000"/>
+                  <a:lumOff val="95000"/>
+                  <a:alpha val="55000"/>
+                </a:schemeClr>
+              </a:gs>
+              <a:gs pos="89000">
+                <a:schemeClr val="accent1">
+                  <a:lumMod val="45000"/>
+                  <a:lumOff val="55000"/>
+                  <a:alpha val="0"/>
+                </a:schemeClr>
+              </a:gs>
+            </a:gsLst>
+            <a:lin ang="5400000" scaled="1"/>
+          </a:gradFill>
+          <a:ln>
+            <a:noFill/>
+          </a:ln>
+        </p:spPr>
+        <p:style>
+          <a:lnRef idx="2">
+            <a:schemeClr val="accent1">
+              <a:shade val="15000"/>
+            </a:schemeClr>
+          </a:lnRef>
+          <a:fillRef idx="1">
+            <a:schemeClr val="accent1"/>
+          </a:fillRef>
+          <a:effectRef idx="0">
+            <a:schemeClr val="accent1"/>
+          </a:effectRef>
+          <a:fontRef idx="minor">
+            <a:schemeClr val="lt1"/>
+          </a:fontRef>
+        </p:style>
+        <p:txBody>
+          <a:bodyPr rtlCol="0" anchor="ctr"/>
+          <a:lstStyle/>
+          <a:p>
+            <a:pPr algn="ctr"/>
+            <a:endParaRPr lang="en-US"/>
+          </a:p>
+        </p:txBody>
+      </p:sp>
+      <p:pic>
+        <p:nvPicPr>
+          <p:cNvPr id="1026" name="Picture 2">
+            <a:extLst>
+              <a:ext uri="{FF2B5EF4-FFF2-40B4-BE49-F238E27FC236}">
+                <a16:creationId xmlns:a16="http://schemas.microsoft.com/office/drawing/2014/main" id="{6FD60A9D-F392-8ED5-38AF-A641FA1DEAA3}"/>
+              </a:ext>
+            </a:extLst>
+          </p:cNvPr>
+          <p:cNvPicPr>
+            <a:picLocks noChangeAspect="1" noChangeArrowheads="1"/>
+          </p:cNvPicPr>
+          <p:nvPr/>
+        </p:nvPicPr>
+        <p:blipFill>
+          <a:blip r:embed="rId7">
+            <a:extLst>
+              <a:ext uri="{28A0092B-C50C-407E-A947-70E740481C1C}">
+                <a14:useLocalDpi xmlns:a14="http://schemas.microsoft.com/office/drawing/2010/main" val="0"/>
+              </a:ext>
+            </a:extLst>
+          </a:blip>
+          <a:srcRect/>
+          <a:stretch>
+            <a:fillRect/>
+          </a:stretch>
+        </p:blipFill>
+        <p:spPr bwMode="auto">
+          <a:xfrm rot="162713">
+            <a:off x="8501235" y="4460520"/>
+            <a:ext cx="3037845" cy="679390"/>
+          </a:xfrm>
+          <a:prstGeom prst="rect">
+            <a:avLst/>
+          </a:prstGeom>
+          <a:noFill/>
+          <a:extLst>
+            <a:ext uri="{909E8E84-426E-40DD-AFC4-6F175D3DCCD1}">
+              <a14:hiddenFill xmlns:a14="http://schemas.microsoft.com/office/drawing/2010/main">
+                <a:solidFill>
+                  <a:srgbClr val="FFFFFF"/>
+                </a:solidFill>
+              </a14:hiddenFill>
+            </a:ext>
+          </a:extLst>
+        </p:spPr>
+      </p:pic>
+      <p:grpSp>
+        <p:nvGrpSpPr>
+          <p:cNvPr id="33" name="Group 32">
+            <a:extLst>
+              <a:ext uri="{FF2B5EF4-FFF2-40B4-BE49-F238E27FC236}">
+                <a16:creationId xmlns:a16="http://schemas.microsoft.com/office/drawing/2014/main" id="{151C0BC0-FC02-B85A-DAA4-9DFFE67BE714}"/>
+              </a:ext>
+            </a:extLst>
+          </p:cNvPr>
+          <p:cNvGrpSpPr/>
+          <p:nvPr/>
+        </p:nvGrpSpPr>
+        <p:grpSpPr>
+          <a:xfrm rot="20539069">
+            <a:off x="1025974" y="2572716"/>
+            <a:ext cx="3855979" cy="3150835"/>
+            <a:chOff x="950411" y="2957596"/>
+            <a:chExt cx="3855979" cy="3150835"/>
+          </a:xfrm>
+        </p:grpSpPr>
+        <p:sp>
+          <p:nvSpPr>
+            <p:cNvPr id="17" name="Rectangle: Rounded Corners 16">
+              <a:extLst>
+                <a:ext uri="{FF2B5EF4-FFF2-40B4-BE49-F238E27FC236}">
+                  <a16:creationId xmlns:a16="http://schemas.microsoft.com/office/drawing/2014/main" id="{C539F344-21DE-E202-0266-AEDADFE22DDE}"/>
+                </a:ext>
+              </a:extLst>
+            </p:cNvPr>
+            <p:cNvSpPr/>
+            <p:nvPr/>
+          </p:nvSpPr>
+          <p:spPr>
+            <a:xfrm rot="21224836">
+              <a:off x="1658865" y="3393140"/>
+              <a:ext cx="2264945" cy="2279748"/>
+            </a:xfrm>
+            <a:prstGeom prst="roundRect">
+              <a:avLst>
+                <a:gd name="adj" fmla="val 1396"/>
+              </a:avLst>
+            </a:prstGeom>
+            <a:solidFill>
+              <a:schemeClr val="tx1">
+                <a:alpha val="22000"/>
+              </a:schemeClr>
+            </a:solidFill>
+            <a:ln>
+              <a:noFill/>
+            </a:ln>
+            <a:effectLst>
+              <a:glow rad="914400">
+                <a:srgbClr val="1F3351">
+                  <a:alpha val="69000"/>
+                </a:srgbClr>
+              </a:glow>
+              <a:outerShdw blurRad="50800" dist="50800" dir="5400000" algn="ctr" rotWithShape="0">
+                <a:srgbClr val="000000">
+                  <a:alpha val="99000"/>
+                </a:srgbClr>
+              </a:outerShdw>
+            </a:effectLst>
+          </p:spPr>
+          <p:style>
+            <a:lnRef idx="2">
+              <a:schemeClr val="accent1">
+                <a:shade val="15000"/>
+              </a:schemeClr>
+            </a:lnRef>
+            <a:fillRef idx="1">
+              <a:schemeClr val="accent1"/>
+            </a:fillRef>
+            <a:effectRef idx="0">
+              <a:schemeClr val="accent1"/>
+            </a:effectRef>
+            <a:fontRef idx="minor">
+              <a:schemeClr val="lt1"/>
+            </a:fontRef>
+          </p:style>
+          <p:txBody>
+            <a:bodyPr rtlCol="0" anchor="ctr"/>
+            <a:lstStyle/>
+            <a:p>
+              <a:pPr algn="ctr"/>
+              <a:endParaRPr lang="en-US"/>
+            </a:p>
+          </p:txBody>
+        </p:sp>
+        <p:sp>
+          <p:nvSpPr>
+            <p:cNvPr id="19" name="Oval 18">
+              <a:extLst>
+                <a:ext uri="{FF2B5EF4-FFF2-40B4-BE49-F238E27FC236}">
+                  <a16:creationId xmlns:a16="http://schemas.microsoft.com/office/drawing/2014/main" id="{464B468C-CD59-C96D-DCFF-92AE027350CD}"/>
+                </a:ext>
+              </a:extLst>
+            </p:cNvPr>
+            <p:cNvSpPr/>
+            <p:nvPr/>
+          </p:nvSpPr>
+          <p:spPr>
+            <a:xfrm rot="21224836">
+              <a:off x="2847234" y="4291368"/>
+              <a:ext cx="148126" cy="151976"/>
+            </a:xfrm>
+            <a:prstGeom prst="ellipse">
+              <a:avLst/>
+            </a:prstGeom>
+            <a:solidFill>
+              <a:srgbClr val="3B4B65"/>
+            </a:solidFill>
+            <a:ln>
+              <a:solidFill>
+                <a:srgbClr val="3B4B65"/>
+              </a:solidFill>
+            </a:ln>
+          </p:spPr>
+          <p:style>
+            <a:lnRef idx="2">
+              <a:schemeClr val="accent1">
+                <a:shade val="15000"/>
+              </a:schemeClr>
+            </a:lnRef>
+            <a:fillRef idx="1">
+              <a:schemeClr val="accent1"/>
+            </a:fillRef>
+            <a:effectRef idx="0">
+              <a:schemeClr val="accent1"/>
+            </a:effectRef>
+            <a:fontRef idx="minor">
+              <a:schemeClr val="lt1"/>
+            </a:fontRef>
+          </p:style>
+          <p:txBody>
+            <a:bodyPr rtlCol="0" anchor="ctr"/>
+            <a:lstStyle/>
+            <a:p>
+              <a:pPr algn="ctr"/>
+              <a:endParaRPr lang="en-US"/>
+            </a:p>
+          </p:txBody>
+        </p:sp>
+        <p:sp>
+          <p:nvSpPr>
+            <p:cNvPr id="18" name="Oval 17">
+              <a:extLst>
+                <a:ext uri="{FF2B5EF4-FFF2-40B4-BE49-F238E27FC236}">
+                  <a16:creationId xmlns:a16="http://schemas.microsoft.com/office/drawing/2014/main" id="{4B16BC0D-D0D3-5EFB-D44D-C6B586294DD7}"/>
+                </a:ext>
+              </a:extLst>
+            </p:cNvPr>
+            <p:cNvSpPr/>
+            <p:nvPr/>
+          </p:nvSpPr>
+          <p:spPr>
+            <a:xfrm rot="21224836">
+              <a:off x="2234545" y="4399498"/>
+              <a:ext cx="75914" cy="77887"/>
+            </a:xfrm>
+            <a:prstGeom prst="ellipse">
+              <a:avLst/>
+            </a:prstGeom>
+            <a:solidFill>
+              <a:srgbClr val="3B4B65"/>
+            </a:solidFill>
+            <a:ln>
+              <a:solidFill>
+                <a:srgbClr val="3B4B65"/>
+              </a:solidFill>
+            </a:ln>
+          </p:spPr>
+          <p:style>
+            <a:lnRef idx="2">
+              <a:schemeClr val="accent1">
+                <a:shade val="15000"/>
+              </a:schemeClr>
+            </a:lnRef>
+            <a:fillRef idx="1">
+              <a:schemeClr val="accent1"/>
+            </a:fillRef>
+            <a:effectRef idx="0">
+              <a:schemeClr val="accent1"/>
+            </a:effectRef>
+            <a:fontRef idx="minor">
+              <a:schemeClr val="lt1"/>
+            </a:fontRef>
+          </p:style>
+          <p:txBody>
+            <a:bodyPr rtlCol="0" anchor="ctr"/>
+            <a:lstStyle/>
+            <a:p>
+              <a:pPr algn="ctr"/>
+              <a:endParaRPr lang="en-US"/>
+            </a:p>
+          </p:txBody>
+        </p:sp>
+        <mc:AlternateContent xmlns:mc="http://schemas.openxmlformats.org/markup-compatibility/2006">
+          <mc:Choice xmlns:p14="http://schemas.microsoft.com/office/powerpoint/2010/main" Requires="p14">
+            <p:contentPart p14:bwMode="auto" r:id="rId8">
+              <p14:nvContentPartPr>
+                <p14:cNvPr id="20" name="Ink 19">
+                  <a:extLst>
+                    <a:ext uri="{FF2B5EF4-FFF2-40B4-BE49-F238E27FC236}">
+                      <a16:creationId xmlns:a16="http://schemas.microsoft.com/office/drawing/2014/main" id="{189DAB13-CE1E-F2DC-FEDD-42B13AD83156}"/>
+                    </a:ext>
+                  </a:extLst>
+                </p14:cNvPr>
+                <p14:cNvContentPartPr/>
+                <p14:nvPr/>
+              </p14:nvContentPartPr>
+              <p14:xfrm rot="5761859">
+                <a:off x="2910758" y="4330824"/>
+                <a:ext cx="62775" cy="68927"/>
+              </p14:xfrm>
+            </p:contentPart>
+          </mc:Choice>
+          <mc:Fallback>
+            <p:pic>
+              <p:nvPicPr>
+                <p:cNvPr id="20" name="Ink 19">
+                  <a:extLst>
+                    <a:ext uri="{FF2B5EF4-FFF2-40B4-BE49-F238E27FC236}">
+                      <a16:creationId xmlns:a16="http://schemas.microsoft.com/office/drawing/2014/main" id="{189DAB13-CE1E-F2DC-FEDD-42B13AD83156}"/>
+                    </a:ext>
+                  </a:extLst>
+                </p:cNvPr>
+                <p:cNvPicPr/>
+                <p:nvPr/>
+              </p:nvPicPr>
+              <p:blipFill>
+                <a:blip r:embed="rId9"/>
+                <a:stretch>
+                  <a:fillRect/>
+                </a:stretch>
+              </p:blipFill>
+              <p:spPr>
+                <a:xfrm rot="5761859">
+                  <a:off x="2901790" y="4321849"/>
+                  <a:ext cx="80352" cy="86518"/>
+                </a:xfrm>
+                <a:prstGeom prst="rect">
+                  <a:avLst/>
+                </a:prstGeom>
+              </p:spPr>
+            </p:pic>
+          </mc:Fallback>
+        </mc:AlternateContent>
+        <p:pic>
+          <p:nvPicPr>
+            <p:cNvPr id="3" name="Picture 2" descr="A blue square with circles and dots&#10;&#10;AI-generated content may be incorrect.">
+              <a:extLst>
+                <a:ext uri="{FF2B5EF4-FFF2-40B4-BE49-F238E27FC236}">
+                  <a16:creationId xmlns:a16="http://schemas.microsoft.com/office/drawing/2014/main" id="{EBCC15F3-91AF-D751-836D-1BE76F671B13}"/>
+                </a:ext>
+              </a:extLst>
+            </p:cNvPr>
+            <p:cNvPicPr>
+              <a:picLocks noChangeAspect="1"/>
+            </p:cNvPicPr>
+            <p:nvPr/>
+          </p:nvPicPr>
+          <p:blipFill>
+            <a:blip r:embed="rId10">
+              <a:extLst>
+                <a:ext uri="{28A0092B-C50C-407E-A947-70E740481C1C}">
+                  <a14:useLocalDpi xmlns:a14="http://schemas.microsoft.com/office/drawing/2010/main" val="0"/>
+                </a:ext>
+              </a:extLst>
+            </a:blip>
+            <a:stretch>
+              <a:fillRect/>
+            </a:stretch>
+          </p:blipFill>
+          <p:spPr>
+            <a:xfrm rot="21224836">
+              <a:off x="950411" y="2957596"/>
+              <a:ext cx="3855979" cy="3150835"/>
+            </a:xfrm>
+            <a:prstGeom prst="rect">
+              <a:avLst/>
+            </a:prstGeom>
+            <a:effectLst>
+              <a:glow>
+                <a:schemeClr val="bg1"/>
+              </a:glow>
+              <a:outerShdw blurRad="50800" dist="50800" dir="5400000" algn="ctr" rotWithShape="0">
+                <a:srgbClr val="000000">
+                  <a:alpha val="92000"/>
+                </a:srgbClr>
+              </a:outerShdw>
+              <a:reflection stA="0" endPos="65000" dist="50800" dir="5400000" sy="-100000" algn="bl" rotWithShape="0"/>
+            </a:effectLst>
+          </p:spPr>
+        </p:pic>
+      </p:grpSp>
+    </p:spTree>
+    <p:extLst>
+      <p:ext uri="{BB962C8B-B14F-4D97-AF65-F5344CB8AC3E}">
+        <p14:creationId xmlns:p14="http://schemas.microsoft.com/office/powerpoint/2010/main" val="258548572"/>
+      </p:ext>
+    </p:extLst>
+  </p:cSld>
+  <p:clrMapOvr>
+    <a:masterClrMapping/>
+  </p:clrMapOvr>
+</p:sld>
+</file>
+
+<file path=ppt/slides/slide4.xml><?xml version="1.0" encoding="utf-8"?>
+<p:sld xmlns:a="http://schemas.openxmlformats.org/drawingml/2006/main" xmlns:r="http://schemas.openxmlformats.org/officeDocument/2006/relationships" xmlns:p="http://schemas.openxmlformats.org/presentationml/2006/main">
+  <p:cSld>
+    <p:spTree>
+      <p:nvGrpSpPr>
+        <p:cNvPr id="1" name=""/>
+        <p:cNvGrpSpPr/>
+        <p:nvPr/>
+      </p:nvGrpSpPr>
+      <p:grpSpPr>
+        <a:xfrm>
+          <a:off x="0" y="0"/>
+          <a:ext cx="0" cy="0"/>
+          <a:chOff x="0" y="0"/>
+          <a:chExt cx="0" cy="0"/>
+        </a:xfrm>
+      </p:grpSpPr>
+      <p:pic>
+        <p:nvPicPr>
+          <p:cNvPr id="4" name="Picture 3">
+            <a:extLst>
+              <a:ext uri="{FF2B5EF4-FFF2-40B4-BE49-F238E27FC236}">
+                <a16:creationId xmlns:a16="http://schemas.microsoft.com/office/drawing/2014/main" id="{D1836982-8660-AFA0-8E3F-E9D419B5E9D3}"/>
+              </a:ext>
+            </a:extLst>
+          </p:cNvPr>
+          <p:cNvPicPr>
+            <a:picLocks noChangeAspect="1"/>
+          </p:cNvPicPr>
+          <p:nvPr/>
+        </p:nvPicPr>
+        <p:blipFill>
+          <a:blip r:embed="rId2"/>
+          <a:stretch>
+            <a:fillRect/>
+          </a:stretch>
+        </p:blipFill>
+        <p:spPr>
+          <a:xfrm>
+            <a:off x="1901099" y="1063948"/>
+            <a:ext cx="8389802" cy="4730103"/>
+          </a:xfrm>
+          <a:prstGeom prst="rect">
+            <a:avLst/>
+          </a:prstGeom>
+        </p:spPr>
+      </p:pic>
+    </p:spTree>
+    <p:extLst>
+      <p:ext uri="{BB962C8B-B14F-4D97-AF65-F5344CB8AC3E}">
+        <p14:creationId xmlns:p14="http://schemas.microsoft.com/office/powerpoint/2010/main" val="2342250112"/>
+      </p:ext>
+    </p:extLst>
+  </p:cSld>
+  <p:clrMapOvr>
+    <a:masterClrMapping/>
+  </p:clrMapOvr>
+</p:sld>
+</file>
+
+<file path=ppt/slides/slide5.xml><?xml version="1.0" encoding="utf-8"?>
+<p:sld xmlns:a="http://schemas.openxmlformats.org/drawingml/2006/main" xmlns:r="http://schemas.openxmlformats.org/officeDocument/2006/relationships" xmlns:p="http://schemas.openxmlformats.org/presentationml/2006/main">
+  <p:cSld>
+    <p:spTree>
+      <p:nvGrpSpPr>
+        <p:cNvPr id="1" name="">
+          <a:extLst>
+            <a:ext uri="{FF2B5EF4-FFF2-40B4-BE49-F238E27FC236}">
+              <a16:creationId xmlns:a16="http://schemas.microsoft.com/office/drawing/2014/main" id="{5CB95E95-BD79-4F2A-99EB-CC70644B4B5D}"/>
+            </a:ext>
+          </a:extLst>
+        </p:cNvPr>
+        <p:cNvGrpSpPr/>
+        <p:nvPr/>
+      </p:nvGrpSpPr>
+      <p:grpSpPr>
+        <a:xfrm>
+          <a:off x="0" y="0"/>
+          <a:ext cx="0" cy="0"/>
+          <a:chOff x="0" y="0"/>
+          <a:chExt cx="0" cy="0"/>
+        </a:xfrm>
+      </p:grpSpPr>
+      <p:pic>
+        <p:nvPicPr>
+          <p:cNvPr id="4" name="Picture 3">
+            <a:extLst>
+              <a:ext uri="{FF2B5EF4-FFF2-40B4-BE49-F238E27FC236}">
+                <a16:creationId xmlns:a16="http://schemas.microsoft.com/office/drawing/2014/main" id="{BCA3E5D8-2B10-B353-62E3-67F243727FF9}"/>
+              </a:ext>
+            </a:extLst>
+          </p:cNvPr>
+          <p:cNvPicPr>
+            <a:picLocks noChangeAspect="1"/>
+          </p:cNvPicPr>
+          <p:nvPr/>
+        </p:nvPicPr>
+        <p:blipFill>
+          <a:blip r:embed="rId2"/>
+          <a:stretch>
+            <a:fillRect/>
+          </a:stretch>
+        </p:blipFill>
+        <p:spPr>
+          <a:xfrm>
+            <a:off x="1901099" y="1063948"/>
+            <a:ext cx="8389802" cy="4730103"/>
+          </a:xfrm>
+          <a:prstGeom prst="rect">
+            <a:avLst/>
+          </a:prstGeom>
+        </p:spPr>
+      </p:pic>
+    </p:spTree>
+    <p:extLst>
+      <p:ext uri="{BB962C8B-B14F-4D97-AF65-F5344CB8AC3E}">
+        <p14:creationId xmlns:p14="http://schemas.microsoft.com/office/powerpoint/2010/main" val="2328314767"/>
+      </p:ext>
+    </p:extLst>
+  </p:cSld>
+  <p:clrMapOvr>
+    <a:masterClrMapping/>
+  </p:clrMapOvr>
+</p:sld>
+</file>
+
+<file path=ppt/slides/slide6.xml><?xml version="1.0" encoding="utf-8"?>
+<p:sld xmlns:a="http://schemas.openxmlformats.org/drawingml/2006/main" xmlns:r="http://schemas.openxmlformats.org/officeDocument/2006/relationships" xmlns:p="http://schemas.openxmlformats.org/presentationml/2006/main">
+  <p:cSld>
+    <p:spTree>
+      <p:nvGrpSpPr>
+        <p:cNvPr id="1" name=""/>
+        <p:cNvGrpSpPr/>
+        <p:nvPr/>
+      </p:nvGrpSpPr>
+      <p:grpSpPr>
+        <a:xfrm>
+          <a:off x="0" y="0"/>
+          <a:ext cx="0" cy="0"/>
+          <a:chOff x="0" y="0"/>
+          <a:chExt cx="0" cy="0"/>
+        </a:xfrm>
+      </p:grpSpPr>
+      <p:sp>
+        <p:nvSpPr>
+          <p:cNvPr id="15" name="Rectangle 14">
+            <a:extLst>
+              <a:ext uri="{FF2B5EF4-FFF2-40B4-BE49-F238E27FC236}">
+                <a16:creationId xmlns:a16="http://schemas.microsoft.com/office/drawing/2014/main" id="{000A0C73-022E-66FD-B3D5-0313146428AB}"/>
+              </a:ext>
+            </a:extLst>
+          </p:cNvPr>
+          <p:cNvSpPr/>
+          <p:nvPr/>
+        </p:nvSpPr>
+        <p:spPr>
+          <a:xfrm>
+            <a:off x="628650" y="180975"/>
+            <a:ext cx="10610850" cy="6324600"/>
+          </a:xfrm>
+          <a:prstGeom prst="rect">
+            <a:avLst/>
+          </a:prstGeom>
+        </p:spPr>
+        <p:style>
+          <a:lnRef idx="2">
+            <a:schemeClr val="accent1">
+              <a:shade val="15000"/>
+            </a:schemeClr>
+          </a:lnRef>
+          <a:fillRef idx="1">
+            <a:schemeClr val="accent1"/>
+          </a:fillRef>
+          <a:effectRef idx="0">
+            <a:schemeClr val="accent1"/>
+          </a:effectRef>
+          <a:fontRef idx="minor">
+            <a:schemeClr val="lt1"/>
+          </a:fontRef>
+        </p:style>
+        <p:txBody>
+          <a:bodyPr rtlCol="0" anchor="ctr"/>
+          <a:lstStyle/>
+          <a:p>
+            <a:pPr algn="ctr"/>
+            <a:endParaRPr lang="en-US"/>
+          </a:p>
+        </p:txBody>
+      </p:sp>
+      <p:pic>
+        <p:nvPicPr>
+          <p:cNvPr id="4" name="Picture 3">
+            <a:extLst>
+              <a:ext uri="{FF2B5EF4-FFF2-40B4-BE49-F238E27FC236}">
+                <a16:creationId xmlns:a16="http://schemas.microsoft.com/office/drawing/2014/main" id="{E2D1F8EA-E157-4653-0D47-FFAAFD967E19}"/>
+              </a:ext>
+            </a:extLst>
+          </p:cNvPr>
+          <p:cNvPicPr>
+            <a:picLocks noChangeAspect="1"/>
+          </p:cNvPicPr>
+          <p:nvPr/>
+        </p:nvPicPr>
+        <p:blipFill>
+          <a:blip r:embed="rId2"/>
+          <a:stretch>
+            <a:fillRect/>
+          </a:stretch>
+        </p:blipFill>
+        <p:spPr>
+          <a:xfrm>
+            <a:off x="1662290" y="1009867"/>
+            <a:ext cx="8373644" cy="4725058"/>
+          </a:xfrm>
+          <a:prstGeom prst="rect">
+            <a:avLst/>
+          </a:prstGeom>
+        </p:spPr>
+      </p:pic>
+      <p:sp>
+        <p:nvSpPr>
+          <p:cNvPr id="5" name="Isosceles Triangle 4">
+            <a:extLst>
+              <a:ext uri="{FF2B5EF4-FFF2-40B4-BE49-F238E27FC236}">
+                <a16:creationId xmlns:a16="http://schemas.microsoft.com/office/drawing/2014/main" id="{C96F0A28-17CA-0D62-B47B-589B96D37E3C}"/>
+              </a:ext>
+            </a:extLst>
+          </p:cNvPr>
+          <p:cNvSpPr/>
+          <p:nvPr/>
+        </p:nvSpPr>
+        <p:spPr>
+          <a:xfrm rot="10800000">
+            <a:off x="1662290" y="1009864"/>
+            <a:ext cx="8373643" cy="4659813"/>
+          </a:xfrm>
+          <a:prstGeom prst="triangle">
+            <a:avLst>
+              <a:gd name="adj" fmla="val 0"/>
+            </a:avLst>
+          </a:prstGeom>
+          <a:solidFill>
+            <a:schemeClr val="tx1">
+              <a:lumMod val="95000"/>
+              <a:lumOff val="5000"/>
+              <a:alpha val="76000"/>
+            </a:schemeClr>
+          </a:solidFill>
+          <a:ln>
+            <a:noFill/>
+          </a:ln>
+        </p:spPr>
+        <p:style>
+          <a:lnRef idx="2">
+            <a:schemeClr val="accent1">
+              <a:shade val="15000"/>
+            </a:schemeClr>
+          </a:lnRef>
+          <a:fillRef idx="1">
+            <a:schemeClr val="accent1"/>
+          </a:fillRef>
+          <a:effectRef idx="0">
+            <a:schemeClr val="accent1"/>
+          </a:effectRef>
+          <a:fontRef idx="minor">
+            <a:schemeClr val="lt1"/>
+          </a:fontRef>
+        </p:style>
+        <p:txBody>
+          <a:bodyPr rtlCol="0" anchor="ctr"/>
+          <a:lstStyle/>
+          <a:p>
+            <a:pPr algn="ctr"/>
+            <a:endParaRPr lang="en-US"/>
+          </a:p>
+        </p:txBody>
+      </p:sp>
+      <p:pic>
+        <p:nvPicPr>
+          <p:cNvPr id="7" name="Graphic 6" descr="Gears with solid fill">
+            <a:extLst>
+              <a:ext uri="{FF2B5EF4-FFF2-40B4-BE49-F238E27FC236}">
+                <a16:creationId xmlns:a16="http://schemas.microsoft.com/office/drawing/2014/main" id="{23667372-D489-8241-62F7-56C8635EC967}"/>
+              </a:ext>
+            </a:extLst>
+          </p:cNvPr>
+          <p:cNvPicPr>
+            <a:picLocks noChangeAspect="1"/>
+          </p:cNvPicPr>
+          <p:nvPr/>
+        </p:nvPicPr>
+        <p:blipFill>
+          <a:blip r:embed="rId3">
+            <a:extLst>
+              <a:ext uri="{96DAC541-7B7A-43D3-8B79-37D633B846F1}">
+                <asvg:svgBlip xmlns:asvg="http://schemas.microsoft.com/office/drawing/2016/SVG/main" r:embed="rId4"/>
+              </a:ext>
+            </a:extLst>
+          </a:blip>
+          <a:stretch>
+            <a:fillRect/>
+          </a:stretch>
+        </p:blipFill>
+        <p:spPr>
+          <a:xfrm rot="5875852">
+            <a:off x="6581774" y="1038439"/>
+            <a:ext cx="3114675" cy="3114675"/>
+          </a:xfrm>
+          <a:prstGeom prst="rect">
+            <a:avLst/>
+          </a:prstGeom>
+          <a:effectLst>
+            <a:glow rad="1905000">
+              <a:schemeClr val="accent1">
+                <a:alpha val="40000"/>
+              </a:schemeClr>
+            </a:glow>
+            <a:outerShdw blurRad="50800" dist="50800" dir="5400000" algn="ctr" rotWithShape="0">
+              <a:srgbClr val="000000">
+                <a:alpha val="0"/>
+              </a:srgbClr>
+            </a:outerShdw>
+            <a:reflection stA="10000" endPos="65000" dist="50800" dir="5400000" sy="-100000" algn="bl" rotWithShape="0"/>
+          </a:effectLst>
+        </p:spPr>
+      </p:pic>
+      <p:grpSp>
+        <p:nvGrpSpPr>
+          <p:cNvPr id="8" name="Group 7">
+            <a:extLst>
+              <a:ext uri="{FF2B5EF4-FFF2-40B4-BE49-F238E27FC236}">
+                <a16:creationId xmlns:a16="http://schemas.microsoft.com/office/drawing/2014/main" id="{73F2BABF-7AFE-70EB-6C34-F5D80A6E5F0B}"/>
+              </a:ext>
+            </a:extLst>
+          </p:cNvPr>
+          <p:cNvGrpSpPr/>
+          <p:nvPr/>
+        </p:nvGrpSpPr>
+        <p:grpSpPr>
+          <a:xfrm rot="20539069">
+            <a:off x="2138383" y="1853583"/>
+            <a:ext cx="3855979" cy="3150835"/>
+            <a:chOff x="950411" y="2957596"/>
+            <a:chExt cx="3855979" cy="3150835"/>
+          </a:xfrm>
+        </p:grpSpPr>
+        <p:sp>
+          <p:nvSpPr>
+            <p:cNvPr id="9" name="Rectangle: Rounded Corners 8">
+              <a:extLst>
+                <a:ext uri="{FF2B5EF4-FFF2-40B4-BE49-F238E27FC236}">
+                  <a16:creationId xmlns:a16="http://schemas.microsoft.com/office/drawing/2014/main" id="{501C503B-010F-2F7D-80C8-F36C6CC18E8B}"/>
+                </a:ext>
+              </a:extLst>
+            </p:cNvPr>
+            <p:cNvSpPr/>
+            <p:nvPr/>
+          </p:nvSpPr>
+          <p:spPr>
+            <a:xfrm rot="21224836">
+              <a:off x="1658865" y="3393140"/>
+              <a:ext cx="2264945" cy="2279748"/>
+            </a:xfrm>
+            <a:prstGeom prst="roundRect">
+              <a:avLst>
+                <a:gd name="adj" fmla="val 1396"/>
+              </a:avLst>
+            </a:prstGeom>
+            <a:solidFill>
+              <a:schemeClr val="tx1">
+                <a:alpha val="22000"/>
+              </a:schemeClr>
+            </a:solidFill>
+            <a:ln>
+              <a:noFill/>
+            </a:ln>
+            <a:effectLst>
+              <a:glow rad="914400">
+                <a:srgbClr val="1F3351">
+                  <a:alpha val="69000"/>
+                </a:srgbClr>
+              </a:glow>
+              <a:outerShdw blurRad="50800" dist="50800" dir="5400000" algn="ctr" rotWithShape="0">
+                <a:srgbClr val="000000">
+                  <a:alpha val="99000"/>
+                </a:srgbClr>
+              </a:outerShdw>
+            </a:effectLst>
+          </p:spPr>
+          <p:style>
+            <a:lnRef idx="2">
+              <a:schemeClr val="accent1">
+                <a:shade val="15000"/>
+              </a:schemeClr>
+            </a:lnRef>
+            <a:fillRef idx="1">
+              <a:schemeClr val="accent1"/>
+            </a:fillRef>
+            <a:effectRef idx="0">
+              <a:schemeClr val="accent1"/>
+            </a:effectRef>
+            <a:fontRef idx="minor">
+              <a:schemeClr val="lt1"/>
+            </a:fontRef>
+          </p:style>
+          <p:txBody>
+            <a:bodyPr rtlCol="0" anchor="ctr"/>
+            <a:lstStyle/>
+            <a:p>
+              <a:pPr algn="ctr"/>
+              <a:endParaRPr lang="en-US"/>
+            </a:p>
+          </p:txBody>
+        </p:sp>
+        <p:sp>
+          <p:nvSpPr>
+            <p:cNvPr id="10" name="Oval 9">
+              <a:extLst>
+                <a:ext uri="{FF2B5EF4-FFF2-40B4-BE49-F238E27FC236}">
+                  <a16:creationId xmlns:a16="http://schemas.microsoft.com/office/drawing/2014/main" id="{10E9C7A8-1FF8-D575-0709-22D710CD67A6}"/>
+                </a:ext>
+              </a:extLst>
+            </p:cNvPr>
+            <p:cNvSpPr/>
+            <p:nvPr/>
+          </p:nvSpPr>
+          <p:spPr>
+            <a:xfrm rot="21224836">
+              <a:off x="2847234" y="4291368"/>
+              <a:ext cx="148126" cy="151976"/>
+            </a:xfrm>
+            <a:prstGeom prst="ellipse">
+              <a:avLst/>
+            </a:prstGeom>
+            <a:solidFill>
+              <a:srgbClr val="3B4B65"/>
+            </a:solidFill>
+            <a:ln>
+              <a:solidFill>
+                <a:srgbClr val="3B4B65"/>
+              </a:solidFill>
+            </a:ln>
+          </p:spPr>
+          <p:style>
+            <a:lnRef idx="2">
+              <a:schemeClr val="accent1">
+                <a:shade val="15000"/>
+              </a:schemeClr>
+            </a:lnRef>
+            <a:fillRef idx="1">
+              <a:schemeClr val="accent1"/>
+            </a:fillRef>
+            <a:effectRef idx="0">
+              <a:schemeClr val="accent1"/>
+            </a:effectRef>
+            <a:fontRef idx="minor">
+              <a:schemeClr val="lt1"/>
+            </a:fontRef>
+          </p:style>
+          <p:txBody>
+            <a:bodyPr rtlCol="0" anchor="ctr"/>
+            <a:lstStyle/>
+            <a:p>
+              <a:pPr algn="ctr"/>
+              <a:endParaRPr lang="en-US"/>
+            </a:p>
+          </p:txBody>
+        </p:sp>
+        <p:sp>
+          <p:nvSpPr>
+            <p:cNvPr id="11" name="Oval 10">
+              <a:extLst>
+                <a:ext uri="{FF2B5EF4-FFF2-40B4-BE49-F238E27FC236}">
+                  <a16:creationId xmlns:a16="http://schemas.microsoft.com/office/drawing/2014/main" id="{285B4B52-EDAA-0016-33F8-89590EEAD7C3}"/>
+                </a:ext>
+              </a:extLst>
+            </p:cNvPr>
+            <p:cNvSpPr/>
+            <p:nvPr/>
+          </p:nvSpPr>
+          <p:spPr>
+            <a:xfrm rot="21224836">
+              <a:off x="2234545" y="4399498"/>
+              <a:ext cx="75914" cy="77887"/>
+            </a:xfrm>
+            <a:prstGeom prst="ellipse">
+              <a:avLst/>
+            </a:prstGeom>
+            <a:solidFill>
+              <a:srgbClr val="3B4B65"/>
+            </a:solidFill>
+            <a:ln>
+              <a:solidFill>
+                <a:srgbClr val="3B4B65"/>
+              </a:solidFill>
+            </a:ln>
+          </p:spPr>
+          <p:style>
+            <a:lnRef idx="2">
+              <a:schemeClr val="accent1">
+                <a:shade val="15000"/>
+              </a:schemeClr>
+            </a:lnRef>
+            <a:fillRef idx="1">
+              <a:schemeClr val="accent1"/>
+            </a:fillRef>
+            <a:effectRef idx="0">
+              <a:schemeClr val="accent1"/>
+            </a:effectRef>
+            <a:fontRef idx="minor">
+              <a:schemeClr val="lt1"/>
+            </a:fontRef>
+          </p:style>
+          <p:txBody>
+            <a:bodyPr rtlCol="0" anchor="ctr"/>
+            <a:lstStyle/>
+            <a:p>
+              <a:pPr algn="ctr"/>
+              <a:endParaRPr lang="en-US"/>
+            </a:p>
+          </p:txBody>
+        </p:sp>
+        <mc:AlternateContent xmlns:mc="http://schemas.openxmlformats.org/markup-compatibility/2006">
+          <mc:Choice xmlns:p14="http://schemas.microsoft.com/office/powerpoint/2010/main" Requires="p14">
+            <p:contentPart p14:bwMode="auto" r:id="rId5">
+              <p14:nvContentPartPr>
+                <p14:cNvPr id="12" name="Ink 11">
+                  <a:extLst>
+                    <a:ext uri="{FF2B5EF4-FFF2-40B4-BE49-F238E27FC236}">
+                      <a16:creationId xmlns:a16="http://schemas.microsoft.com/office/drawing/2014/main" id="{0FCAF285-6054-3F94-B184-7D40F696CE45}"/>
+                    </a:ext>
+                  </a:extLst>
+                </p14:cNvPr>
+                <p14:cNvContentPartPr/>
+                <p14:nvPr/>
+              </p14:nvContentPartPr>
+              <p14:xfrm rot="5761859">
+                <a:off x="2910758" y="4330824"/>
+                <a:ext cx="62775" cy="68927"/>
+              </p14:xfrm>
+            </p:contentPart>
+          </mc:Choice>
+          <mc:Fallback>
+            <p:pic>
+              <p:nvPicPr>
+                <p:cNvPr id="12" name="Ink 11">
+                  <a:extLst>
+                    <a:ext uri="{FF2B5EF4-FFF2-40B4-BE49-F238E27FC236}">
+                      <a16:creationId xmlns:a16="http://schemas.microsoft.com/office/drawing/2014/main" id="{0FCAF285-6054-3F94-B184-7D40F696CE45}"/>
+                    </a:ext>
+                  </a:extLst>
+                </p:cNvPr>
+                <p:cNvPicPr/>
+                <p:nvPr/>
+              </p:nvPicPr>
+              <p:blipFill>
+                <a:blip r:embed="rId6"/>
+                <a:stretch>
+                  <a:fillRect/>
+                </a:stretch>
+              </p:blipFill>
+              <p:spPr>
+                <a:xfrm rot="5761859">
+                  <a:off x="2901790" y="4321849"/>
+                  <a:ext cx="80352" cy="86518"/>
+                </a:xfrm>
+                <a:prstGeom prst="rect">
+                  <a:avLst/>
+                </a:prstGeom>
+              </p:spPr>
+            </p:pic>
+          </mc:Fallback>
+        </mc:AlternateContent>
+        <p:pic>
+          <p:nvPicPr>
+            <p:cNvPr id="13" name="Picture 12" descr="A blue square with circles and dots&#10;&#10;AI-generated content may be incorrect.">
+              <a:extLst>
+                <a:ext uri="{FF2B5EF4-FFF2-40B4-BE49-F238E27FC236}">
+                  <a16:creationId xmlns:a16="http://schemas.microsoft.com/office/drawing/2014/main" id="{649EA9FC-CE27-166B-A64C-C57B55152D38}"/>
+                </a:ext>
+              </a:extLst>
+            </p:cNvPr>
+            <p:cNvPicPr>
+              <a:picLocks noChangeAspect="1"/>
+            </p:cNvPicPr>
+            <p:nvPr/>
+          </p:nvPicPr>
+          <p:blipFill>
+            <a:blip r:embed="rId7">
+              <a:extLst>
+                <a:ext uri="{28A0092B-C50C-407E-A947-70E740481C1C}">
+                  <a14:useLocalDpi xmlns:a14="http://schemas.microsoft.com/office/drawing/2010/main" val="0"/>
+                </a:ext>
+              </a:extLst>
+            </a:blip>
+            <a:stretch>
+              <a:fillRect/>
+            </a:stretch>
+          </p:blipFill>
+          <p:spPr>
+            <a:xfrm rot="21224836">
+              <a:off x="950411" y="2957596"/>
+              <a:ext cx="3855979" cy="3150835"/>
+            </a:xfrm>
+            <a:prstGeom prst="rect">
+              <a:avLst/>
+            </a:prstGeom>
+            <a:effectLst>
+              <a:glow>
+                <a:schemeClr val="bg1"/>
+              </a:glow>
+              <a:outerShdw blurRad="50800" dist="50800" dir="5400000" algn="ctr" rotWithShape="0">
+                <a:srgbClr val="000000">
+                  <a:alpha val="92000"/>
+                </a:srgbClr>
+              </a:outerShdw>
+              <a:reflection stA="0" endPos="65000" dist="50800" dir="5400000" sy="-100000" algn="bl" rotWithShape="0"/>
+            </a:effectLst>
+          </p:spPr>
+        </p:pic>
+      </p:grpSp>
+      <p:pic>
+        <p:nvPicPr>
+          <p:cNvPr id="2050" name="Picture 2">
+            <a:extLst>
+              <a:ext uri="{FF2B5EF4-FFF2-40B4-BE49-F238E27FC236}">
+                <a16:creationId xmlns:a16="http://schemas.microsoft.com/office/drawing/2014/main" id="{43B4C881-AC01-2177-B299-301ED0B581BB}"/>
+              </a:ext>
+            </a:extLst>
+          </p:cNvPr>
+          <p:cNvPicPr>
+            <a:picLocks noChangeAspect="1" noChangeArrowheads="1"/>
+          </p:cNvPicPr>
+          <p:nvPr/>
+        </p:nvPicPr>
+        <p:blipFill>
+          <a:blip r:embed="rId8">
+            <a:extLst>
+              <a:ext uri="{28A0092B-C50C-407E-A947-70E740481C1C}">
+                <a14:useLocalDpi xmlns:a14="http://schemas.microsoft.com/office/drawing/2010/main" val="0"/>
+              </a:ext>
+            </a:extLst>
+          </a:blip>
+          <a:srcRect/>
+          <a:stretch>
+            <a:fillRect/>
+          </a:stretch>
+        </p:blipFill>
+        <p:spPr bwMode="auto">
+          <a:xfrm rot="21038034">
+            <a:off x="3264472" y="3904057"/>
+            <a:ext cx="5419725" cy="1333500"/>
+          </a:xfrm>
+          <a:prstGeom prst="rect">
+            <a:avLst/>
+          </a:prstGeom>
+          <a:noFill/>
+          <a:effectLst>
+            <a:glow rad="1244600">
+              <a:srgbClr val="FFFFFF">
+                <a:alpha val="40000"/>
+              </a:srgbClr>
+            </a:glow>
+            <a:outerShdw blurRad="50800" dist="50800" dir="5400000" algn="ctr" rotWithShape="0">
+              <a:srgbClr val="000000">
+                <a:alpha val="15000"/>
+              </a:srgbClr>
+            </a:outerShdw>
+            <a:reflection stA="36000" endPos="65000" dist="50800" dir="5400000" sy="-100000" algn="bl" rotWithShape="0"/>
+          </a:effectLst>
+          <a:extLst>
+            <a:ext uri="{909E8E84-426E-40DD-AFC4-6F175D3DCCD1}">
+              <a14:hiddenFill xmlns:a14="http://schemas.microsoft.com/office/drawing/2010/main">
+                <a:solidFill>
+                  <a:srgbClr val="FFFFFF"/>
+                </a:solidFill>
+              </a14:hiddenFill>
+            </a:ext>
+          </a:extLst>
+        </p:spPr>
+      </p:pic>
+      <p:sp>
+        <p:nvSpPr>
+          <p:cNvPr id="14" name="Rectangle 13">
+            <a:extLst>
+              <a:ext uri="{FF2B5EF4-FFF2-40B4-BE49-F238E27FC236}">
+                <a16:creationId xmlns:a16="http://schemas.microsoft.com/office/drawing/2014/main" id="{A417216B-0ECE-747E-9B62-5810646A1F6B}"/>
+              </a:ext>
+            </a:extLst>
+          </p:cNvPr>
+          <p:cNvSpPr/>
+          <p:nvPr/>
+        </p:nvSpPr>
+        <p:spPr>
+          <a:xfrm>
+            <a:off x="1662288" y="1021197"/>
+            <a:ext cx="8373643" cy="4648482"/>
+          </a:xfrm>
+          <a:prstGeom prst="rect">
+            <a:avLst/>
+          </a:prstGeom>
+          <a:noFill/>
+          <a:ln w="76200">
+            <a:solidFill>
+              <a:srgbClr val="FFFFFF"/>
+            </a:solidFill>
+          </a:ln>
+        </p:spPr>
+        <p:style>
+          <a:lnRef idx="2">
+            <a:schemeClr val="accent1">
+              <a:shade val="15000"/>
+            </a:schemeClr>
+          </a:lnRef>
+          <a:fillRef idx="1">
+            <a:schemeClr val="accent1"/>
+          </a:fillRef>
+          <a:effectRef idx="0">
+            <a:schemeClr val="accent1"/>
+          </a:effectRef>
+          <a:fontRef idx="minor">
+            <a:schemeClr val="lt1"/>
+          </a:fontRef>
+        </p:style>
+        <p:txBody>
+          <a:bodyPr rtlCol="0" anchor="ctr"/>
+          <a:lstStyle/>
+          <a:p>
+            <a:pPr algn="ctr"/>
+            <a:endParaRPr lang="en-US"/>
+          </a:p>
+        </p:txBody>
+      </p:sp>
+      <p:pic>
+        <p:nvPicPr>
+          <p:cNvPr id="2052" name="Picture 4">
+            <a:extLst>
+              <a:ext uri="{FF2B5EF4-FFF2-40B4-BE49-F238E27FC236}">
+                <a16:creationId xmlns:a16="http://schemas.microsoft.com/office/drawing/2014/main" id="{9E50C927-8ADA-E212-A6FD-788497773F54}"/>
+              </a:ext>
+            </a:extLst>
+          </p:cNvPr>
+          <p:cNvPicPr>
+            <a:picLocks noChangeAspect="1" noChangeArrowheads="1"/>
+          </p:cNvPicPr>
+          <p:nvPr/>
+        </p:nvPicPr>
+        <p:blipFill>
+          <a:blip r:embed="rId9">
+            <a:extLst>
+              <a:ext uri="{28A0092B-C50C-407E-A947-70E740481C1C}">
+                <a14:useLocalDpi xmlns:a14="http://schemas.microsoft.com/office/drawing/2010/main" val="0"/>
+              </a:ext>
+            </a:extLst>
+          </a:blip>
+          <a:srcRect/>
+          <a:stretch>
+            <a:fillRect/>
+          </a:stretch>
+        </p:blipFill>
+        <p:spPr bwMode="auto">
+          <a:xfrm>
+            <a:off x="7501351" y="4335362"/>
+            <a:ext cx="1619250" cy="1333500"/>
+          </a:xfrm>
+          <a:prstGeom prst="rect">
+            <a:avLst/>
+          </a:prstGeom>
+          <a:noFill/>
+          <a:extLst>
+            <a:ext uri="{909E8E84-426E-40DD-AFC4-6F175D3DCCD1}">
+              <a14:hiddenFill xmlns:a14="http://schemas.microsoft.com/office/drawing/2010/main">
+                <a:solidFill>
+                  <a:srgbClr val="FFFFFF"/>
+                </a:solidFill>
+              </a14:hiddenFill>
+            </a:ext>
+          </a:extLst>
+        </p:spPr>
+      </p:pic>
+    </p:spTree>
+    <p:extLst>
+      <p:ext uri="{BB962C8B-B14F-4D97-AF65-F5344CB8AC3E}">
+        <p14:creationId xmlns:p14="http://schemas.microsoft.com/office/powerpoint/2010/main" val="1551014298"/>
+      </p:ext>
+    </p:extLst>
+  </p:cSld>
+  <p:clrMapOvr>
+    <a:masterClrMapping/>
+  </p:clrMapOvr>
+</p:sld>
+</file>
+
+<file path=ppt/slides/slide7.xml><?xml version="1.0" encoding="utf-8"?>
+<p:sld xmlns:a="http://schemas.openxmlformats.org/drawingml/2006/main" xmlns:r="http://schemas.openxmlformats.org/officeDocument/2006/relationships" xmlns:p="http://schemas.openxmlformats.org/presentationml/2006/main">
+  <p:cSld>
+    <p:spTree>
+      <p:nvGrpSpPr>
+        <p:cNvPr id="1" name="">
+          <a:extLst>
+            <a:ext uri="{FF2B5EF4-FFF2-40B4-BE49-F238E27FC236}">
+              <a16:creationId xmlns:a16="http://schemas.microsoft.com/office/drawing/2014/main" id="{1EECDA40-7C46-2BA1-BF5A-9D8681A7EB9C}"/>
+            </a:ext>
+          </a:extLst>
+        </p:cNvPr>
+        <p:cNvGrpSpPr/>
+        <p:nvPr/>
+      </p:nvGrpSpPr>
+      <p:grpSpPr>
+        <a:xfrm>
+          <a:off x="0" y="0"/>
+          <a:ext cx="0" cy="0"/>
+          <a:chOff x="0" y="0"/>
+          <a:chExt cx="0" cy="0"/>
+        </a:xfrm>
+      </p:grpSpPr>
+      <p:pic>
+        <p:nvPicPr>
+          <p:cNvPr id="7" name="Picture 6">
+            <a:extLst>
+              <a:ext uri="{FF2B5EF4-FFF2-40B4-BE49-F238E27FC236}">
+                <a16:creationId xmlns:a16="http://schemas.microsoft.com/office/drawing/2014/main" id="{140C2001-E0BB-8019-CBEF-853F78F0E70F}"/>
+              </a:ext>
+            </a:extLst>
+          </p:cNvPr>
+          <p:cNvPicPr>
+            <a:picLocks noChangeAspect="1"/>
+          </p:cNvPicPr>
+          <p:nvPr/>
+        </p:nvPicPr>
+        <p:blipFill>
+          <a:blip r:embed="rId2"/>
+          <a:stretch>
+            <a:fillRect/>
+          </a:stretch>
+        </p:blipFill>
+        <p:spPr>
+          <a:xfrm>
+            <a:off x="1662290" y="1009866"/>
+            <a:ext cx="8373644" cy="4725059"/>
+          </a:xfrm>
+          <a:prstGeom prst="rect">
+            <a:avLst/>
+          </a:prstGeom>
+        </p:spPr>
+      </p:pic>
+      <p:sp>
+        <p:nvSpPr>
+          <p:cNvPr id="10" name="Rectangle: Rounded Corners 9">
+            <a:extLst>
+              <a:ext uri="{FF2B5EF4-FFF2-40B4-BE49-F238E27FC236}">
+                <a16:creationId xmlns:a16="http://schemas.microsoft.com/office/drawing/2014/main" id="{9CEDBDB2-BA68-AFEF-E856-914E1157277E}"/>
+              </a:ext>
+            </a:extLst>
+          </p:cNvPr>
+          <p:cNvSpPr/>
+          <p:nvPr/>
+        </p:nvSpPr>
+        <p:spPr>
+          <a:xfrm>
+            <a:off x="5275303" y="1776484"/>
+            <a:ext cx="8996473" cy="5081516"/>
+          </a:xfrm>
+          <a:prstGeom prst="roundRect">
+            <a:avLst>
+              <a:gd name="adj" fmla="val 3570"/>
+            </a:avLst>
+          </a:prstGeom>
+          <a:blipFill dpi="0" rotWithShape="1">
+            <a:blip r:embed="rId3">
+              <a:alphaModFix amt="24000"/>
+            </a:blip>
+            <a:srcRect/>
+            <a:stretch>
+              <a:fillRect/>
+            </a:stretch>
+          </a:blipFill>
+          <a:ln>
+            <a:noFill/>
+          </a:ln>
+        </p:spPr>
+        <p:style>
+          <a:lnRef idx="2">
+            <a:schemeClr val="accent1">
+              <a:shade val="15000"/>
+            </a:schemeClr>
+          </a:lnRef>
+          <a:fillRef idx="1">
+            <a:schemeClr val="accent1"/>
+          </a:fillRef>
+          <a:effectRef idx="0">
+            <a:schemeClr val="accent1"/>
+          </a:effectRef>
+          <a:fontRef idx="minor">
+            <a:schemeClr val="lt1"/>
+          </a:fontRef>
+        </p:style>
+        <p:txBody>
+          <a:bodyPr rtlCol="0" anchor="ctr"/>
+          <a:lstStyle/>
+          <a:p>
+            <a:pPr algn="ctr"/>
+            <a:endParaRPr lang="en-US"/>
+          </a:p>
+        </p:txBody>
+      </p:sp>
+      <p:sp>
+        <p:nvSpPr>
+          <p:cNvPr id="8" name="Rectangle 122">
+            <a:extLst>
+              <a:ext uri="{FF2B5EF4-FFF2-40B4-BE49-F238E27FC236}">
+                <a16:creationId xmlns:a16="http://schemas.microsoft.com/office/drawing/2014/main" id="{8F3DDB53-F852-3436-48DC-7FFD0E442659}"/>
+              </a:ext>
+            </a:extLst>
+          </p:cNvPr>
+          <p:cNvSpPr/>
+          <p:nvPr/>
+        </p:nvSpPr>
+        <p:spPr>
+          <a:xfrm rot="16200000">
+            <a:off x="4589134" y="-204067"/>
+            <a:ext cx="2292639" cy="9542801"/>
+          </a:xfrm>
+          <a:custGeom>
+            <a:avLst/>
+            <a:gdLst>
+              <a:gd name="connsiteX0" fmla="*/ 0 w 2734279"/>
+              <a:gd name="connsiteY0" fmla="*/ 0 h 3245793"/>
+              <a:gd name="connsiteX1" fmla="*/ 2734279 w 2734279"/>
+              <a:gd name="connsiteY1" fmla="*/ 0 h 3245793"/>
+              <a:gd name="connsiteX2" fmla="*/ 2734279 w 2734279"/>
+              <a:gd name="connsiteY2" fmla="*/ 3245793 h 3245793"/>
+              <a:gd name="connsiteX3" fmla="*/ 0 w 2734279"/>
+              <a:gd name="connsiteY3" fmla="*/ 3245793 h 3245793"/>
+              <a:gd name="connsiteX4" fmla="*/ 0 w 2734279"/>
+              <a:gd name="connsiteY4" fmla="*/ 0 h 3245793"/>
+              <a:gd name="connsiteX0" fmla="*/ 0 w 2734279"/>
+              <a:gd name="connsiteY0" fmla="*/ 0 h 3245793"/>
+              <a:gd name="connsiteX1" fmla="*/ 2734279 w 2734279"/>
+              <a:gd name="connsiteY1" fmla="*/ 0 h 3245793"/>
+              <a:gd name="connsiteX2" fmla="*/ 1897782 w 2734279"/>
+              <a:gd name="connsiteY2" fmla="*/ 1017778 h 3245793"/>
+              <a:gd name="connsiteX3" fmla="*/ 2734279 w 2734279"/>
+              <a:gd name="connsiteY3" fmla="*/ 3245793 h 3245793"/>
+              <a:gd name="connsiteX4" fmla="*/ 0 w 2734279"/>
+              <a:gd name="connsiteY4" fmla="*/ 3245793 h 3245793"/>
+              <a:gd name="connsiteX5" fmla="*/ 0 w 2734279"/>
+              <a:gd name="connsiteY5" fmla="*/ 0 h 3245793"/>
+              <a:gd name="connsiteX0" fmla="*/ 0 w 2734279"/>
+              <a:gd name="connsiteY0" fmla="*/ 0 h 3245793"/>
+              <a:gd name="connsiteX1" fmla="*/ 2734279 w 2734279"/>
+              <a:gd name="connsiteY1" fmla="*/ 0 h 3245793"/>
+              <a:gd name="connsiteX2" fmla="*/ 1897782 w 2734279"/>
+              <a:gd name="connsiteY2" fmla="*/ 1017778 h 3245793"/>
+              <a:gd name="connsiteX3" fmla="*/ 2734279 w 2734279"/>
+              <a:gd name="connsiteY3" fmla="*/ 3245793 h 3245793"/>
+              <a:gd name="connsiteX4" fmla="*/ 0 w 2734279"/>
+              <a:gd name="connsiteY4" fmla="*/ 3245793 h 3245793"/>
+              <a:gd name="connsiteX5" fmla="*/ 0 w 2734279"/>
+              <a:gd name="connsiteY5" fmla="*/ 0 h 3245793"/>
+              <a:gd name="connsiteX0" fmla="*/ 0 w 3121495"/>
+              <a:gd name="connsiteY0" fmla="*/ 0 h 3245793"/>
+              <a:gd name="connsiteX1" fmla="*/ 2734279 w 3121495"/>
+              <a:gd name="connsiteY1" fmla="*/ 0 h 3245793"/>
+              <a:gd name="connsiteX2" fmla="*/ 1897782 w 3121495"/>
+              <a:gd name="connsiteY2" fmla="*/ 1017778 h 3245793"/>
+              <a:gd name="connsiteX3" fmla="*/ 3056022 w 3121495"/>
+              <a:gd name="connsiteY3" fmla="*/ 1764538 h 3245793"/>
+              <a:gd name="connsiteX4" fmla="*/ 2734279 w 3121495"/>
+              <a:gd name="connsiteY4" fmla="*/ 3245793 h 3245793"/>
+              <a:gd name="connsiteX5" fmla="*/ 0 w 3121495"/>
+              <a:gd name="connsiteY5" fmla="*/ 3245793 h 3245793"/>
+              <a:gd name="connsiteX6" fmla="*/ 0 w 3121495"/>
+              <a:gd name="connsiteY6" fmla="*/ 0 h 3245793"/>
+              <a:gd name="connsiteX0" fmla="*/ 0 w 3094349"/>
+              <a:gd name="connsiteY0" fmla="*/ 0 h 3245793"/>
+              <a:gd name="connsiteX1" fmla="*/ 2734279 w 3094349"/>
+              <a:gd name="connsiteY1" fmla="*/ 0 h 3245793"/>
+              <a:gd name="connsiteX2" fmla="*/ 1897782 w 3094349"/>
+              <a:gd name="connsiteY2" fmla="*/ 1017778 h 3245793"/>
+              <a:gd name="connsiteX3" fmla="*/ 3056022 w 3094349"/>
+              <a:gd name="connsiteY3" fmla="*/ 1764538 h 3245793"/>
+              <a:gd name="connsiteX4" fmla="*/ 2553102 w 3094349"/>
+              <a:gd name="connsiteY4" fmla="*/ 2465578 h 3245793"/>
+              <a:gd name="connsiteX5" fmla="*/ 2734279 w 3094349"/>
+              <a:gd name="connsiteY5" fmla="*/ 3245793 h 3245793"/>
+              <a:gd name="connsiteX6" fmla="*/ 0 w 3094349"/>
+              <a:gd name="connsiteY6" fmla="*/ 3245793 h 3245793"/>
+              <a:gd name="connsiteX7" fmla="*/ 0 w 3094349"/>
+              <a:gd name="connsiteY7" fmla="*/ 0 h 3245793"/>
+              <a:gd name="connsiteX0" fmla="*/ 0 w 2916671"/>
+              <a:gd name="connsiteY0" fmla="*/ 0 h 3245793"/>
+              <a:gd name="connsiteX1" fmla="*/ 2734279 w 2916671"/>
+              <a:gd name="connsiteY1" fmla="*/ 0 h 3245793"/>
+              <a:gd name="connsiteX2" fmla="*/ 1897782 w 2916671"/>
+              <a:gd name="connsiteY2" fmla="*/ 1017778 h 3245793"/>
+              <a:gd name="connsiteX3" fmla="*/ 2682642 w 2916671"/>
+              <a:gd name="connsiteY3" fmla="*/ 1855978 h 3245793"/>
+              <a:gd name="connsiteX4" fmla="*/ 2553102 w 2916671"/>
+              <a:gd name="connsiteY4" fmla="*/ 2465578 h 3245793"/>
+              <a:gd name="connsiteX5" fmla="*/ 2734279 w 2916671"/>
+              <a:gd name="connsiteY5" fmla="*/ 3245793 h 3245793"/>
+              <a:gd name="connsiteX6" fmla="*/ 0 w 2916671"/>
+              <a:gd name="connsiteY6" fmla="*/ 3245793 h 3245793"/>
+              <a:gd name="connsiteX7" fmla="*/ 0 w 2916671"/>
+              <a:gd name="connsiteY7" fmla="*/ 0 h 3245793"/>
+              <a:gd name="connsiteX0" fmla="*/ 0 w 3436755"/>
+              <a:gd name="connsiteY0" fmla="*/ 0 h 3254582"/>
+              <a:gd name="connsiteX1" fmla="*/ 2734279 w 3436755"/>
+              <a:gd name="connsiteY1" fmla="*/ 0 h 3254582"/>
+              <a:gd name="connsiteX2" fmla="*/ 1897782 w 3436755"/>
+              <a:gd name="connsiteY2" fmla="*/ 1017778 h 3254582"/>
+              <a:gd name="connsiteX3" fmla="*/ 2682642 w 3436755"/>
+              <a:gd name="connsiteY3" fmla="*/ 1855978 h 3254582"/>
+              <a:gd name="connsiteX4" fmla="*/ 2553102 w 3436755"/>
+              <a:gd name="connsiteY4" fmla="*/ 2465578 h 3254582"/>
+              <a:gd name="connsiteX5" fmla="*/ 3305105 w 3436755"/>
+              <a:gd name="connsiteY5" fmla="*/ 3254582 h 3254582"/>
+              <a:gd name="connsiteX6" fmla="*/ 0 w 3436755"/>
+              <a:gd name="connsiteY6" fmla="*/ 3245793 h 3254582"/>
+              <a:gd name="connsiteX7" fmla="*/ 0 w 3436755"/>
+              <a:gd name="connsiteY7" fmla="*/ 0 h 3254582"/>
+              <a:gd name="connsiteX0" fmla="*/ 0 w 3432826"/>
+              <a:gd name="connsiteY0" fmla="*/ 0 h 3254582"/>
+              <a:gd name="connsiteX1" fmla="*/ 2734279 w 3432826"/>
+              <a:gd name="connsiteY1" fmla="*/ 0 h 3254582"/>
+              <a:gd name="connsiteX2" fmla="*/ 1897782 w 3432826"/>
+              <a:gd name="connsiteY2" fmla="*/ 1017778 h 3254582"/>
+              <a:gd name="connsiteX3" fmla="*/ 2986272 w 3432826"/>
+              <a:gd name="connsiteY3" fmla="*/ 1803246 h 3254582"/>
+              <a:gd name="connsiteX4" fmla="*/ 2553102 w 3432826"/>
+              <a:gd name="connsiteY4" fmla="*/ 2465578 h 3254582"/>
+              <a:gd name="connsiteX5" fmla="*/ 3305105 w 3432826"/>
+              <a:gd name="connsiteY5" fmla="*/ 3254582 h 3254582"/>
+              <a:gd name="connsiteX6" fmla="*/ 0 w 3432826"/>
+              <a:gd name="connsiteY6" fmla="*/ 3245793 h 3254582"/>
+              <a:gd name="connsiteX7" fmla="*/ 0 w 3432826"/>
+              <a:gd name="connsiteY7" fmla="*/ 0 h 3254582"/>
+              <a:gd name="connsiteX0" fmla="*/ 0 w 3646164"/>
+              <a:gd name="connsiteY0" fmla="*/ 0 h 3275822"/>
+              <a:gd name="connsiteX1" fmla="*/ 2734279 w 3646164"/>
+              <a:gd name="connsiteY1" fmla="*/ 0 h 3275822"/>
+              <a:gd name="connsiteX2" fmla="*/ 1897782 w 3646164"/>
+              <a:gd name="connsiteY2" fmla="*/ 1017778 h 3275822"/>
+              <a:gd name="connsiteX3" fmla="*/ 2986272 w 3646164"/>
+              <a:gd name="connsiteY3" fmla="*/ 1803246 h 3275822"/>
+              <a:gd name="connsiteX4" fmla="*/ 2553102 w 3646164"/>
+              <a:gd name="connsiteY4" fmla="*/ 2465578 h 3275822"/>
+              <a:gd name="connsiteX5" fmla="*/ 3460548 w 3646164"/>
+              <a:gd name="connsiteY5" fmla="*/ 3205784 h 3275822"/>
+              <a:gd name="connsiteX6" fmla="*/ 3305105 w 3646164"/>
+              <a:gd name="connsiteY6" fmla="*/ 3254582 h 3275822"/>
+              <a:gd name="connsiteX7" fmla="*/ 0 w 3646164"/>
+              <a:gd name="connsiteY7" fmla="*/ 3245793 h 3275822"/>
+              <a:gd name="connsiteX8" fmla="*/ 0 w 3646164"/>
+              <a:gd name="connsiteY8" fmla="*/ 0 h 3275822"/>
+              <a:gd name="connsiteX0" fmla="*/ 0 w 3573838"/>
+              <a:gd name="connsiteY0" fmla="*/ 0 h 3290379"/>
+              <a:gd name="connsiteX1" fmla="*/ 2734279 w 3573838"/>
+              <a:gd name="connsiteY1" fmla="*/ 0 h 3290379"/>
+              <a:gd name="connsiteX2" fmla="*/ 1897782 w 3573838"/>
+              <a:gd name="connsiteY2" fmla="*/ 1017778 h 3290379"/>
+              <a:gd name="connsiteX3" fmla="*/ 2986272 w 3573838"/>
+              <a:gd name="connsiteY3" fmla="*/ 1803246 h 3290379"/>
+              <a:gd name="connsiteX4" fmla="*/ 2553102 w 3573838"/>
+              <a:gd name="connsiteY4" fmla="*/ 2465578 h 3290379"/>
+              <a:gd name="connsiteX5" fmla="*/ 3254080 w 3573838"/>
+              <a:gd name="connsiteY5" fmla="*/ 3227756 h 3290379"/>
+              <a:gd name="connsiteX6" fmla="*/ 3305105 w 3573838"/>
+              <a:gd name="connsiteY6" fmla="*/ 3254582 h 3290379"/>
+              <a:gd name="connsiteX7" fmla="*/ 0 w 3573838"/>
+              <a:gd name="connsiteY7" fmla="*/ 3245793 h 3290379"/>
+              <a:gd name="connsiteX8" fmla="*/ 0 w 3573838"/>
+              <a:gd name="connsiteY8" fmla="*/ 0 h 3290379"/>
+              <a:gd name="connsiteX0" fmla="*/ 0 w 3561349"/>
+              <a:gd name="connsiteY0" fmla="*/ 0 h 3260738"/>
+              <a:gd name="connsiteX1" fmla="*/ 2734279 w 3561349"/>
+              <a:gd name="connsiteY1" fmla="*/ 0 h 3260738"/>
+              <a:gd name="connsiteX2" fmla="*/ 1897782 w 3561349"/>
+              <a:gd name="connsiteY2" fmla="*/ 1017778 h 3260738"/>
+              <a:gd name="connsiteX3" fmla="*/ 2986272 w 3561349"/>
+              <a:gd name="connsiteY3" fmla="*/ 1803246 h 3260738"/>
+              <a:gd name="connsiteX4" fmla="*/ 2553102 w 3561349"/>
+              <a:gd name="connsiteY4" fmla="*/ 2465578 h 3260738"/>
+              <a:gd name="connsiteX5" fmla="*/ 2950449 w 3561349"/>
+              <a:gd name="connsiteY5" fmla="*/ 2854229 h 3260738"/>
+              <a:gd name="connsiteX6" fmla="*/ 3254080 w 3561349"/>
+              <a:gd name="connsiteY6" fmla="*/ 3227756 h 3260738"/>
+              <a:gd name="connsiteX7" fmla="*/ 3305105 w 3561349"/>
+              <a:gd name="connsiteY7" fmla="*/ 3254582 h 3260738"/>
+              <a:gd name="connsiteX8" fmla="*/ 0 w 3561349"/>
+              <a:gd name="connsiteY8" fmla="*/ 3245793 h 3260738"/>
+              <a:gd name="connsiteX9" fmla="*/ 0 w 3561349"/>
+              <a:gd name="connsiteY9" fmla="*/ 0 h 3260738"/>
+              <a:gd name="connsiteX0" fmla="*/ 0 w 3466950"/>
+              <a:gd name="connsiteY0" fmla="*/ 0 h 3263749"/>
+              <a:gd name="connsiteX1" fmla="*/ 2734279 w 3466950"/>
+              <a:gd name="connsiteY1" fmla="*/ 0 h 3263749"/>
+              <a:gd name="connsiteX2" fmla="*/ 1897782 w 3466950"/>
+              <a:gd name="connsiteY2" fmla="*/ 1017778 h 3263749"/>
+              <a:gd name="connsiteX3" fmla="*/ 2986272 w 3466950"/>
+              <a:gd name="connsiteY3" fmla="*/ 1803246 h 3263749"/>
+              <a:gd name="connsiteX4" fmla="*/ 2553102 w 3466950"/>
+              <a:gd name="connsiteY4" fmla="*/ 2465578 h 3263749"/>
+              <a:gd name="connsiteX5" fmla="*/ 2950449 w 3466950"/>
+              <a:gd name="connsiteY5" fmla="*/ 2854229 h 3263749"/>
+              <a:gd name="connsiteX6" fmla="*/ 3254080 w 3466950"/>
+              <a:gd name="connsiteY6" fmla="*/ 3227756 h 3263749"/>
+              <a:gd name="connsiteX7" fmla="*/ 3305105 w 3466950"/>
+              <a:gd name="connsiteY7" fmla="*/ 3254582 h 3263749"/>
+              <a:gd name="connsiteX8" fmla="*/ 1104378 w 3466950"/>
+              <a:gd name="connsiteY8" fmla="*/ 3254123 h 3263749"/>
+              <a:gd name="connsiteX9" fmla="*/ 0 w 3466950"/>
+              <a:gd name="connsiteY9" fmla="*/ 3245793 h 3263749"/>
+              <a:gd name="connsiteX10" fmla="*/ 0 w 3466950"/>
+              <a:gd name="connsiteY10" fmla="*/ 0 h 3263749"/>
+              <a:gd name="connsiteX0" fmla="*/ 0 w 3466950"/>
+              <a:gd name="connsiteY0" fmla="*/ 2172 h 3265921"/>
+              <a:gd name="connsiteX1" fmla="*/ 1043653 w 3466950"/>
+              <a:gd name="connsiteY1" fmla="*/ 0 h 3265921"/>
+              <a:gd name="connsiteX2" fmla="*/ 2734279 w 3466950"/>
+              <a:gd name="connsiteY2" fmla="*/ 2172 h 3265921"/>
+              <a:gd name="connsiteX3" fmla="*/ 1897782 w 3466950"/>
+              <a:gd name="connsiteY3" fmla="*/ 1019950 h 3265921"/>
+              <a:gd name="connsiteX4" fmla="*/ 2986272 w 3466950"/>
+              <a:gd name="connsiteY4" fmla="*/ 1805418 h 3265921"/>
+              <a:gd name="connsiteX5" fmla="*/ 2553102 w 3466950"/>
+              <a:gd name="connsiteY5" fmla="*/ 2467750 h 3265921"/>
+              <a:gd name="connsiteX6" fmla="*/ 2950449 w 3466950"/>
+              <a:gd name="connsiteY6" fmla="*/ 2856401 h 3265921"/>
+              <a:gd name="connsiteX7" fmla="*/ 3254080 w 3466950"/>
+              <a:gd name="connsiteY7" fmla="*/ 3229928 h 3265921"/>
+              <a:gd name="connsiteX8" fmla="*/ 3305105 w 3466950"/>
+              <a:gd name="connsiteY8" fmla="*/ 3256754 h 3265921"/>
+              <a:gd name="connsiteX9" fmla="*/ 1104378 w 3466950"/>
+              <a:gd name="connsiteY9" fmla="*/ 3256295 h 3265921"/>
+              <a:gd name="connsiteX10" fmla="*/ 0 w 3466950"/>
+              <a:gd name="connsiteY10" fmla="*/ 3247965 h 3265921"/>
+              <a:gd name="connsiteX11" fmla="*/ 0 w 3466950"/>
+              <a:gd name="connsiteY11" fmla="*/ 2172 h 3265921"/>
+              <a:gd name="connsiteX0" fmla="*/ 0 w 3466950"/>
+              <a:gd name="connsiteY0" fmla="*/ 3247965 h 3265921"/>
+              <a:gd name="connsiteX1" fmla="*/ 1043653 w 3466950"/>
+              <a:gd name="connsiteY1" fmla="*/ 0 h 3265921"/>
+              <a:gd name="connsiteX2" fmla="*/ 2734279 w 3466950"/>
+              <a:gd name="connsiteY2" fmla="*/ 2172 h 3265921"/>
+              <a:gd name="connsiteX3" fmla="*/ 1897782 w 3466950"/>
+              <a:gd name="connsiteY3" fmla="*/ 1019950 h 3265921"/>
+              <a:gd name="connsiteX4" fmla="*/ 2986272 w 3466950"/>
+              <a:gd name="connsiteY4" fmla="*/ 1805418 h 3265921"/>
+              <a:gd name="connsiteX5" fmla="*/ 2553102 w 3466950"/>
+              <a:gd name="connsiteY5" fmla="*/ 2467750 h 3265921"/>
+              <a:gd name="connsiteX6" fmla="*/ 2950449 w 3466950"/>
+              <a:gd name="connsiteY6" fmla="*/ 2856401 h 3265921"/>
+              <a:gd name="connsiteX7" fmla="*/ 3254080 w 3466950"/>
+              <a:gd name="connsiteY7" fmla="*/ 3229928 h 3265921"/>
+              <a:gd name="connsiteX8" fmla="*/ 3305105 w 3466950"/>
+              <a:gd name="connsiteY8" fmla="*/ 3256754 h 3265921"/>
+              <a:gd name="connsiteX9" fmla="*/ 1104378 w 3466950"/>
+              <a:gd name="connsiteY9" fmla="*/ 3256295 h 3265921"/>
+              <a:gd name="connsiteX10" fmla="*/ 0 w 3466950"/>
+              <a:gd name="connsiteY10" fmla="*/ 3247965 h 3265921"/>
+              <a:gd name="connsiteX0" fmla="*/ 60725 w 2423297"/>
+              <a:gd name="connsiteY0" fmla="*/ 3256295 h 3265921"/>
+              <a:gd name="connsiteX1" fmla="*/ 0 w 2423297"/>
+              <a:gd name="connsiteY1" fmla="*/ 0 h 3265921"/>
+              <a:gd name="connsiteX2" fmla="*/ 1690626 w 2423297"/>
+              <a:gd name="connsiteY2" fmla="*/ 2172 h 3265921"/>
+              <a:gd name="connsiteX3" fmla="*/ 854129 w 2423297"/>
+              <a:gd name="connsiteY3" fmla="*/ 1019950 h 3265921"/>
+              <a:gd name="connsiteX4" fmla="*/ 1942619 w 2423297"/>
+              <a:gd name="connsiteY4" fmla="*/ 1805418 h 3265921"/>
+              <a:gd name="connsiteX5" fmla="*/ 1509449 w 2423297"/>
+              <a:gd name="connsiteY5" fmla="*/ 2467750 h 3265921"/>
+              <a:gd name="connsiteX6" fmla="*/ 1906796 w 2423297"/>
+              <a:gd name="connsiteY6" fmla="*/ 2856401 h 3265921"/>
+              <a:gd name="connsiteX7" fmla="*/ 2210427 w 2423297"/>
+              <a:gd name="connsiteY7" fmla="*/ 3229928 h 3265921"/>
+              <a:gd name="connsiteX8" fmla="*/ 2261452 w 2423297"/>
+              <a:gd name="connsiteY8" fmla="*/ 3256754 h 3265921"/>
+              <a:gd name="connsiteX9" fmla="*/ 60725 w 2423297"/>
+              <a:gd name="connsiteY9" fmla="*/ 3256295 h 3265921"/>
+            </a:gdLst>
+            <a:ahLst/>
+            <a:cxnLst>
+              <a:cxn ang="0">
+                <a:pos x="connsiteX0" y="connsiteY0"/>
+              </a:cxn>
+              <a:cxn ang="0">
+                <a:pos x="connsiteX1" y="connsiteY1"/>
+              </a:cxn>
+              <a:cxn ang="0">
+                <a:pos x="connsiteX2" y="connsiteY2"/>
+              </a:cxn>
+              <a:cxn ang="0">
+                <a:pos x="connsiteX3" y="connsiteY3"/>
+              </a:cxn>
+              <a:cxn ang="0">
+                <a:pos x="connsiteX4" y="connsiteY4"/>
+              </a:cxn>
+              <a:cxn ang="0">
+                <a:pos x="connsiteX5" y="connsiteY5"/>
+              </a:cxn>
+              <a:cxn ang="0">
+                <a:pos x="connsiteX6" y="connsiteY6"/>
+              </a:cxn>
+              <a:cxn ang="0">
+                <a:pos x="connsiteX7" y="connsiteY7"/>
+              </a:cxn>
+              <a:cxn ang="0">
+                <a:pos x="connsiteX8" y="connsiteY8"/>
+              </a:cxn>
+              <a:cxn ang="0">
+                <a:pos x="connsiteX9" y="connsiteY9"/>
+              </a:cxn>
+            </a:cxnLst>
+            <a:rect l="l" t="t" r="r" b="b"/>
+            <a:pathLst>
+              <a:path w="2423297" h="3265921">
+                <a:moveTo>
+                  <a:pt x="60725" y="3256295"/>
+                </a:moveTo>
+                <a:lnTo>
+                  <a:pt x="0" y="0"/>
+                </a:lnTo>
+                <a:lnTo>
+                  <a:pt x="1690626" y="2172"/>
+                </a:lnTo>
+                <a:cubicBezTo>
+                  <a:pt x="1688654" y="270311"/>
+                  <a:pt x="856101" y="751811"/>
+                  <a:pt x="854129" y="1019950"/>
+                </a:cubicBezTo>
+                <a:cubicBezTo>
+                  <a:pt x="787103" y="1429610"/>
+                  <a:pt x="1803203" y="1434082"/>
+                  <a:pt x="1942619" y="1805418"/>
+                </a:cubicBezTo>
+                <a:cubicBezTo>
+                  <a:pt x="2143279" y="2053068"/>
+                  <a:pt x="1515419" y="2292586"/>
+                  <a:pt x="1509449" y="2467750"/>
+                </a:cubicBezTo>
+                <a:cubicBezTo>
+                  <a:pt x="1503479" y="2642914"/>
+                  <a:pt x="1789966" y="2729371"/>
+                  <a:pt x="1906796" y="2856401"/>
+                </a:cubicBezTo>
+                <a:cubicBezTo>
+                  <a:pt x="2023626" y="2983431"/>
+                  <a:pt x="2139172" y="3166132"/>
+                  <a:pt x="2210427" y="3229928"/>
+                </a:cubicBezTo>
+                <a:cubicBezTo>
+                  <a:pt x="2281682" y="3293724"/>
+                  <a:pt x="2619736" y="3252360"/>
+                  <a:pt x="2261452" y="3256754"/>
+                </a:cubicBezTo>
+                <a:lnTo>
+                  <a:pt x="60725" y="3256295"/>
+                </a:lnTo>
+                <a:close/>
+              </a:path>
+            </a:pathLst>
+          </a:custGeom>
+          <a:solidFill>
+            <a:srgbClr val="004483">
+              <a:alpha val="42000"/>
+            </a:srgbClr>
+          </a:solidFill>
+          <a:ln>
+            <a:solidFill>
+              <a:srgbClr val="003457"/>
+            </a:solidFill>
+          </a:ln>
+          <a:effectLst>
+            <a:glow rad="50800">
+              <a:srgbClr val="381C38">
+                <a:alpha val="22000"/>
+              </a:srgbClr>
+            </a:glow>
+            <a:outerShdw blurRad="50800" dist="50800" dir="5400000" algn="ctr" rotWithShape="0">
+              <a:srgbClr val="000000">
+                <a:alpha val="14000"/>
+              </a:srgbClr>
+            </a:outerShdw>
+            <a:softEdge rad="0"/>
+          </a:effectLst>
+        </p:spPr>
+        <p:style>
+          <a:lnRef idx="2">
+            <a:schemeClr val="accent1">
+              <a:shade val="15000"/>
+            </a:schemeClr>
+          </a:lnRef>
+          <a:fillRef idx="1">
+            <a:schemeClr val="accent1"/>
+          </a:fillRef>
+          <a:effectRef idx="0">
+            <a:schemeClr val="accent1"/>
+          </a:effectRef>
+          <a:fontRef idx="minor">
+            <a:schemeClr val="lt1"/>
+          </a:fontRef>
+        </p:style>
+        <p:txBody>
+          <a:bodyPr rtlCol="0" anchor="ctr"/>
+          <a:lstStyle/>
+          <a:p>
+            <a:pPr algn="ctr"/>
+            <a:endParaRPr lang="en-US" noProof="1"/>
+          </a:p>
+        </p:txBody>
+      </p:sp>
+      <p:sp>
+        <p:nvSpPr>
+          <p:cNvPr id="9" name="Rectangle 122">
+            <a:extLst>
+              <a:ext uri="{FF2B5EF4-FFF2-40B4-BE49-F238E27FC236}">
+                <a16:creationId xmlns:a16="http://schemas.microsoft.com/office/drawing/2014/main" id="{FC0D35E9-9730-0C9A-84E7-0E6A7D3AF79D}"/>
+              </a:ext>
+            </a:extLst>
+          </p:cNvPr>
+          <p:cNvSpPr/>
+          <p:nvPr/>
+        </p:nvSpPr>
+        <p:spPr>
+          <a:xfrm rot="16200000" flipV="1">
+            <a:off x="4728790" y="-120058"/>
+            <a:ext cx="2014701" cy="9587139"/>
+          </a:xfrm>
+          <a:custGeom>
+            <a:avLst/>
+            <a:gdLst>
+              <a:gd name="connsiteX0" fmla="*/ 0 w 2734279"/>
+              <a:gd name="connsiteY0" fmla="*/ 0 h 3245793"/>
+              <a:gd name="connsiteX1" fmla="*/ 2734279 w 2734279"/>
+              <a:gd name="connsiteY1" fmla="*/ 0 h 3245793"/>
+              <a:gd name="connsiteX2" fmla="*/ 2734279 w 2734279"/>
+              <a:gd name="connsiteY2" fmla="*/ 3245793 h 3245793"/>
+              <a:gd name="connsiteX3" fmla="*/ 0 w 2734279"/>
+              <a:gd name="connsiteY3" fmla="*/ 3245793 h 3245793"/>
+              <a:gd name="connsiteX4" fmla="*/ 0 w 2734279"/>
+              <a:gd name="connsiteY4" fmla="*/ 0 h 3245793"/>
+              <a:gd name="connsiteX0" fmla="*/ 0 w 2734279"/>
+              <a:gd name="connsiteY0" fmla="*/ 0 h 3245793"/>
+              <a:gd name="connsiteX1" fmla="*/ 2734279 w 2734279"/>
+              <a:gd name="connsiteY1" fmla="*/ 0 h 3245793"/>
+              <a:gd name="connsiteX2" fmla="*/ 1897782 w 2734279"/>
+              <a:gd name="connsiteY2" fmla="*/ 1017778 h 3245793"/>
+              <a:gd name="connsiteX3" fmla="*/ 2734279 w 2734279"/>
+              <a:gd name="connsiteY3" fmla="*/ 3245793 h 3245793"/>
+              <a:gd name="connsiteX4" fmla="*/ 0 w 2734279"/>
+              <a:gd name="connsiteY4" fmla="*/ 3245793 h 3245793"/>
+              <a:gd name="connsiteX5" fmla="*/ 0 w 2734279"/>
+              <a:gd name="connsiteY5" fmla="*/ 0 h 3245793"/>
+              <a:gd name="connsiteX0" fmla="*/ 0 w 2734279"/>
+              <a:gd name="connsiteY0" fmla="*/ 0 h 3245793"/>
+              <a:gd name="connsiteX1" fmla="*/ 2734279 w 2734279"/>
+              <a:gd name="connsiteY1" fmla="*/ 0 h 3245793"/>
+              <a:gd name="connsiteX2" fmla="*/ 1897782 w 2734279"/>
+              <a:gd name="connsiteY2" fmla="*/ 1017778 h 3245793"/>
+              <a:gd name="connsiteX3" fmla="*/ 2734279 w 2734279"/>
+              <a:gd name="connsiteY3" fmla="*/ 3245793 h 3245793"/>
+              <a:gd name="connsiteX4" fmla="*/ 0 w 2734279"/>
+              <a:gd name="connsiteY4" fmla="*/ 3245793 h 3245793"/>
+              <a:gd name="connsiteX5" fmla="*/ 0 w 2734279"/>
+              <a:gd name="connsiteY5" fmla="*/ 0 h 3245793"/>
+              <a:gd name="connsiteX0" fmla="*/ 0 w 3121495"/>
+              <a:gd name="connsiteY0" fmla="*/ 0 h 3245793"/>
+              <a:gd name="connsiteX1" fmla="*/ 2734279 w 3121495"/>
+              <a:gd name="connsiteY1" fmla="*/ 0 h 3245793"/>
+              <a:gd name="connsiteX2" fmla="*/ 1897782 w 3121495"/>
+              <a:gd name="connsiteY2" fmla="*/ 1017778 h 3245793"/>
+              <a:gd name="connsiteX3" fmla="*/ 3056022 w 3121495"/>
+              <a:gd name="connsiteY3" fmla="*/ 1764538 h 3245793"/>
+              <a:gd name="connsiteX4" fmla="*/ 2734279 w 3121495"/>
+              <a:gd name="connsiteY4" fmla="*/ 3245793 h 3245793"/>
+              <a:gd name="connsiteX5" fmla="*/ 0 w 3121495"/>
+              <a:gd name="connsiteY5" fmla="*/ 3245793 h 3245793"/>
+              <a:gd name="connsiteX6" fmla="*/ 0 w 3121495"/>
+              <a:gd name="connsiteY6" fmla="*/ 0 h 3245793"/>
+              <a:gd name="connsiteX0" fmla="*/ 0 w 3094349"/>
+              <a:gd name="connsiteY0" fmla="*/ 0 h 3245793"/>
+              <a:gd name="connsiteX1" fmla="*/ 2734279 w 3094349"/>
+              <a:gd name="connsiteY1" fmla="*/ 0 h 3245793"/>
+              <a:gd name="connsiteX2" fmla="*/ 1897782 w 3094349"/>
+              <a:gd name="connsiteY2" fmla="*/ 1017778 h 3245793"/>
+              <a:gd name="connsiteX3" fmla="*/ 3056022 w 3094349"/>
+              <a:gd name="connsiteY3" fmla="*/ 1764538 h 3245793"/>
+              <a:gd name="connsiteX4" fmla="*/ 2553102 w 3094349"/>
+              <a:gd name="connsiteY4" fmla="*/ 2465578 h 3245793"/>
+              <a:gd name="connsiteX5" fmla="*/ 2734279 w 3094349"/>
+              <a:gd name="connsiteY5" fmla="*/ 3245793 h 3245793"/>
+              <a:gd name="connsiteX6" fmla="*/ 0 w 3094349"/>
+              <a:gd name="connsiteY6" fmla="*/ 3245793 h 3245793"/>
+              <a:gd name="connsiteX7" fmla="*/ 0 w 3094349"/>
+              <a:gd name="connsiteY7" fmla="*/ 0 h 3245793"/>
+              <a:gd name="connsiteX0" fmla="*/ 0 w 2916671"/>
+              <a:gd name="connsiteY0" fmla="*/ 0 h 3245793"/>
+              <a:gd name="connsiteX1" fmla="*/ 2734279 w 2916671"/>
+              <a:gd name="connsiteY1" fmla="*/ 0 h 3245793"/>
+              <a:gd name="connsiteX2" fmla="*/ 1897782 w 2916671"/>
+              <a:gd name="connsiteY2" fmla="*/ 1017778 h 3245793"/>
+              <a:gd name="connsiteX3" fmla="*/ 2682642 w 2916671"/>
+              <a:gd name="connsiteY3" fmla="*/ 1855978 h 3245793"/>
+              <a:gd name="connsiteX4" fmla="*/ 2553102 w 2916671"/>
+              <a:gd name="connsiteY4" fmla="*/ 2465578 h 3245793"/>
+              <a:gd name="connsiteX5" fmla="*/ 2734279 w 2916671"/>
+              <a:gd name="connsiteY5" fmla="*/ 3245793 h 3245793"/>
+              <a:gd name="connsiteX6" fmla="*/ 0 w 2916671"/>
+              <a:gd name="connsiteY6" fmla="*/ 3245793 h 3245793"/>
+              <a:gd name="connsiteX7" fmla="*/ 0 w 2916671"/>
+              <a:gd name="connsiteY7" fmla="*/ 0 h 3245793"/>
+              <a:gd name="connsiteX0" fmla="*/ 0 w 2772357"/>
+              <a:gd name="connsiteY0" fmla="*/ 0 h 3250146"/>
+              <a:gd name="connsiteX1" fmla="*/ 2734279 w 2772357"/>
+              <a:gd name="connsiteY1" fmla="*/ 0 h 3250146"/>
+              <a:gd name="connsiteX2" fmla="*/ 1897782 w 2772357"/>
+              <a:gd name="connsiteY2" fmla="*/ 1017778 h 3250146"/>
+              <a:gd name="connsiteX3" fmla="*/ 2682642 w 2772357"/>
+              <a:gd name="connsiteY3" fmla="*/ 1855978 h 3250146"/>
+              <a:gd name="connsiteX4" fmla="*/ 2553102 w 2772357"/>
+              <a:gd name="connsiteY4" fmla="*/ 2465578 h 3250146"/>
+              <a:gd name="connsiteX5" fmla="*/ 1765046 w 2772357"/>
+              <a:gd name="connsiteY5" fmla="*/ 3250146 h 3250146"/>
+              <a:gd name="connsiteX6" fmla="*/ 0 w 2772357"/>
+              <a:gd name="connsiteY6" fmla="*/ 3245793 h 3250146"/>
+              <a:gd name="connsiteX7" fmla="*/ 0 w 2772357"/>
+              <a:gd name="connsiteY7" fmla="*/ 0 h 3250146"/>
+              <a:gd name="connsiteX0" fmla="*/ 0 w 2734280"/>
+              <a:gd name="connsiteY0" fmla="*/ 0 h 3250146"/>
+              <a:gd name="connsiteX1" fmla="*/ 2734279 w 2734280"/>
+              <a:gd name="connsiteY1" fmla="*/ 0 h 3250146"/>
+              <a:gd name="connsiteX2" fmla="*/ 1897782 w 2734280"/>
+              <a:gd name="connsiteY2" fmla="*/ 1017778 h 3250146"/>
+              <a:gd name="connsiteX3" fmla="*/ 2682642 w 2734280"/>
+              <a:gd name="connsiteY3" fmla="*/ 1855978 h 3250146"/>
+              <a:gd name="connsiteX4" fmla="*/ 1494124 w 2734280"/>
+              <a:gd name="connsiteY4" fmla="*/ 2487342 h 3250146"/>
+              <a:gd name="connsiteX5" fmla="*/ 1765046 w 2734280"/>
+              <a:gd name="connsiteY5" fmla="*/ 3250146 h 3250146"/>
+              <a:gd name="connsiteX6" fmla="*/ 0 w 2734280"/>
+              <a:gd name="connsiteY6" fmla="*/ 3245793 h 3250146"/>
+              <a:gd name="connsiteX7" fmla="*/ 0 w 2734280"/>
+              <a:gd name="connsiteY7" fmla="*/ 0 h 3250146"/>
+              <a:gd name="connsiteX0" fmla="*/ 0 w 2734278"/>
+              <a:gd name="connsiteY0" fmla="*/ 0 h 3250146"/>
+              <a:gd name="connsiteX1" fmla="*/ 2734279 w 2734278"/>
+              <a:gd name="connsiteY1" fmla="*/ 0 h 3250146"/>
+              <a:gd name="connsiteX2" fmla="*/ 1897782 w 2734278"/>
+              <a:gd name="connsiteY2" fmla="*/ 1017778 h 3250146"/>
+              <a:gd name="connsiteX3" fmla="*/ 2521103 w 2734278"/>
+              <a:gd name="connsiteY3" fmla="*/ 1960450 h 3250146"/>
+              <a:gd name="connsiteX4" fmla="*/ 1494124 w 2734278"/>
+              <a:gd name="connsiteY4" fmla="*/ 2487342 h 3250146"/>
+              <a:gd name="connsiteX5" fmla="*/ 1765046 w 2734278"/>
+              <a:gd name="connsiteY5" fmla="*/ 3250146 h 3250146"/>
+              <a:gd name="connsiteX6" fmla="*/ 0 w 2734278"/>
+              <a:gd name="connsiteY6" fmla="*/ 3245793 h 3250146"/>
+              <a:gd name="connsiteX7" fmla="*/ 0 w 2734278"/>
+              <a:gd name="connsiteY7" fmla="*/ 0 h 3250146"/>
+              <a:gd name="connsiteX0" fmla="*/ 0 w 3147103"/>
+              <a:gd name="connsiteY0" fmla="*/ 1 h 3250147"/>
+              <a:gd name="connsiteX1" fmla="*/ 3147102 w 3147103"/>
+              <a:gd name="connsiteY1" fmla="*/ 0 h 3250147"/>
+              <a:gd name="connsiteX2" fmla="*/ 1897782 w 3147103"/>
+              <a:gd name="connsiteY2" fmla="*/ 1017779 h 3250147"/>
+              <a:gd name="connsiteX3" fmla="*/ 2521103 w 3147103"/>
+              <a:gd name="connsiteY3" fmla="*/ 1960451 h 3250147"/>
+              <a:gd name="connsiteX4" fmla="*/ 1494124 w 3147103"/>
+              <a:gd name="connsiteY4" fmla="*/ 2487343 h 3250147"/>
+              <a:gd name="connsiteX5" fmla="*/ 1765046 w 3147103"/>
+              <a:gd name="connsiteY5" fmla="*/ 3250147 h 3250147"/>
+              <a:gd name="connsiteX6" fmla="*/ 0 w 3147103"/>
+              <a:gd name="connsiteY6" fmla="*/ 3245794 h 3250147"/>
+              <a:gd name="connsiteX7" fmla="*/ 0 w 3147103"/>
+              <a:gd name="connsiteY7" fmla="*/ 1 h 3250147"/>
+            </a:gdLst>
+            <a:ahLst/>
+            <a:cxnLst>
+              <a:cxn ang="0">
+                <a:pos x="connsiteX0" y="connsiteY0"/>
+              </a:cxn>
+              <a:cxn ang="0">
+                <a:pos x="connsiteX1" y="connsiteY1"/>
+              </a:cxn>
+              <a:cxn ang="0">
+                <a:pos x="connsiteX2" y="connsiteY2"/>
+              </a:cxn>
+              <a:cxn ang="0">
+                <a:pos x="connsiteX3" y="connsiteY3"/>
+              </a:cxn>
+              <a:cxn ang="0">
+                <a:pos x="connsiteX4" y="connsiteY4"/>
+              </a:cxn>
+              <a:cxn ang="0">
+                <a:pos x="connsiteX5" y="connsiteY5"/>
+              </a:cxn>
+              <a:cxn ang="0">
+                <a:pos x="connsiteX6" y="connsiteY6"/>
+              </a:cxn>
+              <a:cxn ang="0">
+                <a:pos x="connsiteX7" y="connsiteY7"/>
+              </a:cxn>
+            </a:cxnLst>
+            <a:rect l="l" t="t" r="r" b="b"/>
+            <a:pathLst>
+              <a:path w="3147103" h="3250147">
+                <a:moveTo>
+                  <a:pt x="0" y="1"/>
+                </a:moveTo>
+                <a:lnTo>
+                  <a:pt x="3147102" y="0"/>
+                </a:lnTo>
+                <a:cubicBezTo>
+                  <a:pt x="3145130" y="268139"/>
+                  <a:pt x="1899754" y="749640"/>
+                  <a:pt x="1897782" y="1017779"/>
+                </a:cubicBezTo>
+                <a:cubicBezTo>
+                  <a:pt x="1830756" y="1427439"/>
+                  <a:pt x="2381687" y="1589115"/>
+                  <a:pt x="2521103" y="1960451"/>
+                </a:cubicBezTo>
+                <a:cubicBezTo>
+                  <a:pt x="2721763" y="2208101"/>
+                  <a:pt x="1620133" y="2272394"/>
+                  <a:pt x="1494124" y="2487343"/>
+                </a:cubicBezTo>
+                <a:cubicBezTo>
+                  <a:pt x="1368115" y="2702292"/>
+                  <a:pt x="2282003" y="3126461"/>
+                  <a:pt x="1765046" y="3250147"/>
+                </a:cubicBezTo>
+                <a:lnTo>
+                  <a:pt x="0" y="3245794"/>
+                </a:lnTo>
+                <a:lnTo>
+                  <a:pt x="0" y="1"/>
+                </a:lnTo>
+                <a:close/>
+              </a:path>
+            </a:pathLst>
+          </a:custGeom>
+          <a:solidFill>
+            <a:srgbClr val="003E79">
+              <a:alpha val="42000"/>
+            </a:srgbClr>
+          </a:solidFill>
+          <a:ln>
+            <a:noFill/>
+          </a:ln>
+          <a:effectLst>
+            <a:glow rad="50800">
+              <a:srgbClr val="381C38">
+                <a:alpha val="22000"/>
+              </a:srgbClr>
+            </a:glow>
+            <a:outerShdw blurRad="50800" dist="50800" dir="5400000" algn="ctr" rotWithShape="0">
+              <a:srgbClr val="000000">
+                <a:alpha val="14000"/>
+              </a:srgbClr>
+            </a:outerShdw>
+            <a:softEdge rad="0"/>
+          </a:effectLst>
+        </p:spPr>
+        <p:style>
+          <a:lnRef idx="2">
+            <a:schemeClr val="accent1">
+              <a:shade val="15000"/>
+            </a:schemeClr>
+          </a:lnRef>
+          <a:fillRef idx="1">
+            <a:schemeClr val="accent1"/>
+          </a:fillRef>
+          <a:effectRef idx="0">
+            <a:schemeClr val="accent1"/>
+          </a:effectRef>
+          <a:fontRef idx="minor">
+            <a:schemeClr val="lt1"/>
+          </a:fontRef>
+        </p:style>
+        <p:txBody>
+          <a:bodyPr rtlCol="0" anchor="ctr"/>
+          <a:lstStyle/>
+          <a:p>
+            <a:pPr algn="ctr"/>
+            <a:endParaRPr lang="en-US" noProof="1"/>
+          </a:p>
+        </p:txBody>
+      </p:sp>
+      <p:pic>
+        <p:nvPicPr>
+          <p:cNvPr id="1026" name="Picture 2">
+            <a:extLst>
+              <a:ext uri="{FF2B5EF4-FFF2-40B4-BE49-F238E27FC236}">
+                <a16:creationId xmlns:a16="http://schemas.microsoft.com/office/drawing/2014/main" id="{ECB41F3C-C026-22E9-AC42-0E4A597770EF}"/>
+              </a:ext>
+            </a:extLst>
+          </p:cNvPr>
+          <p:cNvPicPr>
+            <a:picLocks noChangeAspect="1" noChangeArrowheads="1"/>
+          </p:cNvPicPr>
+          <p:nvPr/>
+        </p:nvPicPr>
+        <p:blipFill>
+          <a:blip r:embed="rId4">
+            <a:extLst>
+              <a:ext uri="{28A0092B-C50C-407E-A947-70E740481C1C}">
+                <a14:useLocalDpi xmlns:a14="http://schemas.microsoft.com/office/drawing/2010/main" val="0"/>
+              </a:ext>
+            </a:extLst>
+          </a:blip>
+          <a:srcRect/>
+          <a:stretch>
+            <a:fillRect/>
+          </a:stretch>
+        </p:blipFill>
+        <p:spPr bwMode="auto">
+          <a:xfrm>
+            <a:off x="2348345" y="4404512"/>
+            <a:ext cx="7162800" cy="1276350"/>
+          </a:xfrm>
+          <a:prstGeom prst="rect">
+            <a:avLst/>
+          </a:prstGeom>
+          <a:noFill/>
+          <a:extLst>
+            <a:ext uri="{909E8E84-426E-40DD-AFC4-6F175D3DCCD1}">
+              <a14:hiddenFill xmlns:a14="http://schemas.microsoft.com/office/drawing/2010/main">
+                <a:solidFill>
+                  <a:srgbClr val="FFFFFF"/>
+                </a:solidFill>
+              </a14:hiddenFill>
+            </a:ext>
+          </a:extLst>
+        </p:spPr>
+      </p:pic>
+    </p:spTree>
+    <p:extLst>
+      <p:ext uri="{BB962C8B-B14F-4D97-AF65-F5344CB8AC3E}">
+        <p14:creationId xmlns:p14="http://schemas.microsoft.com/office/powerpoint/2010/main" val="373553578"/>
+      </p:ext>
+    </p:extLst>
+  </p:cSld>
+  <p:clrMapOvr>
+    <a:masterClrMapping/>
+  </p:clrMapOvr>
+</p:sld>
+</file>
+
+<file path=ppt/slides/slide8.xml><?xml version="1.0" encoding="utf-8"?>
+<p:sld xmlns:a="http://schemas.openxmlformats.org/drawingml/2006/main" xmlns:r="http://schemas.openxmlformats.org/officeDocument/2006/relationships" xmlns:p="http://schemas.openxmlformats.org/presentationml/2006/main">
+  <p:cSld>
+    <p:spTree>
+      <p:nvGrpSpPr>
+        <p:cNvPr id="1" name="">
+          <a:extLst>
+            <a:ext uri="{FF2B5EF4-FFF2-40B4-BE49-F238E27FC236}">
+              <a16:creationId xmlns:a16="http://schemas.microsoft.com/office/drawing/2014/main" id="{58E3B540-C694-2B40-EADE-37B8CC996204}"/>
+            </a:ext>
+          </a:extLst>
+        </p:cNvPr>
+        <p:cNvGrpSpPr/>
+        <p:nvPr/>
+      </p:nvGrpSpPr>
+      <p:grpSpPr>
+        <a:xfrm>
+          <a:off x="0" y="0"/>
+          <a:ext cx="0" cy="0"/>
+          <a:chOff x="0" y="0"/>
+          <a:chExt cx="0" cy="0"/>
+        </a:xfrm>
+      </p:grpSpPr>
+      <p:pic>
+        <p:nvPicPr>
+          <p:cNvPr id="7" name="Picture 6">
+            <a:extLst>
+              <a:ext uri="{FF2B5EF4-FFF2-40B4-BE49-F238E27FC236}">
+                <a16:creationId xmlns:a16="http://schemas.microsoft.com/office/drawing/2014/main" id="{7FCD7FF7-7E8E-AF1B-7728-E992B635B6B1}"/>
+              </a:ext>
+            </a:extLst>
+          </p:cNvPr>
+          <p:cNvPicPr>
+            <a:picLocks noChangeAspect="1"/>
+          </p:cNvPicPr>
+          <p:nvPr/>
+        </p:nvPicPr>
+        <p:blipFill>
+          <a:blip r:embed="rId2"/>
+          <a:stretch>
+            <a:fillRect/>
+          </a:stretch>
+        </p:blipFill>
+        <p:spPr>
+          <a:xfrm>
+            <a:off x="1662290" y="1009866"/>
+            <a:ext cx="8373644" cy="4725059"/>
+          </a:xfrm>
+          <a:prstGeom prst="rect">
+            <a:avLst/>
+          </a:prstGeom>
+        </p:spPr>
+      </p:pic>
+      <p:sp>
+        <p:nvSpPr>
+          <p:cNvPr id="10" name="Rectangle: Rounded Corners 9">
+            <a:extLst>
+              <a:ext uri="{FF2B5EF4-FFF2-40B4-BE49-F238E27FC236}">
+                <a16:creationId xmlns:a16="http://schemas.microsoft.com/office/drawing/2014/main" id="{A1AC2567-FFB3-C044-AB7F-4CE93BB01295}"/>
+              </a:ext>
+            </a:extLst>
+          </p:cNvPr>
+          <p:cNvSpPr/>
+          <p:nvPr/>
+        </p:nvSpPr>
+        <p:spPr>
+          <a:xfrm>
+            <a:off x="1431508" y="888242"/>
+            <a:ext cx="8996473" cy="5081516"/>
+          </a:xfrm>
+          <a:prstGeom prst="roundRect">
+            <a:avLst>
+              <a:gd name="adj" fmla="val 3570"/>
+            </a:avLst>
+          </a:prstGeom>
+          <a:blipFill dpi="0" rotWithShape="1">
+            <a:blip r:embed="rId3">
+              <a:alphaModFix amt="24000"/>
+            </a:blip>
+            <a:srcRect/>
+            <a:stretch>
+              <a:fillRect/>
+            </a:stretch>
+          </a:blipFill>
+          <a:ln>
+            <a:noFill/>
+          </a:ln>
+        </p:spPr>
+        <p:style>
+          <a:lnRef idx="2">
+            <a:schemeClr val="accent1">
+              <a:shade val="15000"/>
+            </a:schemeClr>
+          </a:lnRef>
+          <a:fillRef idx="1">
+            <a:schemeClr val="accent1"/>
+          </a:fillRef>
+          <a:effectRef idx="0">
+            <a:schemeClr val="accent1"/>
+          </a:effectRef>
+          <a:fontRef idx="minor">
+            <a:schemeClr val="lt1"/>
+          </a:fontRef>
+        </p:style>
+        <p:txBody>
+          <a:bodyPr rtlCol="0" anchor="ctr"/>
+          <a:lstStyle/>
+          <a:p>
+            <a:pPr algn="ctr"/>
+            <a:endParaRPr lang="en-US"/>
+          </a:p>
+        </p:txBody>
+      </p:sp>
+      <p:sp>
+        <p:nvSpPr>
+          <p:cNvPr id="8" name="Rectangle 122">
+            <a:extLst>
+              <a:ext uri="{FF2B5EF4-FFF2-40B4-BE49-F238E27FC236}">
+                <a16:creationId xmlns:a16="http://schemas.microsoft.com/office/drawing/2014/main" id="{3E33E2FD-2316-1DF0-77CC-F7A20998A56E}"/>
+              </a:ext>
+            </a:extLst>
+          </p:cNvPr>
+          <p:cNvSpPr/>
+          <p:nvPr/>
+        </p:nvSpPr>
+        <p:spPr>
+          <a:xfrm rot="16200000">
+            <a:off x="4589134" y="-204067"/>
+            <a:ext cx="2292639" cy="9542801"/>
+          </a:xfrm>
+          <a:custGeom>
+            <a:avLst/>
+            <a:gdLst>
+              <a:gd name="connsiteX0" fmla="*/ 0 w 2734279"/>
+              <a:gd name="connsiteY0" fmla="*/ 0 h 3245793"/>
+              <a:gd name="connsiteX1" fmla="*/ 2734279 w 2734279"/>
+              <a:gd name="connsiteY1" fmla="*/ 0 h 3245793"/>
+              <a:gd name="connsiteX2" fmla="*/ 2734279 w 2734279"/>
+              <a:gd name="connsiteY2" fmla="*/ 3245793 h 3245793"/>
+              <a:gd name="connsiteX3" fmla="*/ 0 w 2734279"/>
+              <a:gd name="connsiteY3" fmla="*/ 3245793 h 3245793"/>
+              <a:gd name="connsiteX4" fmla="*/ 0 w 2734279"/>
+              <a:gd name="connsiteY4" fmla="*/ 0 h 3245793"/>
+              <a:gd name="connsiteX0" fmla="*/ 0 w 2734279"/>
+              <a:gd name="connsiteY0" fmla="*/ 0 h 3245793"/>
+              <a:gd name="connsiteX1" fmla="*/ 2734279 w 2734279"/>
+              <a:gd name="connsiteY1" fmla="*/ 0 h 3245793"/>
+              <a:gd name="connsiteX2" fmla="*/ 1897782 w 2734279"/>
+              <a:gd name="connsiteY2" fmla="*/ 1017778 h 3245793"/>
+              <a:gd name="connsiteX3" fmla="*/ 2734279 w 2734279"/>
+              <a:gd name="connsiteY3" fmla="*/ 3245793 h 3245793"/>
+              <a:gd name="connsiteX4" fmla="*/ 0 w 2734279"/>
+              <a:gd name="connsiteY4" fmla="*/ 3245793 h 3245793"/>
+              <a:gd name="connsiteX5" fmla="*/ 0 w 2734279"/>
+              <a:gd name="connsiteY5" fmla="*/ 0 h 3245793"/>
+              <a:gd name="connsiteX0" fmla="*/ 0 w 2734279"/>
+              <a:gd name="connsiteY0" fmla="*/ 0 h 3245793"/>
+              <a:gd name="connsiteX1" fmla="*/ 2734279 w 2734279"/>
+              <a:gd name="connsiteY1" fmla="*/ 0 h 3245793"/>
+              <a:gd name="connsiteX2" fmla="*/ 1897782 w 2734279"/>
+              <a:gd name="connsiteY2" fmla="*/ 1017778 h 3245793"/>
+              <a:gd name="connsiteX3" fmla="*/ 2734279 w 2734279"/>
+              <a:gd name="connsiteY3" fmla="*/ 3245793 h 3245793"/>
+              <a:gd name="connsiteX4" fmla="*/ 0 w 2734279"/>
+              <a:gd name="connsiteY4" fmla="*/ 3245793 h 3245793"/>
+              <a:gd name="connsiteX5" fmla="*/ 0 w 2734279"/>
+              <a:gd name="connsiteY5" fmla="*/ 0 h 3245793"/>
+              <a:gd name="connsiteX0" fmla="*/ 0 w 3121495"/>
+              <a:gd name="connsiteY0" fmla="*/ 0 h 3245793"/>
+              <a:gd name="connsiteX1" fmla="*/ 2734279 w 3121495"/>
+              <a:gd name="connsiteY1" fmla="*/ 0 h 3245793"/>
+              <a:gd name="connsiteX2" fmla="*/ 1897782 w 3121495"/>
+              <a:gd name="connsiteY2" fmla="*/ 1017778 h 3245793"/>
+              <a:gd name="connsiteX3" fmla="*/ 3056022 w 3121495"/>
+              <a:gd name="connsiteY3" fmla="*/ 1764538 h 3245793"/>
+              <a:gd name="connsiteX4" fmla="*/ 2734279 w 3121495"/>
+              <a:gd name="connsiteY4" fmla="*/ 3245793 h 3245793"/>
+              <a:gd name="connsiteX5" fmla="*/ 0 w 3121495"/>
+              <a:gd name="connsiteY5" fmla="*/ 3245793 h 3245793"/>
+              <a:gd name="connsiteX6" fmla="*/ 0 w 3121495"/>
+              <a:gd name="connsiteY6" fmla="*/ 0 h 3245793"/>
+              <a:gd name="connsiteX0" fmla="*/ 0 w 3094349"/>
+              <a:gd name="connsiteY0" fmla="*/ 0 h 3245793"/>
+              <a:gd name="connsiteX1" fmla="*/ 2734279 w 3094349"/>
+              <a:gd name="connsiteY1" fmla="*/ 0 h 3245793"/>
+              <a:gd name="connsiteX2" fmla="*/ 1897782 w 3094349"/>
+              <a:gd name="connsiteY2" fmla="*/ 1017778 h 3245793"/>
+              <a:gd name="connsiteX3" fmla="*/ 3056022 w 3094349"/>
+              <a:gd name="connsiteY3" fmla="*/ 1764538 h 3245793"/>
+              <a:gd name="connsiteX4" fmla="*/ 2553102 w 3094349"/>
+              <a:gd name="connsiteY4" fmla="*/ 2465578 h 3245793"/>
+              <a:gd name="connsiteX5" fmla="*/ 2734279 w 3094349"/>
+              <a:gd name="connsiteY5" fmla="*/ 3245793 h 3245793"/>
+              <a:gd name="connsiteX6" fmla="*/ 0 w 3094349"/>
+              <a:gd name="connsiteY6" fmla="*/ 3245793 h 3245793"/>
+              <a:gd name="connsiteX7" fmla="*/ 0 w 3094349"/>
+              <a:gd name="connsiteY7" fmla="*/ 0 h 3245793"/>
+              <a:gd name="connsiteX0" fmla="*/ 0 w 2916671"/>
+              <a:gd name="connsiteY0" fmla="*/ 0 h 3245793"/>
+              <a:gd name="connsiteX1" fmla="*/ 2734279 w 2916671"/>
+              <a:gd name="connsiteY1" fmla="*/ 0 h 3245793"/>
+              <a:gd name="connsiteX2" fmla="*/ 1897782 w 2916671"/>
+              <a:gd name="connsiteY2" fmla="*/ 1017778 h 3245793"/>
+              <a:gd name="connsiteX3" fmla="*/ 2682642 w 2916671"/>
+              <a:gd name="connsiteY3" fmla="*/ 1855978 h 3245793"/>
+              <a:gd name="connsiteX4" fmla="*/ 2553102 w 2916671"/>
+              <a:gd name="connsiteY4" fmla="*/ 2465578 h 3245793"/>
+              <a:gd name="connsiteX5" fmla="*/ 2734279 w 2916671"/>
+              <a:gd name="connsiteY5" fmla="*/ 3245793 h 3245793"/>
+              <a:gd name="connsiteX6" fmla="*/ 0 w 2916671"/>
+              <a:gd name="connsiteY6" fmla="*/ 3245793 h 3245793"/>
+              <a:gd name="connsiteX7" fmla="*/ 0 w 2916671"/>
+              <a:gd name="connsiteY7" fmla="*/ 0 h 3245793"/>
+              <a:gd name="connsiteX0" fmla="*/ 0 w 3436755"/>
+              <a:gd name="connsiteY0" fmla="*/ 0 h 3254582"/>
+              <a:gd name="connsiteX1" fmla="*/ 2734279 w 3436755"/>
+              <a:gd name="connsiteY1" fmla="*/ 0 h 3254582"/>
+              <a:gd name="connsiteX2" fmla="*/ 1897782 w 3436755"/>
+              <a:gd name="connsiteY2" fmla="*/ 1017778 h 3254582"/>
+              <a:gd name="connsiteX3" fmla="*/ 2682642 w 3436755"/>
+              <a:gd name="connsiteY3" fmla="*/ 1855978 h 3254582"/>
+              <a:gd name="connsiteX4" fmla="*/ 2553102 w 3436755"/>
+              <a:gd name="connsiteY4" fmla="*/ 2465578 h 3254582"/>
+              <a:gd name="connsiteX5" fmla="*/ 3305105 w 3436755"/>
+              <a:gd name="connsiteY5" fmla="*/ 3254582 h 3254582"/>
+              <a:gd name="connsiteX6" fmla="*/ 0 w 3436755"/>
+              <a:gd name="connsiteY6" fmla="*/ 3245793 h 3254582"/>
+              <a:gd name="connsiteX7" fmla="*/ 0 w 3436755"/>
+              <a:gd name="connsiteY7" fmla="*/ 0 h 3254582"/>
+              <a:gd name="connsiteX0" fmla="*/ 0 w 3432826"/>
+              <a:gd name="connsiteY0" fmla="*/ 0 h 3254582"/>
+              <a:gd name="connsiteX1" fmla="*/ 2734279 w 3432826"/>
+              <a:gd name="connsiteY1" fmla="*/ 0 h 3254582"/>
+              <a:gd name="connsiteX2" fmla="*/ 1897782 w 3432826"/>
+              <a:gd name="connsiteY2" fmla="*/ 1017778 h 3254582"/>
+              <a:gd name="connsiteX3" fmla="*/ 2986272 w 3432826"/>
+              <a:gd name="connsiteY3" fmla="*/ 1803246 h 3254582"/>
+              <a:gd name="connsiteX4" fmla="*/ 2553102 w 3432826"/>
+              <a:gd name="connsiteY4" fmla="*/ 2465578 h 3254582"/>
+              <a:gd name="connsiteX5" fmla="*/ 3305105 w 3432826"/>
+              <a:gd name="connsiteY5" fmla="*/ 3254582 h 3254582"/>
+              <a:gd name="connsiteX6" fmla="*/ 0 w 3432826"/>
+              <a:gd name="connsiteY6" fmla="*/ 3245793 h 3254582"/>
+              <a:gd name="connsiteX7" fmla="*/ 0 w 3432826"/>
+              <a:gd name="connsiteY7" fmla="*/ 0 h 3254582"/>
+              <a:gd name="connsiteX0" fmla="*/ 0 w 3646164"/>
+              <a:gd name="connsiteY0" fmla="*/ 0 h 3275822"/>
+              <a:gd name="connsiteX1" fmla="*/ 2734279 w 3646164"/>
+              <a:gd name="connsiteY1" fmla="*/ 0 h 3275822"/>
+              <a:gd name="connsiteX2" fmla="*/ 1897782 w 3646164"/>
+              <a:gd name="connsiteY2" fmla="*/ 1017778 h 3275822"/>
+              <a:gd name="connsiteX3" fmla="*/ 2986272 w 3646164"/>
+              <a:gd name="connsiteY3" fmla="*/ 1803246 h 3275822"/>
+              <a:gd name="connsiteX4" fmla="*/ 2553102 w 3646164"/>
+              <a:gd name="connsiteY4" fmla="*/ 2465578 h 3275822"/>
+              <a:gd name="connsiteX5" fmla="*/ 3460548 w 3646164"/>
+              <a:gd name="connsiteY5" fmla="*/ 3205784 h 3275822"/>
+              <a:gd name="connsiteX6" fmla="*/ 3305105 w 3646164"/>
+              <a:gd name="connsiteY6" fmla="*/ 3254582 h 3275822"/>
+              <a:gd name="connsiteX7" fmla="*/ 0 w 3646164"/>
+              <a:gd name="connsiteY7" fmla="*/ 3245793 h 3275822"/>
+              <a:gd name="connsiteX8" fmla="*/ 0 w 3646164"/>
+              <a:gd name="connsiteY8" fmla="*/ 0 h 3275822"/>
+              <a:gd name="connsiteX0" fmla="*/ 0 w 3573838"/>
+              <a:gd name="connsiteY0" fmla="*/ 0 h 3290379"/>
+              <a:gd name="connsiteX1" fmla="*/ 2734279 w 3573838"/>
+              <a:gd name="connsiteY1" fmla="*/ 0 h 3290379"/>
+              <a:gd name="connsiteX2" fmla="*/ 1897782 w 3573838"/>
+              <a:gd name="connsiteY2" fmla="*/ 1017778 h 3290379"/>
+              <a:gd name="connsiteX3" fmla="*/ 2986272 w 3573838"/>
+              <a:gd name="connsiteY3" fmla="*/ 1803246 h 3290379"/>
+              <a:gd name="connsiteX4" fmla="*/ 2553102 w 3573838"/>
+              <a:gd name="connsiteY4" fmla="*/ 2465578 h 3290379"/>
+              <a:gd name="connsiteX5" fmla="*/ 3254080 w 3573838"/>
+              <a:gd name="connsiteY5" fmla="*/ 3227756 h 3290379"/>
+              <a:gd name="connsiteX6" fmla="*/ 3305105 w 3573838"/>
+              <a:gd name="connsiteY6" fmla="*/ 3254582 h 3290379"/>
+              <a:gd name="connsiteX7" fmla="*/ 0 w 3573838"/>
+              <a:gd name="connsiteY7" fmla="*/ 3245793 h 3290379"/>
+              <a:gd name="connsiteX8" fmla="*/ 0 w 3573838"/>
+              <a:gd name="connsiteY8" fmla="*/ 0 h 3290379"/>
+              <a:gd name="connsiteX0" fmla="*/ 0 w 3561349"/>
+              <a:gd name="connsiteY0" fmla="*/ 0 h 3260738"/>
+              <a:gd name="connsiteX1" fmla="*/ 2734279 w 3561349"/>
+              <a:gd name="connsiteY1" fmla="*/ 0 h 3260738"/>
+              <a:gd name="connsiteX2" fmla="*/ 1897782 w 3561349"/>
+              <a:gd name="connsiteY2" fmla="*/ 1017778 h 3260738"/>
+              <a:gd name="connsiteX3" fmla="*/ 2986272 w 3561349"/>
+              <a:gd name="connsiteY3" fmla="*/ 1803246 h 3260738"/>
+              <a:gd name="connsiteX4" fmla="*/ 2553102 w 3561349"/>
+              <a:gd name="connsiteY4" fmla="*/ 2465578 h 3260738"/>
+              <a:gd name="connsiteX5" fmla="*/ 2950449 w 3561349"/>
+              <a:gd name="connsiteY5" fmla="*/ 2854229 h 3260738"/>
+              <a:gd name="connsiteX6" fmla="*/ 3254080 w 3561349"/>
+              <a:gd name="connsiteY6" fmla="*/ 3227756 h 3260738"/>
+              <a:gd name="connsiteX7" fmla="*/ 3305105 w 3561349"/>
+              <a:gd name="connsiteY7" fmla="*/ 3254582 h 3260738"/>
+              <a:gd name="connsiteX8" fmla="*/ 0 w 3561349"/>
+              <a:gd name="connsiteY8" fmla="*/ 3245793 h 3260738"/>
+              <a:gd name="connsiteX9" fmla="*/ 0 w 3561349"/>
+              <a:gd name="connsiteY9" fmla="*/ 0 h 3260738"/>
+              <a:gd name="connsiteX0" fmla="*/ 0 w 3466950"/>
+              <a:gd name="connsiteY0" fmla="*/ 0 h 3263749"/>
+              <a:gd name="connsiteX1" fmla="*/ 2734279 w 3466950"/>
+              <a:gd name="connsiteY1" fmla="*/ 0 h 3263749"/>
+              <a:gd name="connsiteX2" fmla="*/ 1897782 w 3466950"/>
+              <a:gd name="connsiteY2" fmla="*/ 1017778 h 3263749"/>
+              <a:gd name="connsiteX3" fmla="*/ 2986272 w 3466950"/>
+              <a:gd name="connsiteY3" fmla="*/ 1803246 h 3263749"/>
+              <a:gd name="connsiteX4" fmla="*/ 2553102 w 3466950"/>
+              <a:gd name="connsiteY4" fmla="*/ 2465578 h 3263749"/>
+              <a:gd name="connsiteX5" fmla="*/ 2950449 w 3466950"/>
+              <a:gd name="connsiteY5" fmla="*/ 2854229 h 3263749"/>
+              <a:gd name="connsiteX6" fmla="*/ 3254080 w 3466950"/>
+              <a:gd name="connsiteY6" fmla="*/ 3227756 h 3263749"/>
+              <a:gd name="connsiteX7" fmla="*/ 3305105 w 3466950"/>
+              <a:gd name="connsiteY7" fmla="*/ 3254582 h 3263749"/>
+              <a:gd name="connsiteX8" fmla="*/ 1104378 w 3466950"/>
+              <a:gd name="connsiteY8" fmla="*/ 3254123 h 3263749"/>
+              <a:gd name="connsiteX9" fmla="*/ 0 w 3466950"/>
+              <a:gd name="connsiteY9" fmla="*/ 3245793 h 3263749"/>
+              <a:gd name="connsiteX10" fmla="*/ 0 w 3466950"/>
+              <a:gd name="connsiteY10" fmla="*/ 0 h 3263749"/>
+              <a:gd name="connsiteX0" fmla="*/ 0 w 3466950"/>
+              <a:gd name="connsiteY0" fmla="*/ 2172 h 3265921"/>
+              <a:gd name="connsiteX1" fmla="*/ 1043653 w 3466950"/>
+              <a:gd name="connsiteY1" fmla="*/ 0 h 3265921"/>
+              <a:gd name="connsiteX2" fmla="*/ 2734279 w 3466950"/>
+              <a:gd name="connsiteY2" fmla="*/ 2172 h 3265921"/>
+              <a:gd name="connsiteX3" fmla="*/ 1897782 w 3466950"/>
+              <a:gd name="connsiteY3" fmla="*/ 1019950 h 3265921"/>
+              <a:gd name="connsiteX4" fmla="*/ 2986272 w 3466950"/>
+              <a:gd name="connsiteY4" fmla="*/ 1805418 h 3265921"/>
+              <a:gd name="connsiteX5" fmla="*/ 2553102 w 3466950"/>
+              <a:gd name="connsiteY5" fmla="*/ 2467750 h 3265921"/>
+              <a:gd name="connsiteX6" fmla="*/ 2950449 w 3466950"/>
+              <a:gd name="connsiteY6" fmla="*/ 2856401 h 3265921"/>
+              <a:gd name="connsiteX7" fmla="*/ 3254080 w 3466950"/>
+              <a:gd name="connsiteY7" fmla="*/ 3229928 h 3265921"/>
+              <a:gd name="connsiteX8" fmla="*/ 3305105 w 3466950"/>
+              <a:gd name="connsiteY8" fmla="*/ 3256754 h 3265921"/>
+              <a:gd name="connsiteX9" fmla="*/ 1104378 w 3466950"/>
+              <a:gd name="connsiteY9" fmla="*/ 3256295 h 3265921"/>
+              <a:gd name="connsiteX10" fmla="*/ 0 w 3466950"/>
+              <a:gd name="connsiteY10" fmla="*/ 3247965 h 3265921"/>
+              <a:gd name="connsiteX11" fmla="*/ 0 w 3466950"/>
+              <a:gd name="connsiteY11" fmla="*/ 2172 h 3265921"/>
+              <a:gd name="connsiteX0" fmla="*/ 0 w 3466950"/>
+              <a:gd name="connsiteY0" fmla="*/ 3247965 h 3265921"/>
+              <a:gd name="connsiteX1" fmla="*/ 1043653 w 3466950"/>
+              <a:gd name="connsiteY1" fmla="*/ 0 h 3265921"/>
+              <a:gd name="connsiteX2" fmla="*/ 2734279 w 3466950"/>
+              <a:gd name="connsiteY2" fmla="*/ 2172 h 3265921"/>
+              <a:gd name="connsiteX3" fmla="*/ 1897782 w 3466950"/>
+              <a:gd name="connsiteY3" fmla="*/ 1019950 h 3265921"/>
+              <a:gd name="connsiteX4" fmla="*/ 2986272 w 3466950"/>
+              <a:gd name="connsiteY4" fmla="*/ 1805418 h 3265921"/>
+              <a:gd name="connsiteX5" fmla="*/ 2553102 w 3466950"/>
+              <a:gd name="connsiteY5" fmla="*/ 2467750 h 3265921"/>
+              <a:gd name="connsiteX6" fmla="*/ 2950449 w 3466950"/>
+              <a:gd name="connsiteY6" fmla="*/ 2856401 h 3265921"/>
+              <a:gd name="connsiteX7" fmla="*/ 3254080 w 3466950"/>
+              <a:gd name="connsiteY7" fmla="*/ 3229928 h 3265921"/>
+              <a:gd name="connsiteX8" fmla="*/ 3305105 w 3466950"/>
+              <a:gd name="connsiteY8" fmla="*/ 3256754 h 3265921"/>
+              <a:gd name="connsiteX9" fmla="*/ 1104378 w 3466950"/>
+              <a:gd name="connsiteY9" fmla="*/ 3256295 h 3265921"/>
+              <a:gd name="connsiteX10" fmla="*/ 0 w 3466950"/>
+              <a:gd name="connsiteY10" fmla="*/ 3247965 h 3265921"/>
+              <a:gd name="connsiteX0" fmla="*/ 60725 w 2423297"/>
+              <a:gd name="connsiteY0" fmla="*/ 3256295 h 3265921"/>
+              <a:gd name="connsiteX1" fmla="*/ 0 w 2423297"/>
+              <a:gd name="connsiteY1" fmla="*/ 0 h 3265921"/>
+              <a:gd name="connsiteX2" fmla="*/ 1690626 w 2423297"/>
+              <a:gd name="connsiteY2" fmla="*/ 2172 h 3265921"/>
+              <a:gd name="connsiteX3" fmla="*/ 854129 w 2423297"/>
+              <a:gd name="connsiteY3" fmla="*/ 1019950 h 3265921"/>
+              <a:gd name="connsiteX4" fmla="*/ 1942619 w 2423297"/>
+              <a:gd name="connsiteY4" fmla="*/ 1805418 h 3265921"/>
+              <a:gd name="connsiteX5" fmla="*/ 1509449 w 2423297"/>
+              <a:gd name="connsiteY5" fmla="*/ 2467750 h 3265921"/>
+              <a:gd name="connsiteX6" fmla="*/ 1906796 w 2423297"/>
+              <a:gd name="connsiteY6" fmla="*/ 2856401 h 3265921"/>
+              <a:gd name="connsiteX7" fmla="*/ 2210427 w 2423297"/>
+              <a:gd name="connsiteY7" fmla="*/ 3229928 h 3265921"/>
+              <a:gd name="connsiteX8" fmla="*/ 2261452 w 2423297"/>
+              <a:gd name="connsiteY8" fmla="*/ 3256754 h 3265921"/>
+              <a:gd name="connsiteX9" fmla="*/ 60725 w 2423297"/>
+              <a:gd name="connsiteY9" fmla="*/ 3256295 h 3265921"/>
+            </a:gdLst>
+            <a:ahLst/>
+            <a:cxnLst>
+              <a:cxn ang="0">
+                <a:pos x="connsiteX0" y="connsiteY0"/>
+              </a:cxn>
+              <a:cxn ang="0">
+                <a:pos x="connsiteX1" y="connsiteY1"/>
+              </a:cxn>
+              <a:cxn ang="0">
+                <a:pos x="connsiteX2" y="connsiteY2"/>
+              </a:cxn>
+              <a:cxn ang="0">
+                <a:pos x="connsiteX3" y="connsiteY3"/>
+              </a:cxn>
+              <a:cxn ang="0">
+                <a:pos x="connsiteX4" y="connsiteY4"/>
+              </a:cxn>
+              <a:cxn ang="0">
+                <a:pos x="connsiteX5" y="connsiteY5"/>
+              </a:cxn>
+              <a:cxn ang="0">
+                <a:pos x="connsiteX6" y="connsiteY6"/>
+              </a:cxn>
+              <a:cxn ang="0">
+                <a:pos x="connsiteX7" y="connsiteY7"/>
+              </a:cxn>
+              <a:cxn ang="0">
+                <a:pos x="connsiteX8" y="connsiteY8"/>
+              </a:cxn>
+              <a:cxn ang="0">
+                <a:pos x="connsiteX9" y="connsiteY9"/>
+              </a:cxn>
+            </a:cxnLst>
+            <a:rect l="l" t="t" r="r" b="b"/>
+            <a:pathLst>
+              <a:path w="2423297" h="3265921">
+                <a:moveTo>
+                  <a:pt x="60725" y="3256295"/>
+                </a:moveTo>
+                <a:lnTo>
+                  <a:pt x="0" y="0"/>
+                </a:lnTo>
+                <a:lnTo>
+                  <a:pt x="1690626" y="2172"/>
+                </a:lnTo>
+                <a:cubicBezTo>
+                  <a:pt x="1688654" y="270311"/>
+                  <a:pt x="856101" y="751811"/>
+                  <a:pt x="854129" y="1019950"/>
+                </a:cubicBezTo>
+                <a:cubicBezTo>
+                  <a:pt x="787103" y="1429610"/>
+                  <a:pt x="1803203" y="1434082"/>
+                  <a:pt x="1942619" y="1805418"/>
+                </a:cubicBezTo>
+                <a:cubicBezTo>
+                  <a:pt x="2143279" y="2053068"/>
+                  <a:pt x="1515419" y="2292586"/>
+                  <a:pt x="1509449" y="2467750"/>
+                </a:cubicBezTo>
+                <a:cubicBezTo>
+                  <a:pt x="1503479" y="2642914"/>
+                  <a:pt x="1789966" y="2729371"/>
+                  <a:pt x="1906796" y="2856401"/>
+                </a:cubicBezTo>
+                <a:cubicBezTo>
+                  <a:pt x="2023626" y="2983431"/>
+                  <a:pt x="2139172" y="3166132"/>
+                  <a:pt x="2210427" y="3229928"/>
+                </a:cubicBezTo>
+                <a:cubicBezTo>
+                  <a:pt x="2281682" y="3293724"/>
+                  <a:pt x="2619736" y="3252360"/>
+                  <a:pt x="2261452" y="3256754"/>
+                </a:cubicBezTo>
+                <a:lnTo>
+                  <a:pt x="60725" y="3256295"/>
+                </a:lnTo>
+                <a:close/>
+              </a:path>
+            </a:pathLst>
+          </a:custGeom>
+          <a:solidFill>
+            <a:srgbClr val="004483">
+              <a:alpha val="42000"/>
+            </a:srgbClr>
+          </a:solidFill>
+          <a:ln>
+            <a:solidFill>
+              <a:srgbClr val="003457"/>
+            </a:solidFill>
+          </a:ln>
+          <a:effectLst>
+            <a:glow rad="50800">
+              <a:srgbClr val="381C38">
+                <a:alpha val="22000"/>
+              </a:srgbClr>
+            </a:glow>
+            <a:outerShdw blurRad="50800" dist="50800" dir="5400000" algn="ctr" rotWithShape="0">
+              <a:srgbClr val="000000">
+                <a:alpha val="14000"/>
+              </a:srgbClr>
+            </a:outerShdw>
+            <a:softEdge rad="0"/>
+          </a:effectLst>
+        </p:spPr>
+        <p:style>
+          <a:lnRef idx="2">
+            <a:schemeClr val="accent1">
+              <a:shade val="15000"/>
+            </a:schemeClr>
+          </a:lnRef>
+          <a:fillRef idx="1">
+            <a:schemeClr val="accent1"/>
+          </a:fillRef>
+          <a:effectRef idx="0">
+            <a:schemeClr val="accent1"/>
+          </a:effectRef>
+          <a:fontRef idx="minor">
+            <a:schemeClr val="lt1"/>
+          </a:fontRef>
+        </p:style>
+        <p:txBody>
+          <a:bodyPr rtlCol="0" anchor="ctr"/>
+          <a:lstStyle/>
+          <a:p>
+            <a:pPr algn="ctr"/>
+            <a:endParaRPr lang="en-US" noProof="1"/>
+          </a:p>
+        </p:txBody>
+      </p:sp>
+      <p:sp>
+        <p:nvSpPr>
+          <p:cNvPr id="9" name="Rectangle 122">
+            <a:extLst>
+              <a:ext uri="{FF2B5EF4-FFF2-40B4-BE49-F238E27FC236}">
+                <a16:creationId xmlns:a16="http://schemas.microsoft.com/office/drawing/2014/main" id="{374A398A-CE74-F347-A872-BF3A14EB3FC9}"/>
+              </a:ext>
+            </a:extLst>
+          </p:cNvPr>
+          <p:cNvSpPr/>
+          <p:nvPr/>
+        </p:nvSpPr>
+        <p:spPr>
+          <a:xfrm rot="16200000" flipV="1">
+            <a:off x="4728790" y="-120058"/>
+            <a:ext cx="2014701" cy="9587139"/>
+          </a:xfrm>
+          <a:custGeom>
+            <a:avLst/>
+            <a:gdLst>
+              <a:gd name="connsiteX0" fmla="*/ 0 w 2734279"/>
+              <a:gd name="connsiteY0" fmla="*/ 0 h 3245793"/>
+              <a:gd name="connsiteX1" fmla="*/ 2734279 w 2734279"/>
+              <a:gd name="connsiteY1" fmla="*/ 0 h 3245793"/>
+              <a:gd name="connsiteX2" fmla="*/ 2734279 w 2734279"/>
+              <a:gd name="connsiteY2" fmla="*/ 3245793 h 3245793"/>
+              <a:gd name="connsiteX3" fmla="*/ 0 w 2734279"/>
+              <a:gd name="connsiteY3" fmla="*/ 3245793 h 3245793"/>
+              <a:gd name="connsiteX4" fmla="*/ 0 w 2734279"/>
+              <a:gd name="connsiteY4" fmla="*/ 0 h 3245793"/>
+              <a:gd name="connsiteX0" fmla="*/ 0 w 2734279"/>
+              <a:gd name="connsiteY0" fmla="*/ 0 h 3245793"/>
+              <a:gd name="connsiteX1" fmla="*/ 2734279 w 2734279"/>
+              <a:gd name="connsiteY1" fmla="*/ 0 h 3245793"/>
+              <a:gd name="connsiteX2" fmla="*/ 1897782 w 2734279"/>
+              <a:gd name="connsiteY2" fmla="*/ 1017778 h 3245793"/>
+              <a:gd name="connsiteX3" fmla="*/ 2734279 w 2734279"/>
+              <a:gd name="connsiteY3" fmla="*/ 3245793 h 3245793"/>
+              <a:gd name="connsiteX4" fmla="*/ 0 w 2734279"/>
+              <a:gd name="connsiteY4" fmla="*/ 3245793 h 3245793"/>
+              <a:gd name="connsiteX5" fmla="*/ 0 w 2734279"/>
+              <a:gd name="connsiteY5" fmla="*/ 0 h 3245793"/>
+              <a:gd name="connsiteX0" fmla="*/ 0 w 2734279"/>
+              <a:gd name="connsiteY0" fmla="*/ 0 h 3245793"/>
+              <a:gd name="connsiteX1" fmla="*/ 2734279 w 2734279"/>
+              <a:gd name="connsiteY1" fmla="*/ 0 h 3245793"/>
+              <a:gd name="connsiteX2" fmla="*/ 1897782 w 2734279"/>
+              <a:gd name="connsiteY2" fmla="*/ 1017778 h 3245793"/>
+              <a:gd name="connsiteX3" fmla="*/ 2734279 w 2734279"/>
+              <a:gd name="connsiteY3" fmla="*/ 3245793 h 3245793"/>
+              <a:gd name="connsiteX4" fmla="*/ 0 w 2734279"/>
+              <a:gd name="connsiteY4" fmla="*/ 3245793 h 3245793"/>
+              <a:gd name="connsiteX5" fmla="*/ 0 w 2734279"/>
+              <a:gd name="connsiteY5" fmla="*/ 0 h 3245793"/>
+              <a:gd name="connsiteX0" fmla="*/ 0 w 3121495"/>
+              <a:gd name="connsiteY0" fmla="*/ 0 h 3245793"/>
+              <a:gd name="connsiteX1" fmla="*/ 2734279 w 3121495"/>
+              <a:gd name="connsiteY1" fmla="*/ 0 h 3245793"/>
+              <a:gd name="connsiteX2" fmla="*/ 1897782 w 3121495"/>
+              <a:gd name="connsiteY2" fmla="*/ 1017778 h 3245793"/>
+              <a:gd name="connsiteX3" fmla="*/ 3056022 w 3121495"/>
+              <a:gd name="connsiteY3" fmla="*/ 1764538 h 3245793"/>
+              <a:gd name="connsiteX4" fmla="*/ 2734279 w 3121495"/>
+              <a:gd name="connsiteY4" fmla="*/ 3245793 h 3245793"/>
+              <a:gd name="connsiteX5" fmla="*/ 0 w 3121495"/>
+              <a:gd name="connsiteY5" fmla="*/ 3245793 h 3245793"/>
+              <a:gd name="connsiteX6" fmla="*/ 0 w 3121495"/>
+              <a:gd name="connsiteY6" fmla="*/ 0 h 3245793"/>
+              <a:gd name="connsiteX0" fmla="*/ 0 w 3094349"/>
+              <a:gd name="connsiteY0" fmla="*/ 0 h 3245793"/>
+              <a:gd name="connsiteX1" fmla="*/ 2734279 w 3094349"/>
+              <a:gd name="connsiteY1" fmla="*/ 0 h 3245793"/>
+              <a:gd name="connsiteX2" fmla="*/ 1897782 w 3094349"/>
+              <a:gd name="connsiteY2" fmla="*/ 1017778 h 3245793"/>
+              <a:gd name="connsiteX3" fmla="*/ 3056022 w 3094349"/>
+              <a:gd name="connsiteY3" fmla="*/ 1764538 h 3245793"/>
+              <a:gd name="connsiteX4" fmla="*/ 2553102 w 3094349"/>
+              <a:gd name="connsiteY4" fmla="*/ 2465578 h 3245793"/>
+              <a:gd name="connsiteX5" fmla="*/ 2734279 w 3094349"/>
+              <a:gd name="connsiteY5" fmla="*/ 3245793 h 3245793"/>
+              <a:gd name="connsiteX6" fmla="*/ 0 w 3094349"/>
+              <a:gd name="connsiteY6" fmla="*/ 3245793 h 3245793"/>
+              <a:gd name="connsiteX7" fmla="*/ 0 w 3094349"/>
+              <a:gd name="connsiteY7" fmla="*/ 0 h 3245793"/>
+              <a:gd name="connsiteX0" fmla="*/ 0 w 2916671"/>
+              <a:gd name="connsiteY0" fmla="*/ 0 h 3245793"/>
+              <a:gd name="connsiteX1" fmla="*/ 2734279 w 2916671"/>
+              <a:gd name="connsiteY1" fmla="*/ 0 h 3245793"/>
+              <a:gd name="connsiteX2" fmla="*/ 1897782 w 2916671"/>
+              <a:gd name="connsiteY2" fmla="*/ 1017778 h 3245793"/>
+              <a:gd name="connsiteX3" fmla="*/ 2682642 w 2916671"/>
+              <a:gd name="connsiteY3" fmla="*/ 1855978 h 3245793"/>
+              <a:gd name="connsiteX4" fmla="*/ 2553102 w 2916671"/>
+              <a:gd name="connsiteY4" fmla="*/ 2465578 h 3245793"/>
+              <a:gd name="connsiteX5" fmla="*/ 2734279 w 2916671"/>
+              <a:gd name="connsiteY5" fmla="*/ 3245793 h 3245793"/>
+              <a:gd name="connsiteX6" fmla="*/ 0 w 2916671"/>
+              <a:gd name="connsiteY6" fmla="*/ 3245793 h 3245793"/>
+              <a:gd name="connsiteX7" fmla="*/ 0 w 2916671"/>
+              <a:gd name="connsiteY7" fmla="*/ 0 h 3245793"/>
+              <a:gd name="connsiteX0" fmla="*/ 0 w 2772357"/>
+              <a:gd name="connsiteY0" fmla="*/ 0 h 3250146"/>
+              <a:gd name="connsiteX1" fmla="*/ 2734279 w 2772357"/>
+              <a:gd name="connsiteY1" fmla="*/ 0 h 3250146"/>
+              <a:gd name="connsiteX2" fmla="*/ 1897782 w 2772357"/>
+              <a:gd name="connsiteY2" fmla="*/ 1017778 h 3250146"/>
+              <a:gd name="connsiteX3" fmla="*/ 2682642 w 2772357"/>
+              <a:gd name="connsiteY3" fmla="*/ 1855978 h 3250146"/>
+              <a:gd name="connsiteX4" fmla="*/ 2553102 w 2772357"/>
+              <a:gd name="connsiteY4" fmla="*/ 2465578 h 3250146"/>
+              <a:gd name="connsiteX5" fmla="*/ 1765046 w 2772357"/>
+              <a:gd name="connsiteY5" fmla="*/ 3250146 h 3250146"/>
+              <a:gd name="connsiteX6" fmla="*/ 0 w 2772357"/>
+              <a:gd name="connsiteY6" fmla="*/ 3245793 h 3250146"/>
+              <a:gd name="connsiteX7" fmla="*/ 0 w 2772357"/>
+              <a:gd name="connsiteY7" fmla="*/ 0 h 3250146"/>
+              <a:gd name="connsiteX0" fmla="*/ 0 w 2734280"/>
+              <a:gd name="connsiteY0" fmla="*/ 0 h 3250146"/>
+              <a:gd name="connsiteX1" fmla="*/ 2734279 w 2734280"/>
+              <a:gd name="connsiteY1" fmla="*/ 0 h 3250146"/>
+              <a:gd name="connsiteX2" fmla="*/ 1897782 w 2734280"/>
+              <a:gd name="connsiteY2" fmla="*/ 1017778 h 3250146"/>
+              <a:gd name="connsiteX3" fmla="*/ 2682642 w 2734280"/>
+              <a:gd name="connsiteY3" fmla="*/ 1855978 h 3250146"/>
+              <a:gd name="connsiteX4" fmla="*/ 1494124 w 2734280"/>
+              <a:gd name="connsiteY4" fmla="*/ 2487342 h 3250146"/>
+              <a:gd name="connsiteX5" fmla="*/ 1765046 w 2734280"/>
+              <a:gd name="connsiteY5" fmla="*/ 3250146 h 3250146"/>
+              <a:gd name="connsiteX6" fmla="*/ 0 w 2734280"/>
+              <a:gd name="connsiteY6" fmla="*/ 3245793 h 3250146"/>
+              <a:gd name="connsiteX7" fmla="*/ 0 w 2734280"/>
+              <a:gd name="connsiteY7" fmla="*/ 0 h 3250146"/>
+              <a:gd name="connsiteX0" fmla="*/ 0 w 2734278"/>
+              <a:gd name="connsiteY0" fmla="*/ 0 h 3250146"/>
+              <a:gd name="connsiteX1" fmla="*/ 2734279 w 2734278"/>
+              <a:gd name="connsiteY1" fmla="*/ 0 h 3250146"/>
+              <a:gd name="connsiteX2" fmla="*/ 1897782 w 2734278"/>
+              <a:gd name="connsiteY2" fmla="*/ 1017778 h 3250146"/>
+              <a:gd name="connsiteX3" fmla="*/ 2521103 w 2734278"/>
+              <a:gd name="connsiteY3" fmla="*/ 1960450 h 3250146"/>
+              <a:gd name="connsiteX4" fmla="*/ 1494124 w 2734278"/>
+              <a:gd name="connsiteY4" fmla="*/ 2487342 h 3250146"/>
+              <a:gd name="connsiteX5" fmla="*/ 1765046 w 2734278"/>
+              <a:gd name="connsiteY5" fmla="*/ 3250146 h 3250146"/>
+              <a:gd name="connsiteX6" fmla="*/ 0 w 2734278"/>
+              <a:gd name="connsiteY6" fmla="*/ 3245793 h 3250146"/>
+              <a:gd name="connsiteX7" fmla="*/ 0 w 2734278"/>
+              <a:gd name="connsiteY7" fmla="*/ 0 h 3250146"/>
+              <a:gd name="connsiteX0" fmla="*/ 0 w 3147103"/>
+              <a:gd name="connsiteY0" fmla="*/ 1 h 3250147"/>
+              <a:gd name="connsiteX1" fmla="*/ 3147102 w 3147103"/>
+              <a:gd name="connsiteY1" fmla="*/ 0 h 3250147"/>
+              <a:gd name="connsiteX2" fmla="*/ 1897782 w 3147103"/>
+              <a:gd name="connsiteY2" fmla="*/ 1017779 h 3250147"/>
+              <a:gd name="connsiteX3" fmla="*/ 2521103 w 3147103"/>
+              <a:gd name="connsiteY3" fmla="*/ 1960451 h 3250147"/>
+              <a:gd name="connsiteX4" fmla="*/ 1494124 w 3147103"/>
+              <a:gd name="connsiteY4" fmla="*/ 2487343 h 3250147"/>
+              <a:gd name="connsiteX5" fmla="*/ 1765046 w 3147103"/>
+              <a:gd name="connsiteY5" fmla="*/ 3250147 h 3250147"/>
+              <a:gd name="connsiteX6" fmla="*/ 0 w 3147103"/>
+              <a:gd name="connsiteY6" fmla="*/ 3245794 h 3250147"/>
+              <a:gd name="connsiteX7" fmla="*/ 0 w 3147103"/>
+              <a:gd name="connsiteY7" fmla="*/ 1 h 3250147"/>
+            </a:gdLst>
+            <a:ahLst/>
+            <a:cxnLst>
+              <a:cxn ang="0">
+                <a:pos x="connsiteX0" y="connsiteY0"/>
+              </a:cxn>
+              <a:cxn ang="0">
+                <a:pos x="connsiteX1" y="connsiteY1"/>
+              </a:cxn>
+              <a:cxn ang="0">
+                <a:pos x="connsiteX2" y="connsiteY2"/>
+              </a:cxn>
+              <a:cxn ang="0">
+                <a:pos x="connsiteX3" y="connsiteY3"/>
+              </a:cxn>
+              <a:cxn ang="0">
+                <a:pos x="connsiteX4" y="connsiteY4"/>
+              </a:cxn>
+              <a:cxn ang="0">
+                <a:pos x="connsiteX5" y="connsiteY5"/>
+              </a:cxn>
+              <a:cxn ang="0">
+                <a:pos x="connsiteX6" y="connsiteY6"/>
+              </a:cxn>
+              <a:cxn ang="0">
+                <a:pos x="connsiteX7" y="connsiteY7"/>
+              </a:cxn>
+            </a:cxnLst>
+            <a:rect l="l" t="t" r="r" b="b"/>
+            <a:pathLst>
+              <a:path w="3147103" h="3250147">
+                <a:moveTo>
+                  <a:pt x="0" y="1"/>
+                </a:moveTo>
+                <a:lnTo>
+                  <a:pt x="3147102" y="0"/>
+                </a:lnTo>
+                <a:cubicBezTo>
+                  <a:pt x="3145130" y="268139"/>
+                  <a:pt x="1899754" y="749640"/>
+                  <a:pt x="1897782" y="1017779"/>
+                </a:cubicBezTo>
+                <a:cubicBezTo>
+                  <a:pt x="1830756" y="1427439"/>
+                  <a:pt x="2381687" y="1589115"/>
+                  <a:pt x="2521103" y="1960451"/>
+                </a:cubicBezTo>
+                <a:cubicBezTo>
+                  <a:pt x="2721763" y="2208101"/>
+                  <a:pt x="1620133" y="2272394"/>
+                  <a:pt x="1494124" y="2487343"/>
+                </a:cubicBezTo>
+                <a:cubicBezTo>
+                  <a:pt x="1368115" y="2702292"/>
+                  <a:pt x="2282003" y="3126461"/>
+                  <a:pt x="1765046" y="3250147"/>
+                </a:cubicBezTo>
+                <a:lnTo>
+                  <a:pt x="0" y="3245794"/>
+                </a:lnTo>
+                <a:lnTo>
+                  <a:pt x="0" y="1"/>
+                </a:lnTo>
+                <a:close/>
+              </a:path>
+            </a:pathLst>
+          </a:custGeom>
+          <a:solidFill>
+            <a:srgbClr val="003E79">
+              <a:alpha val="42000"/>
+            </a:srgbClr>
+          </a:solidFill>
+          <a:ln>
+            <a:noFill/>
+          </a:ln>
+          <a:effectLst>
+            <a:glow rad="50800">
+              <a:srgbClr val="381C38">
+                <a:alpha val="22000"/>
+              </a:srgbClr>
+            </a:glow>
+            <a:outerShdw blurRad="50800" dist="50800" dir="5400000" algn="ctr" rotWithShape="0">
+              <a:srgbClr val="000000">
+                <a:alpha val="14000"/>
+              </a:srgbClr>
+            </a:outerShdw>
+            <a:softEdge rad="0"/>
+          </a:effectLst>
+        </p:spPr>
+        <p:style>
+          <a:lnRef idx="2">
+            <a:schemeClr val="accent1">
+              <a:shade val="15000"/>
+            </a:schemeClr>
+          </a:lnRef>
+          <a:fillRef idx="1">
+            <a:schemeClr val="accent1"/>
+          </a:fillRef>
+          <a:effectRef idx="0">
+            <a:schemeClr val="accent1"/>
+          </a:effectRef>
+          <a:fontRef idx="minor">
+            <a:schemeClr val="lt1"/>
+          </a:fontRef>
+        </p:style>
+        <p:txBody>
+          <a:bodyPr rtlCol="0" anchor="ctr"/>
+          <a:lstStyle/>
+          <a:p>
+            <a:pPr algn="ctr"/>
+            <a:endParaRPr lang="en-US" noProof="1"/>
+          </a:p>
+        </p:txBody>
+      </p:sp>
+      <p:pic>
+        <p:nvPicPr>
+          <p:cNvPr id="1026" name="Picture 2">
+            <a:extLst>
+              <a:ext uri="{FF2B5EF4-FFF2-40B4-BE49-F238E27FC236}">
+                <a16:creationId xmlns:a16="http://schemas.microsoft.com/office/drawing/2014/main" id="{629FED5A-339D-9E23-D5E4-03DC999C752F}"/>
+              </a:ext>
+            </a:extLst>
+          </p:cNvPr>
+          <p:cNvPicPr>
+            <a:picLocks noChangeAspect="1" noChangeArrowheads="1"/>
+          </p:cNvPicPr>
+          <p:nvPr/>
+        </p:nvPicPr>
+        <p:blipFill>
+          <a:blip r:embed="rId4">
+            <a:extLst>
+              <a:ext uri="{28A0092B-C50C-407E-A947-70E740481C1C}">
+                <a14:useLocalDpi xmlns:a14="http://schemas.microsoft.com/office/drawing/2010/main" val="0"/>
+              </a:ext>
+            </a:extLst>
+          </a:blip>
+          <a:srcRect/>
+          <a:stretch>
+            <a:fillRect/>
+          </a:stretch>
+        </p:blipFill>
+        <p:spPr bwMode="auto">
+          <a:xfrm>
+            <a:off x="2348345" y="4404512"/>
+            <a:ext cx="7162800" cy="1276350"/>
+          </a:xfrm>
+          <a:prstGeom prst="rect">
+            <a:avLst/>
+          </a:prstGeom>
+          <a:noFill/>
+          <a:extLst>
+            <a:ext uri="{909E8E84-426E-40DD-AFC4-6F175D3DCCD1}">
+              <a14:hiddenFill xmlns:a14="http://schemas.microsoft.com/office/drawing/2010/main">
+                <a:solidFill>
+                  <a:srgbClr val="FFFFFF"/>
+                </a:solidFill>
+              </a14:hiddenFill>
+            </a:ext>
+          </a:extLst>
+        </p:spPr>
+      </p:pic>
+    </p:spTree>
+    <p:extLst>
+      <p:ext uri="{BB962C8B-B14F-4D97-AF65-F5344CB8AC3E}">
+        <p14:creationId xmlns:p14="http://schemas.microsoft.com/office/powerpoint/2010/main" val="367921499"/>
+      </p:ext>
+    </p:extLst>
+  </p:cSld>
+  <p:clrMapOvr>
+    <a:masterClrMapping/>
+  </p:clrMapOvr>
+</p:sld>
+</file>
+
 <file path=ppt/theme/theme1.xml><?xml version="1.0" encoding="utf-8"?>
 <a:theme xmlns:a="http://schemas.openxmlformats.org/drawingml/2006/main" name="Office Theme">
   <a:themeElements>
@@ -4225,4 +8032,319 @@
     </a:ext>
   </a:extLst>
 </a:theme>
+</file>
+
+<file path=ppt/theme/theme2.xml><?xml version="1.0" encoding="utf-8"?>
+<a:theme xmlns:a="http://schemas.openxmlformats.org/drawingml/2006/main" name="Office Theme">
+  <a:themeElements>
+    <a:clrScheme name="Office">
+      <a:dk1>
+        <a:sysClr val="windowText" lastClr="000000"/>
+      </a:dk1>
+      <a:lt1>
+        <a:sysClr val="window" lastClr="FFFFFF"/>
+      </a:lt1>
+      <a:dk2>
+        <a:srgbClr val="0E2841"/>
+      </a:dk2>
+      <a:lt2>
+        <a:srgbClr val="E8E8E8"/>
+      </a:lt2>
+      <a:accent1>
+        <a:srgbClr val="156082"/>
+      </a:accent1>
+      <a:accent2>
+        <a:srgbClr val="E97132"/>
+      </a:accent2>
+      <a:accent3>
+        <a:srgbClr val="196B24"/>
+      </a:accent3>
+      <a:accent4>
+        <a:srgbClr val="0F9ED5"/>
+      </a:accent4>
+      <a:accent5>
+        <a:srgbClr val="A02B93"/>
+      </a:accent5>
+      <a:accent6>
+        <a:srgbClr val="4EA72E"/>
+      </a:accent6>
+      <a:hlink>
+        <a:srgbClr val="467886"/>
+      </a:hlink>
+      <a:folHlink>
+        <a:srgbClr val="96607D"/>
+      </a:folHlink>
+    </a:clrScheme>
+    <a:fontScheme name="Office">
+      <a:majorFont>
+        <a:latin typeface="Aptos Display" panose="02110004020202020204"/>
+        <a:ea typeface=""/>
+        <a:cs typeface=""/>
+        <a:font script="Jpan" typeface="游ゴシック Light"/>
+        <a:font script="Hang" typeface="맑은 고딕"/>
+        <a:font script="Hans" typeface="等线 Light"/>
+        <a:font script="Hant" typeface="新細明體"/>
+        <a:font script="Arab" typeface="Times New Roman"/>
+        <a:font script="Hebr" typeface="Times New Roman"/>
+        <a:font script="Thai" typeface="Angsana New"/>
+        <a:font script="Ethi" typeface="Nyala"/>
+        <a:font script="Beng" typeface="Vrinda"/>
+        <a:font script="Gujr" typeface="Shruti"/>
+        <a:font script="Khmr" typeface="MoolBoran"/>
+        <a:font script="Knda" typeface="Tunga"/>
+        <a:font script="Guru" typeface="Raavi"/>
+        <a:font script="Cans" typeface="Euphemia"/>
+        <a:font script="Cher" typeface="Plantagenet Cherokee"/>
+        <a:font script="Yiii" typeface="Microsoft Yi Baiti"/>
+        <a:font script="Tibt" typeface="Microsoft Himalaya"/>
+        <a:font script="Thaa" typeface="MV Boli"/>
+        <a:font script="Deva" typeface="Mangal"/>
+        <a:font script="Telu" typeface="Gautami"/>
+        <a:font script="Taml" typeface="Latha"/>
+        <a:font script="Syrc" typeface="Estrangelo Edessa"/>
+        <a:font script="Orya" typeface="Kalinga"/>
+        <a:font script="Mlym" typeface="Kartika"/>
+        <a:font script="Laoo" typeface="DokChampa"/>
+        <a:font script="Sinh" typeface="Iskoola Pota"/>
+        <a:font script="Mong" typeface="Mongolian Baiti"/>
+        <a:font script="Viet" typeface="Times New Roman"/>
+        <a:font script="Uigh" typeface="Microsoft Uighur"/>
+        <a:font script="Geor" typeface="Sylfaen"/>
+        <a:font script="Armn" typeface="Arial"/>
+        <a:font script="Bugi" typeface="Leelawadee UI"/>
+        <a:font script="Bopo" typeface="Microsoft JhengHei"/>
+        <a:font script="Java" typeface="Javanese Text"/>
+        <a:font script="Lisu" typeface="Segoe UI"/>
+        <a:font script="Mymr" typeface="Myanmar Text"/>
+        <a:font script="Nkoo" typeface="Ebrima"/>
+        <a:font script="Olck" typeface="Nirmala UI"/>
+        <a:font script="Osma" typeface="Ebrima"/>
+        <a:font script="Phag" typeface="Phagspa"/>
+        <a:font script="Syrn" typeface="Estrangelo Edessa"/>
+        <a:font script="Syrj" typeface="Estrangelo Edessa"/>
+        <a:font script="Syre" typeface="Estrangelo Edessa"/>
+        <a:font script="Sora" typeface="Nirmala UI"/>
+        <a:font script="Tale" typeface="Microsoft Tai Le"/>
+        <a:font script="Talu" typeface="Microsoft New Tai Lue"/>
+        <a:font script="Tfng" typeface="Ebrima"/>
+      </a:majorFont>
+      <a:minorFont>
+        <a:latin typeface="Aptos" panose="02110004020202020204"/>
+        <a:ea typeface=""/>
+        <a:cs typeface=""/>
+        <a:font script="Jpan" typeface="游ゴシック"/>
+        <a:font script="Hang" typeface="맑은 고딕"/>
+        <a:font script="Hans" typeface="等线"/>
+        <a:font script="Hant" typeface="新細明體"/>
+        <a:font script="Arab" typeface="Arial"/>
+        <a:font script="Hebr" typeface="Arial"/>
+        <a:font script="Thai" typeface="Cordia New"/>
+        <a:font script="Ethi" typeface="Nyala"/>
+        <a:font script="Beng" typeface="Vrinda"/>
+        <a:font script="Gujr" typeface="Shruti"/>
+        <a:font script="Khmr" typeface="DaunPenh"/>
+        <a:font script="Knda" typeface="Tunga"/>
+        <a:font script="Guru" typeface="Raavi"/>
+        <a:font script="Cans" typeface="Euphemia"/>
+        <a:font script="Cher" typeface="Plantagenet Cherokee"/>
+        <a:font script="Yiii" typeface="Microsoft Yi Baiti"/>
+        <a:font script="Tibt" typeface="Microsoft Himalaya"/>
+        <a:font script="Thaa" typeface="MV Boli"/>
+        <a:font script="Deva" typeface="Mangal"/>
+        <a:font script="Telu" typeface="Gautami"/>
+        <a:font script="Taml" typeface="Latha"/>
+        <a:font script="Syrc" typeface="Estrangelo Edessa"/>
+        <a:font script="Orya" typeface="Kalinga"/>
+        <a:font script="Mlym" typeface="Kartika"/>
+        <a:font script="Laoo" typeface="DokChampa"/>
+        <a:font script="Sinh" typeface="Iskoola Pota"/>
+        <a:font script="Mong" typeface="Mongolian Baiti"/>
+        <a:font script="Viet" typeface="Arial"/>
+        <a:font script="Uigh" typeface="Microsoft Uighur"/>
+        <a:font script="Geor" typeface="Sylfaen"/>
+        <a:font script="Armn" typeface="Arial"/>
+        <a:font script="Bugi" typeface="Leelawadee UI"/>
+        <a:font script="Bopo" typeface="Microsoft JhengHei"/>
+        <a:font script="Java" typeface="Javanese Text"/>
+        <a:font script="Lisu" typeface="Segoe UI"/>
+        <a:font script="Mymr" typeface="Myanmar Text"/>
+        <a:font script="Nkoo" typeface="Ebrima"/>
+        <a:font script="Olck" typeface="Nirmala UI"/>
+        <a:font script="Osma" typeface="Ebrima"/>
+        <a:font script="Phag" typeface="Phagspa"/>
+        <a:font script="Syrn" typeface="Estrangelo Edessa"/>
+        <a:font script="Syrj" typeface="Estrangelo Edessa"/>
+        <a:font script="Syre" typeface="Estrangelo Edessa"/>
+        <a:font script="Sora" typeface="Nirmala UI"/>
+        <a:font script="Tale" typeface="Microsoft Tai Le"/>
+        <a:font script="Talu" typeface="Microsoft New Tai Lue"/>
+        <a:font script="Tfng" typeface="Ebrima"/>
+      </a:minorFont>
+    </a:fontScheme>
+    <a:fmtScheme name="Office">
+      <a:fillStyleLst>
+        <a:solidFill>
+          <a:schemeClr val="phClr"/>
+        </a:solidFill>
+        <a:gradFill rotWithShape="1">
+          <a:gsLst>
+            <a:gs pos="0">
+              <a:schemeClr val="phClr">
+                <a:lumMod val="110000"/>
+                <a:satMod val="105000"/>
+                <a:tint val="67000"/>
+              </a:schemeClr>
+            </a:gs>
+            <a:gs pos="50000">
+              <a:schemeClr val="phClr">
+                <a:lumMod val="105000"/>
+                <a:satMod val="103000"/>
+                <a:tint val="73000"/>
+              </a:schemeClr>
+            </a:gs>
+            <a:gs pos="100000">
+              <a:schemeClr val="phClr">
+                <a:lumMod val="105000"/>
+                <a:satMod val="109000"/>
+                <a:tint val="81000"/>
+              </a:schemeClr>
+            </a:gs>
+          </a:gsLst>
+          <a:lin ang="5400000" scaled="0"/>
+        </a:gradFill>
+        <a:gradFill rotWithShape="1">
+          <a:gsLst>
+            <a:gs pos="0">
+              <a:schemeClr val="phClr">
+                <a:satMod val="103000"/>
+                <a:lumMod val="102000"/>
+                <a:tint val="94000"/>
+              </a:schemeClr>
+            </a:gs>
+            <a:gs pos="50000">
+              <a:schemeClr val="phClr">
+                <a:satMod val="110000"/>
+                <a:lumMod val="100000"/>
+                <a:shade val="100000"/>
+              </a:schemeClr>
+            </a:gs>
+            <a:gs pos="100000">
+              <a:schemeClr val="phClr">
+                <a:lumMod val="99000"/>
+                <a:satMod val="120000"/>
+                <a:shade val="78000"/>
+              </a:schemeClr>
+            </a:gs>
+          </a:gsLst>
+          <a:lin ang="5400000" scaled="0"/>
+        </a:gradFill>
+      </a:fillStyleLst>
+      <a:lnStyleLst>
+        <a:ln w="12700" cap="flat" cmpd="sng" algn="ctr">
+          <a:solidFill>
+            <a:schemeClr val="phClr"/>
+          </a:solidFill>
+          <a:prstDash val="solid"/>
+          <a:miter lim="800000"/>
+        </a:ln>
+        <a:ln w="19050" cap="flat" cmpd="sng" algn="ctr">
+          <a:solidFill>
+            <a:schemeClr val="phClr"/>
+          </a:solidFill>
+          <a:prstDash val="solid"/>
+          <a:miter lim="800000"/>
+        </a:ln>
+        <a:ln w="25400" cap="flat" cmpd="sng" algn="ctr">
+          <a:solidFill>
+            <a:schemeClr val="phClr"/>
+          </a:solidFill>
+          <a:prstDash val="solid"/>
+          <a:miter lim="800000"/>
+        </a:ln>
+      </a:lnStyleLst>
+      <a:effectStyleLst>
+        <a:effectStyle>
+          <a:effectLst/>
+        </a:effectStyle>
+        <a:effectStyle>
+          <a:effectLst/>
+        </a:effectStyle>
+        <a:effectStyle>
+          <a:effectLst>
+            <a:outerShdw blurRad="57150" dist="19050" dir="5400000" algn="ctr" rotWithShape="0">
+              <a:srgbClr val="000000">
+                <a:alpha val="63000"/>
+              </a:srgbClr>
+            </a:outerShdw>
+          </a:effectLst>
+        </a:effectStyle>
+      </a:effectStyleLst>
+      <a:bgFillStyleLst>
+        <a:solidFill>
+          <a:schemeClr val="phClr"/>
+        </a:solidFill>
+        <a:solidFill>
+          <a:schemeClr val="phClr">
+            <a:tint val="95000"/>
+            <a:satMod val="170000"/>
+          </a:schemeClr>
+        </a:solidFill>
+        <a:gradFill rotWithShape="1">
+          <a:gsLst>
+            <a:gs pos="0">
+              <a:schemeClr val="phClr">
+                <a:tint val="93000"/>
+                <a:satMod val="150000"/>
+                <a:shade val="98000"/>
+                <a:lumMod val="102000"/>
+              </a:schemeClr>
+            </a:gs>
+            <a:gs pos="50000">
+              <a:schemeClr val="phClr">
+                <a:tint val="98000"/>
+                <a:satMod val="130000"/>
+                <a:shade val="90000"/>
+                <a:lumMod val="103000"/>
+              </a:schemeClr>
+            </a:gs>
+            <a:gs pos="100000">
+              <a:schemeClr val="phClr">
+                <a:shade val="63000"/>
+                <a:satMod val="120000"/>
+              </a:schemeClr>
+            </a:gs>
+          </a:gsLst>
+          <a:lin ang="5400000" scaled="0"/>
+        </a:gradFill>
+      </a:bgFillStyleLst>
+    </a:fmtScheme>
+  </a:themeElements>
+  <a:objectDefaults>
+    <a:lnDef>
+      <a:spPr/>
+      <a:bodyPr/>
+      <a:lstStyle/>
+      <a:style>
+        <a:lnRef idx="2">
+          <a:schemeClr val="accent1"/>
+        </a:lnRef>
+        <a:fillRef idx="0">
+          <a:schemeClr val="accent1"/>
+        </a:fillRef>
+        <a:effectRef idx="1">
+          <a:schemeClr val="accent1"/>
+        </a:effectRef>
+        <a:fontRef idx="minor">
+          <a:schemeClr val="tx1"/>
+        </a:fontRef>
+      </a:style>
+    </a:lnDef>
+  </a:objectDefaults>
+  <a:extraClrSchemeLst/>
+  <a:extLst>
+    <a:ext uri="{05A4C25C-085E-4340-85A3-A5531E510DB2}">
+      <thm15:themeFamily xmlns:thm15="http://schemas.microsoft.com/office/thememl/2012/main" name="Office Theme" id="{2E142A2C-CD16-42D6-873A-C26D2A0506FA}" vid="{1BDDFF52-6CD6-40A5-AB3C-68EB2F1E4D0A}"/>
+    </a:ext>
+  </a:extLst>
+</a:theme>
 </file>
</xml_diff>